<commit_message>
Drop the "covers:" line from per-line code slides
The line now shows just the code and its explanation.

Co-Authored-By: Claude Opus 5 <noreply@anthropic.com>
</commit_message>
<xml_diff>
--- a/ai101/slides/week-01.pptx
+++ b/ai101/slides/week-01.pptx
@@ -3483,21 +3483,6 @@
               <a:t>A small paragraph under the title. class="tag" lets CSS make it grey and small.</a:t>
             </a:r>
           </a:p>
-          <a:p>
-            <a:pPr>
-              <a:spcBef>
-                <a:spcPts val="1800"/>
-              </a:spcBef>
-            </a:pPr>
-            <a:r>
-              <a:rPr sz="1500">
-                <a:solidFill>
-                  <a:srgbClr val="6D8C97"/>
-                </a:solidFill>
-              </a:rPr>
-              <a:t>covers: The &lt;p&gt; tag</a:t>
-            </a:r>
-          </a:p>
         </p:txBody>
       </p:sp>
     </p:spTree>
@@ -3880,21 +3865,6 @@
               <a:t>An empty &lt;div&gt; with id="chat". Empty for now - your messages will fill it later.</a:t>
             </a:r>
           </a:p>
-          <a:p>
-            <a:pPr>
-              <a:spcBef>
-                <a:spcPts val="1800"/>
-              </a:spcBef>
-            </a:pPr>
-            <a:r>
-              <a:rPr sz="1500">
-                <a:solidFill>
-                  <a:srgbClr val="6D8C97"/>
-                </a:solidFill>
-              </a:rPr>
-              <a:t>covers: The &lt;div&gt; tag</a:t>
-            </a:r>
-          </a:p>
         </p:txBody>
       </p:sp>
     </p:spTree>
@@ -4151,21 +4121,6 @@
               <a:t>Opens a &lt;form&gt; with id="composer": the text box and Send button belong together.</a:t>
             </a:r>
           </a:p>
-          <a:p>
-            <a:pPr>
-              <a:spcBef>
-                <a:spcPts val="1800"/>
-              </a:spcBef>
-            </a:pPr>
-            <a:r>
-              <a:rPr sz="1500">
-                <a:solidFill>
-                  <a:srgbClr val="6D8C97"/>
-                </a:solidFill>
-              </a:rPr>
-              <a:t>covers: The &lt;form&gt; tag</a:t>
-            </a:r>
-          </a:p>
         </p:txBody>
       </p:sp>
     </p:spTree>
@@ -4422,21 +4377,6 @@
               <a:t>The &lt;input&gt; the student types in. placeholder is the faint hint; autocomplete off hides suggestions.</a:t>
             </a:r>
           </a:p>
-          <a:p>
-            <a:pPr>
-              <a:spcBef>
-                <a:spcPts val="1800"/>
-              </a:spcBef>
-            </a:pPr>
-            <a:r>
-              <a:rPr sz="1500">
-                <a:solidFill>
-                  <a:srgbClr val="6D8C97"/>
-                </a:solidFill>
-              </a:rPr>
-              <a:t>covers: The &lt;input&gt; tag</a:t>
-            </a:r>
-          </a:p>
         </p:txBody>
       </p:sp>
     </p:spTree>
@@ -4835,21 +4775,6 @@
               <a:t>The Send &lt;button&gt;. type="submit" means clicking it (or pressing Enter) sends the form.</a:t>
             </a:r>
           </a:p>
-          <a:p>
-            <a:pPr>
-              <a:spcBef>
-                <a:spcPts val="1800"/>
-              </a:spcBef>
-            </a:pPr>
-            <a:r>
-              <a:rPr sz="1500">
-                <a:solidFill>
-                  <a:srgbClr val="6D8C97"/>
-                </a:solidFill>
-              </a:rPr>
-              <a:t>covers: The &lt;button&gt; tag</a:t>
-            </a:r>
-          </a:p>
         </p:txBody>
       </p:sp>
     </p:spTree>
@@ -5500,21 +5425,6 @@
               <a:t>Loads style.css so the page uses your styles. rel says it is a stylesheet; href is the filename.</a:t>
             </a:r>
           </a:p>
-          <a:p>
-            <a:pPr>
-              <a:spcBef>
-                <a:spcPts val="1800"/>
-              </a:spcBef>
-            </a:pPr>
-            <a:r>
-              <a:rPr sz="1500">
-                <a:solidFill>
-                  <a:srgbClr val="6D8C97"/>
-                </a:solidFill>
-              </a:rPr>
-              <a:t>covers: The &lt;link&gt; tag</a:t>
-            </a:r>
-          </a:p>
         </p:txBody>
       </p:sp>
     </p:spTree>
@@ -5883,21 +5793,6 @@
               <a:t>Starts a rule for &lt;body&gt;, the whole page. Everything between { and } styles it.</a:t>
             </a:r>
           </a:p>
-          <a:p>
-            <a:pPr>
-              <a:spcBef>
-                <a:spcPts val="1800"/>
-              </a:spcBef>
-            </a:pPr>
-            <a:r>
-              <a:rPr sz="1500">
-                <a:solidFill>
-                  <a:srgbClr val="6D8C97"/>
-                </a:solidFill>
-              </a:rPr>
-              <a:t>covers: A CSS rule</a:t>
-            </a:r>
-          </a:p>
         </p:txBody>
       </p:sp>
     </p:spTree>
@@ -6281,21 +6176,6 @@
               <a:t>Removes the browser's default margin so nothing is pushed off the edge.</a:t>
             </a:r>
           </a:p>
-          <a:p>
-            <a:pPr>
-              <a:spcBef>
-                <a:spcPts val="1800"/>
-              </a:spcBef>
-            </a:pPr>
-            <a:r>
-              <a:rPr sz="1500">
-                <a:solidFill>
-                  <a:srgbClr val="6D8C97"/>
-                </a:solidFill>
-              </a:rPr>
-              <a:t>covers: margin</a:t>
-            </a:r>
-          </a:p>
         </p:txBody>
       </p:sp>
     </p:spTree>
@@ -6552,21 +6432,6 @@
               <a:t>Sets the font. The browser uses the first one it has.</a:t>
             </a:r>
           </a:p>
-          <a:p>
-            <a:pPr>
-              <a:spcBef>
-                <a:spcPts val="1800"/>
-              </a:spcBef>
-            </a:pPr>
-            <a:r>
-              <a:rPr sz="1500">
-                <a:solidFill>
-                  <a:srgbClr val="6D8C97"/>
-                </a:solidFill>
-              </a:rPr>
-              <a:t>covers: font-family</a:t>
-            </a:r>
-          </a:p>
         </p:txBody>
       </p:sp>
     </p:spTree>
@@ -6808,21 +6673,6 @@
               <a:t>The page's background colour, a soft blue-grey.</a:t>
             </a:r>
           </a:p>
-          <a:p>
-            <a:pPr>
-              <a:spcBef>
-                <a:spcPts val="1800"/>
-              </a:spcBef>
-            </a:pPr>
-            <a:r>
-              <a:rPr sz="1500">
-                <a:solidFill>
-                  <a:srgbClr val="6D8C97"/>
-                </a:solidFill>
-              </a:rPr>
-              <a:t>covers: background</a:t>
-            </a:r>
-          </a:p>
         </p:txBody>
       </p:sp>
     </p:spTree>
@@ -7064,21 +6914,6 @@
               <a:t>The default text colour, a dark near-black.</a:t>
             </a:r>
           </a:p>
-          <a:p>
-            <a:pPr>
-              <a:spcBef>
-                <a:spcPts val="1800"/>
-              </a:spcBef>
-            </a:pPr>
-            <a:r>
-              <a:rPr sz="1500">
-                <a:solidFill>
-                  <a:srgbClr val="6D8C97"/>
-                </a:solidFill>
-              </a:rPr>
-              <a:t>covers: color</a:t>
-            </a:r>
-          </a:p>
         </p:txBody>
       </p:sp>
     </p:spTree>
@@ -7331,21 +7166,6 @@
               <a:t>Starts a rule for .app - the &lt;main&gt; box we labelled earlier.</a:t>
             </a:r>
           </a:p>
-          <a:p>
-            <a:pPr>
-              <a:spcBef>
-                <a:spcPts val="1800"/>
-              </a:spcBef>
-            </a:pPr>
-            <a:r>
-              <a:rPr sz="1500">
-                <a:solidFill>
-                  <a:srgbClr val="6D8C97"/>
-                </a:solidFill>
-              </a:rPr>
-              <a:t>covers: A CSS rule</a:t>
-            </a:r>
-          </a:p>
         </p:txBody>
       </p:sp>
     </p:spTree>
@@ -7732,21 +7552,6 @@
               <a:t>It never grows wider than 620px, so lines stay easy to read.</a:t>
             </a:r>
           </a:p>
-          <a:p>
-            <a:pPr>
-              <a:spcBef>
-                <a:spcPts val="1800"/>
-              </a:spcBef>
-            </a:pPr>
-            <a:r>
-              <a:rPr sz="1500">
-                <a:solidFill>
-                  <a:srgbClr val="6D8C97"/>
-                </a:solidFill>
-              </a:rPr>
-              <a:t>covers: max-width</a:t>
-            </a:r>
-          </a:p>
         </p:txBody>
       </p:sp>
     </p:spTree>
@@ -7873,21 +7678,6 @@
               <a:t>margin: 0 auto centres it: no top/bottom margin, equal left/right.</a:t>
             </a:r>
           </a:p>
-          <a:p>
-            <a:pPr>
-              <a:spcBef>
-                <a:spcPts val="1800"/>
-              </a:spcBef>
-            </a:pPr>
-            <a:r>
-              <a:rPr sz="1500">
-                <a:solidFill>
-                  <a:srgbClr val="6D8C97"/>
-                </a:solidFill>
-              </a:rPr>
-              <a:t>covers: margin</a:t>
-            </a:r>
-          </a:p>
         </p:txBody>
       </p:sp>
     </p:spTree>
@@ -8129,21 +7919,6 @@
               <a:t>Space inside the box so text is not jammed against the edge.</a:t>
             </a:r>
           </a:p>
-          <a:p>
-            <a:pPr>
-              <a:spcBef>
-                <a:spcPts val="1800"/>
-              </a:spcBef>
-            </a:pPr>
-            <a:r>
-              <a:rPr sz="1500">
-                <a:solidFill>
-                  <a:srgbClr val="6D8C97"/>
-                </a:solidFill>
-              </a:rPr>
-              <a:t>covers: padding</a:t>
-            </a:r>
-          </a:p>
         </p:txBody>
       </p:sp>
     </p:spTree>
@@ -8511,21 +8286,6 @@
               <a:t>Styles the &lt;h1&gt; inside .top: no margin except a little below, and a 26px size. (A one-line rule.)</a:t>
             </a:r>
           </a:p>
-          <a:p>
-            <a:pPr>
-              <a:spcBef>
-                <a:spcPts val="1800"/>
-              </a:spcBef>
-            </a:pPr>
-            <a:r>
-              <a:rPr sz="1500">
-                <a:solidFill>
-                  <a:srgbClr val="6D8C97"/>
-                </a:solidFill>
-              </a:rPr>
-              <a:t>covers: margin, font-size</a:t>
-            </a:r>
-          </a:p>
         </p:txBody>
       </p:sp>
     </p:spTree>
@@ -8652,21 +8412,6 @@
               <a:t>Styles the .tag paragraph: spaced below, grey, and small.</a:t>
             </a:r>
           </a:p>
-          <a:p>
-            <a:pPr>
-              <a:spcBef>
-                <a:spcPts val="1800"/>
-              </a:spcBef>
-            </a:pPr>
-            <a:r>
-              <a:rPr sz="1500">
-                <a:solidFill>
-                  <a:srgbClr val="6D8C97"/>
-                </a:solidFill>
-              </a:rPr>
-              <a:t>covers: margin, color, font-size</a:t>
-            </a:r>
-          </a:p>
         </p:txBody>
       </p:sp>
     </p:spTree>
@@ -8793,21 +8538,6 @@
               <a:t>Starts a rule for the .chat box.</a:t>
             </a:r>
           </a:p>
-          <a:p>
-            <a:pPr>
-              <a:spcBef>
-                <a:spcPts val="1800"/>
-              </a:spcBef>
-            </a:pPr>
-            <a:r>
-              <a:rPr sz="1500">
-                <a:solidFill>
-                  <a:srgbClr val="6D8C97"/>
-                </a:solidFill>
-              </a:rPr>
-              <a:t>covers: A CSS rule</a:t>
-            </a:r>
-          </a:p>
         </p:txBody>
       </p:sp>
     </p:spTree>
@@ -9049,21 +8779,6 @@
               <a:t>Opens &lt;main&gt;, the box that holds everything. class="app" is a label CSS can target.</a:t>
             </a:r>
           </a:p>
-          <a:p>
-            <a:pPr>
-              <a:spcBef>
-                <a:spcPts val="1800"/>
-              </a:spcBef>
-            </a:pPr>
-            <a:r>
-              <a:rPr sz="1500">
-                <a:solidFill>
-                  <a:srgbClr val="6D8C97"/>
-                </a:solidFill>
-              </a:rPr>
-              <a:t>covers: The &lt;main&gt; tag</a:t>
-            </a:r>
-          </a:p>
         </p:txBody>
       </p:sp>
     </p:spTree>
@@ -9190,21 +8905,6 @@
               <a:t>Keeps it at least 260px tall so it reads as a chat area even when empty.</a:t>
             </a:r>
           </a:p>
-          <a:p>
-            <a:pPr>
-              <a:spcBef>
-                <a:spcPts val="1800"/>
-              </a:spcBef>
-            </a:pPr>
-            <a:r>
-              <a:rPr sz="1500">
-                <a:solidFill>
-                  <a:srgbClr val="6D8C97"/>
-                </a:solidFill>
-              </a:rPr>
-              <a:t>covers: min-height</a:t>
-            </a:r>
-          </a:p>
         </p:txBody>
       </p:sp>
     </p:spTree>
@@ -9331,21 +9031,6 @@
               <a:t>Space inside the chat box.</a:t>
             </a:r>
           </a:p>
-          <a:p>
-            <a:pPr>
-              <a:spcBef>
-                <a:spcPts val="1800"/>
-              </a:spcBef>
-            </a:pPr>
-            <a:r>
-              <a:rPr sz="1500">
-                <a:solidFill>
-                  <a:srgbClr val="6D8C97"/>
-                </a:solidFill>
-              </a:rPr>
-              <a:t>covers: padding</a:t>
-            </a:r>
-          </a:p>
         </p:txBody>
       </p:sp>
     </p:spTree>
@@ -9472,21 +9157,6 @@
               <a:t>A white background so messages stand out from the page.</a:t>
             </a:r>
           </a:p>
-          <a:p>
-            <a:pPr>
-              <a:spcBef>
-                <a:spcPts val="1800"/>
-              </a:spcBef>
-            </a:pPr>
-            <a:r>
-              <a:rPr sz="1500">
-                <a:solidFill>
-                  <a:srgbClr val="6D8C97"/>
-                </a:solidFill>
-              </a:rPr>
-              <a:t>covers: background</a:t>
-            </a:r>
-          </a:p>
         </p:txBody>
       </p:sp>
     </p:spTree>
@@ -9728,21 +9398,6 @@
               <a:t>A thin grey line around it.</a:t>
             </a:r>
           </a:p>
-          <a:p>
-            <a:pPr>
-              <a:spcBef>
-                <a:spcPts val="1800"/>
-              </a:spcBef>
-            </a:pPr>
-            <a:r>
-              <a:rPr sz="1500">
-                <a:solidFill>
-                  <a:srgbClr val="6D8C97"/>
-                </a:solidFill>
-              </a:rPr>
-              <a:t>covers: border</a:t>
-            </a:r>
-          </a:p>
         </p:txBody>
       </p:sp>
     </p:spTree>
@@ -9984,21 +9639,6 @@
               <a:t>Rounds the corners a little.</a:t>
             </a:r>
           </a:p>
-          <a:p>
-            <a:pPr>
-              <a:spcBef>
-                <a:spcPts val="1800"/>
-              </a:spcBef>
-            </a:pPr>
-            <a:r>
-              <a:rPr sz="1500">
-                <a:solidFill>
-                  <a:srgbClr val="6D8C97"/>
-                </a:solidFill>
-              </a:rPr>
-              <a:t>covers: border-radius</a:t>
-            </a:r>
-          </a:p>
         </p:txBody>
       </p:sp>
     </p:spTree>
@@ -10611,21 +10251,6 @@
               <a:t>Lays the form's children in a row with a small gap and a little space above. display: flex is the key part.</a:t>
             </a:r>
           </a:p>
-          <a:p>
-            <a:pPr>
-              <a:spcBef>
-                <a:spcPts val="1800"/>
-              </a:spcBef>
-            </a:pPr>
-            <a:r>
-              <a:rPr sz="1500">
-                <a:solidFill>
-                  <a:srgbClr val="6D8C97"/>
-                </a:solidFill>
-              </a:rPr>
-              <a:t>covers: display: flex, gap</a:t>
-            </a:r>
-          </a:p>
         </p:txBody>
       </p:sp>
     </p:spTree>
@@ -10752,21 +10377,6 @@
               <a:t>Starts a rule for the input inside .composer.</a:t>
             </a:r>
           </a:p>
-          <a:p>
-            <a:pPr>
-              <a:spcBef>
-                <a:spcPts val="1800"/>
-              </a:spcBef>
-            </a:pPr>
-            <a:r>
-              <a:rPr sz="1500">
-                <a:solidFill>
-                  <a:srgbClr val="6D8C97"/>
-                </a:solidFill>
-              </a:rPr>
-              <a:t>covers: A CSS rule</a:t>
-            </a:r>
-          </a:p>
         </p:txBody>
       </p:sp>
     </p:spTree>
@@ -11023,21 +10633,6 @@
               <a:t>flex: 1 makes the text box stretch to fill the space the button leaves.</a:t>
             </a:r>
           </a:p>
-          <a:p>
-            <a:pPr>
-              <a:spcBef>
-                <a:spcPts val="1800"/>
-              </a:spcBef>
-            </a:pPr>
-            <a:r>
-              <a:rPr sz="1500">
-                <a:solidFill>
-                  <a:srgbClr val="6D8C97"/>
-                </a:solidFill>
-              </a:rPr>
-              <a:t>covers: flex: 1</a:t>
-            </a:r>
-          </a:p>
         </p:txBody>
       </p:sp>
     </p:spTree>
@@ -11164,21 +10759,6 @@
               <a:t>Space inside the text box.</a:t>
             </a:r>
           </a:p>
-          <a:p>
-            <a:pPr>
-              <a:spcBef>
-                <a:spcPts val="1800"/>
-              </a:spcBef>
-            </a:pPr>
-            <a:r>
-              <a:rPr sz="1500">
-                <a:solidFill>
-                  <a:srgbClr val="6D8C97"/>
-                </a:solidFill>
-              </a:rPr>
-              <a:t>covers: padding</a:t>
-            </a:r>
-          </a:p>
         </p:txBody>
       </p:sp>
     </p:spTree>
@@ -11305,21 +10885,6 @@
               <a:t>A thin grey border to match the chat box.</a:t>
             </a:r>
           </a:p>
-          <a:p>
-            <a:pPr>
-              <a:spcBef>
-                <a:spcPts val="1800"/>
-              </a:spcBef>
-            </a:pPr>
-            <a:r>
-              <a:rPr sz="1500">
-                <a:solidFill>
-                  <a:srgbClr val="6D8C97"/>
-                </a:solidFill>
-              </a:rPr>
-              <a:t>covers: border</a:t>
-            </a:r>
-          </a:p>
         </p:txBody>
       </p:sp>
     </p:spTree>
@@ -11446,21 +11011,6 @@
               <a:t>Rounded corners.</a:t>
             </a:r>
           </a:p>
-          <a:p>
-            <a:pPr>
-              <a:spcBef>
-                <a:spcPts val="1800"/>
-              </a:spcBef>
-            </a:pPr>
-            <a:r>
-              <a:rPr sz="1500">
-                <a:solidFill>
-                  <a:srgbClr val="6D8C97"/>
-                </a:solidFill>
-              </a:rPr>
-              <a:t>covers: border-radius</a:t>
-            </a:r>
-          </a:p>
         </p:txBody>
       </p:sp>
     </p:spTree>
@@ -11587,21 +11137,6 @@
               <a:t>Comfortable text size.</a:t>
             </a:r>
           </a:p>
-          <a:p>
-            <a:pPr>
-              <a:spcBef>
-                <a:spcPts val="1800"/>
-              </a:spcBef>
-            </a:pPr>
-            <a:r>
-              <a:rPr sz="1500">
-                <a:solidFill>
-                  <a:srgbClr val="6D8C97"/>
-                </a:solidFill>
-              </a:rPr>
-              <a:t>covers: font-size</a:t>
-            </a:r>
-          </a:p>
         </p:txBody>
       </p:sp>
     </p:spTree>
@@ -11854,21 +11389,6 @@
               <a:t>Starts a rule for the button inside .composer.</a:t>
             </a:r>
           </a:p>
-          <a:p>
-            <a:pPr>
-              <a:spcBef>
-                <a:spcPts val="1800"/>
-              </a:spcBef>
-            </a:pPr>
-            <a:r>
-              <a:rPr sz="1500">
-                <a:solidFill>
-                  <a:srgbClr val="6D8C97"/>
-                </a:solidFill>
-              </a:rPr>
-              <a:t>covers: A CSS rule</a:t>
-            </a:r>
-          </a:p>
         </p:txBody>
       </p:sp>
     </p:spTree>
@@ -11995,21 +11515,6 @@
               <a:t>Opens &lt;header&gt;, the top strip. It closes a few lines down.</a:t>
             </a:r>
           </a:p>
-          <a:p>
-            <a:pPr>
-              <a:spcBef>
-                <a:spcPts val="1800"/>
-              </a:spcBef>
-            </a:pPr>
-            <a:r>
-              <a:rPr sz="1500">
-                <a:solidFill>
-                  <a:srgbClr val="6D8C97"/>
-                </a:solidFill>
-              </a:rPr>
-              <a:t>covers: The &lt;header&gt; tag</a:t>
-            </a:r>
-          </a:p>
         </p:txBody>
       </p:sp>
     </p:spTree>
@@ -12136,21 +11641,6 @@
               <a:t>Padding to make the button a comfortable size to tap.</a:t>
             </a:r>
           </a:p>
-          <a:p>
-            <a:pPr>
-              <a:spcBef>
-                <a:spcPts val="1800"/>
-              </a:spcBef>
-            </a:pPr>
-            <a:r>
-              <a:rPr sz="1500">
-                <a:solidFill>
-                  <a:srgbClr val="6D8C97"/>
-                </a:solidFill>
-              </a:rPr>
-              <a:t>covers: padding</a:t>
-            </a:r>
-          </a:p>
         </p:txBody>
       </p:sp>
     </p:spTree>
@@ -12277,21 +11767,6 @@
               <a:t>border: 0 removes the default button outline.</a:t>
             </a:r>
           </a:p>
-          <a:p>
-            <a:pPr>
-              <a:spcBef>
-                <a:spcPts val="1800"/>
-              </a:spcBef>
-            </a:pPr>
-            <a:r>
-              <a:rPr sz="1500">
-                <a:solidFill>
-                  <a:srgbClr val="6D8C97"/>
-                </a:solidFill>
-              </a:rPr>
-              <a:t>covers: border</a:t>
-            </a:r>
-          </a:p>
         </p:txBody>
       </p:sp>
     </p:spTree>
@@ -12418,21 +11893,6 @@
               <a:t>Rounded corners.</a:t>
             </a:r>
           </a:p>
-          <a:p>
-            <a:pPr>
-              <a:spcBef>
-                <a:spcPts val="1800"/>
-              </a:spcBef>
-            </a:pPr>
-            <a:r>
-              <a:rPr sz="1500">
-                <a:solidFill>
-                  <a:srgbClr val="6D8C97"/>
-                </a:solidFill>
-              </a:rPr>
-              <a:t>covers: border-radius</a:t>
-            </a:r>
-          </a:p>
         </p:txBody>
       </p:sp>
     </p:spTree>
@@ -12559,21 +12019,6 @@
               <a:t>The brand blue as its background.</a:t>
             </a:r>
           </a:p>
-          <a:p>
-            <a:pPr>
-              <a:spcBef>
-                <a:spcPts val="1800"/>
-              </a:spcBef>
-            </a:pPr>
-            <a:r>
-              <a:rPr sz="1500">
-                <a:solidFill>
-                  <a:srgbClr val="6D8C97"/>
-                </a:solidFill>
-              </a:rPr>
-              <a:t>covers: background</a:t>
-            </a:r>
-          </a:p>
         </p:txBody>
       </p:sp>
     </p:spTree>
@@ -12700,21 +12145,6 @@
               <a:t>White text on the blue.</a:t>
             </a:r>
           </a:p>
-          <a:p>
-            <a:pPr>
-              <a:spcBef>
-                <a:spcPts val="1800"/>
-              </a:spcBef>
-            </a:pPr>
-            <a:r>
-              <a:rPr sz="1500">
-                <a:solidFill>
-                  <a:srgbClr val="6D8C97"/>
-                </a:solidFill>
-              </a:rPr>
-              <a:t>covers: color</a:t>
-            </a:r>
-          </a:p>
         </p:txBody>
       </p:sp>
     </p:spTree>
@@ -12841,21 +12271,6 @@
               <a:t>Readable text size.</a:t>
             </a:r>
           </a:p>
-          <a:p>
-            <a:pPr>
-              <a:spcBef>
-                <a:spcPts val="1800"/>
-              </a:spcBef>
-            </a:pPr>
-            <a:r>
-              <a:rPr sz="1500">
-                <a:solidFill>
-                  <a:srgbClr val="6D8C97"/>
-                </a:solidFill>
-              </a:rPr>
-              <a:t>covers: font-size</a:t>
-            </a:r>
-          </a:p>
         </p:txBody>
       </p:sp>
     </p:spTree>
@@ -13112,21 +12527,6 @@
               <a:t>cursor: pointer shows a hand so it looks clickable.</a:t>
             </a:r>
           </a:p>
-          <a:p>
-            <a:pPr>
-              <a:spcBef>
-                <a:spcPts val="1800"/>
-              </a:spcBef>
-            </a:pPr>
-            <a:r>
-              <a:rPr sz="1500">
-                <a:solidFill>
-                  <a:srgbClr val="6D8C97"/>
-                </a:solidFill>
-              </a:rPr>
-              <a:t>covers: cursor</a:t>
-            </a:r>
-          </a:p>
         </p:txBody>
       </p:sp>
     </p:spTree>
@@ -13766,21 +13166,6 @@
               <a:t>Loads your JavaScript. It sits at the very bottom so every box above already exists when the code runs.</a:t>
             </a:r>
           </a:p>
-          <a:p>
-            <a:pPr>
-              <a:spcBef>
-                <a:spcPts val="1800"/>
-              </a:spcBef>
-            </a:pPr>
-            <a:r>
-              <a:rPr sz="1500">
-                <a:solidFill>
-                  <a:srgbClr val="6D8C97"/>
-                </a:solidFill>
-              </a:rPr>
-              <a:t>covers: The &lt;script&gt; tag</a:t>
-            </a:r>
-          </a:p>
         </p:txBody>
       </p:sp>
     </p:spTree>
@@ -14134,21 +13519,6 @@
               <a:t>A comment: a note for you, ignored by the computer.</a:t>
             </a:r>
           </a:p>
-          <a:p>
-            <a:pPr>
-              <a:spcBef>
-                <a:spcPts val="1800"/>
-              </a:spcBef>
-            </a:pPr>
-            <a:r>
-              <a:rPr sz="1500">
-                <a:solidFill>
-                  <a:srgbClr val="6D8C97"/>
-                </a:solidFill>
-              </a:rPr>
-              <a:t>covers: A comment</a:t>
-            </a:r>
-          </a:p>
         </p:txBody>
       </p:sp>
     </p:spTree>
@@ -14405,21 +13775,6 @@
               <a:t>console.log prints a message to the console panel - proof the file is running.</a:t>
             </a:r>
           </a:p>
-          <a:p>
-            <a:pPr>
-              <a:spcBef>
-                <a:spcPts val="1800"/>
-              </a:spcBef>
-            </a:pPr>
-            <a:r>
-              <a:rPr sz="1500">
-                <a:solidFill>
-                  <a:srgbClr val="6D8C97"/>
-                </a:solidFill>
-              </a:rPr>
-              <a:t>covers: console.log()</a:t>
-            </a:r>
-          </a:p>
         </p:txBody>
       </p:sp>
     </p:spTree>
@@ -14546,21 +13901,6 @@
               <a:t>Another comment, explaining the check below.</a:t>
             </a:r>
           </a:p>
-          <a:p>
-            <a:pPr>
-              <a:spcBef>
-                <a:spcPts val="1800"/>
-              </a:spcBef>
-            </a:pPr>
-            <a:r>
-              <a:rPr sz="1500">
-                <a:solidFill>
-                  <a:srgbClr val="6D8C97"/>
-                </a:solidFill>
-              </a:rPr>
-              <a:t>covers: A comment</a:t>
-            </a:r>
-          </a:p>
         </p:txBody>
       </p:sp>
     </p:spTree>
@@ -14687,21 +14027,6 @@
               <a:t>A comment continued: what would happen if the script ran too early.</a:t>
             </a:r>
           </a:p>
-          <a:p>
-            <a:pPr>
-              <a:spcBef>
-                <a:spcPts val="1800"/>
-              </a:spcBef>
-            </a:pPr>
-            <a:r>
-              <a:rPr sz="1500">
-                <a:solidFill>
-                  <a:srgbClr val="6D8C97"/>
-                </a:solidFill>
-              </a:rPr>
-              <a:t>covers: A comment</a:t>
-            </a:r>
-          </a:p>
         </p:txBody>
       </p:sp>
     </p:spTree>
@@ -14828,21 +14153,6 @@
               <a:t>The comment's last line: which is why the &lt;script&gt; tag goes at the bottom.</a:t>
             </a:r>
           </a:p>
-          <a:p>
-            <a:pPr>
-              <a:spcBef>
-                <a:spcPts val="1800"/>
-              </a:spcBef>
-            </a:pPr>
-            <a:r>
-              <a:rPr sz="1500">
-                <a:solidFill>
-                  <a:srgbClr val="6D8C97"/>
-                </a:solidFill>
-              </a:rPr>
-              <a:t>covers: A comment</a:t>
-            </a:r>
-          </a:p>
         </p:txBody>
       </p:sp>
     </p:spTree>
@@ -14969,21 +14279,6 @@
               <a:t>The big title of the page, inside an &lt;h1&gt;.</a:t>
             </a:r>
           </a:p>
-          <a:p>
-            <a:pPr>
-              <a:spcBef>
-                <a:spcPts val="1800"/>
-              </a:spcBef>
-            </a:pPr>
-            <a:r>
-              <a:rPr sz="1500">
-                <a:solidFill>
-                  <a:srgbClr val="6D8C97"/>
-                </a:solidFill>
-              </a:rPr>
-              <a:t>covers: The &lt;h1&gt; tag</a:t>
-            </a:r>
-          </a:p>
         </p:txBody>
       </p:sp>
     </p:spTree>
@@ -15238,21 +14533,6 @@
                 </a:solidFill>
               </a:rPr>
               <a:t>getElementById looks for the chat box; !== null is true only if it was found. Because the script is at the bottom, it prints true.</a:t>
-            </a:r>
-          </a:p>
-          <a:p>
-            <a:pPr>
-              <a:spcBef>
-                <a:spcPts val="1800"/>
-              </a:spcBef>
-            </a:pPr>
-            <a:r>
-              <a:rPr sz="1500">
-                <a:solidFill>
-                  <a:srgbClr val="6D8C97"/>
-                </a:solidFill>
-              </a:rPr>
-              <a:t>covers: console.log(), document.getElementById()</a:t>
             </a:r>
           </a:p>
         </p:txBody>

</xml_diff>

<commit_message>
Add run-it checkpoint slides with a Show-output button
Each of weeks 1-4 now ends with a checkpoint slide: an instruction to run
the code and a button the instructor clicks to render the project exactly
as it should look at that point, so the class can compare their screen.
The web deck embeds the assembled project (HTML/CSS/JS inlined) and shows
it in a sandboxed iframe - weeks 1-2 run fully and interactively in the
slide; the AI weeks show the interface and note the reply needs the
classroom key. The .pptx cannot embed a live frame, so there the
checkpoint points at the classroom instead. 366 -> 370 slides.

Co-Authored-By: Claude Opus 5 <noreply@anthropic.com>
</commit_message>
<xml_diff>
--- a/ai101/slides/week-01.pptx
+++ b/ai101/slides/week-01.pptx
@@ -116,6 +116,7 @@
     <p:sldId id="364" r:id="rId115"/>
     <p:sldId id="365" r:id="rId116"/>
     <p:sldId id="366" r:id="rId117"/>
+    <p:sldId id="367" r:id="rId118"/>
   </p:sldIdLst>
   <p:sldSz cx="12191695" cy="6858000" type="screen4x3"/>
   <p:notesSz cx="6858000" cy="9144000"/>
@@ -5688,6 +5689,151 @@
 </file>
 
 <file path=ppt/slides/slide111.xml><?xml version="1.0" encoding="utf-8"?>
+<p:sld xmlns:a="http://schemas.openxmlformats.org/drawingml/2006/main" xmlns:p="http://schemas.openxmlformats.org/presentationml/2006/main" xmlns:r="http://schemas.openxmlformats.org/officeDocument/2006/relationships">
+  <p:cSld>
+    <p:spTree>
+      <p:nvGrpSpPr>
+        <p:cNvPr id="1" name=""/>
+        <p:cNvGrpSpPr/>
+        <p:nvPr/>
+      </p:nvGrpSpPr>
+      <p:grpSpPr/>
+      <p:sp>
+        <p:nvSpPr>
+          <p:cNvPr id="2" name="Title 1"/>
+          <p:cNvSpPr>
+            <a:spLocks noGrp="1"/>
+          </p:cNvSpPr>
+          <p:nvPr>
+            <p:ph type="title"/>
+          </p:nvPr>
+        </p:nvSpPr>
+        <p:spPr/>
+        <p:txBody>
+          <a:bodyPr/>
+          <a:lstStyle/>
+          <a:p>
+            <a:r>
+              <a:rPr sz="3800" b="1">
+                <a:solidFill>
+                  <a:srgbClr val="1F2A37"/>
+                </a:solidFill>
+              </a:rPr>
+              <a:t>Checkpoint: your page</a:t>
+            </a:r>
+          </a:p>
+        </p:txBody>
+      </p:sp>
+      <p:sp>
+        <p:nvSpPr>
+          <p:cNvPr id="3" name="TextBox 2"/>
+          <p:cNvSpPr txBox="1"/>
+          <p:nvPr/>
+        </p:nvSpPr>
+        <p:spPr>
+          <a:xfrm>
+            <a:off x="868680" y="502920"/>
+            <a:ext cx="5486400" cy="457200"/>
+          </a:xfrm>
+          <a:prstGeom prst="rect">
+            <a:avLst/>
+          </a:prstGeom>
+          <a:noFill/>
+        </p:spPr>
+        <p:txBody>
+          <a:bodyPr wrap="none">
+            <a:spAutoFit/>
+          </a:bodyPr>
+          <a:lstStyle/>
+          <a:p>
+            <a:r>
+              <a:rPr sz="1500" b="1">
+                <a:solidFill>
+                  <a:srgbClr val="01AEFD"/>
+                </a:solidFill>
+              </a:rPr>
+              <a:t>CHECKPOINT - RUN IT</a:t>
+            </a:r>
+          </a:p>
+        </p:txBody>
+      </p:sp>
+      <p:sp>
+        <p:nvSpPr>
+          <p:cNvPr id="4" name="TextBox 3"/>
+          <p:cNvSpPr txBox="1"/>
+          <p:nvPr/>
+        </p:nvSpPr>
+        <p:spPr>
+          <a:xfrm>
+            <a:off x="822960" y="1828800"/>
+            <a:ext cx="10515600" cy="4206240"/>
+          </a:xfrm>
+          <a:prstGeom prst="rect">
+            <a:avLst/>
+          </a:prstGeom>
+          <a:noFill/>
+        </p:spPr>
+        <p:txBody>
+          <a:bodyPr wrap="square">
+            <a:spAutoFit/>
+          </a:bodyPr>
+          <a:lstStyle/>
+          <a:p>
+            <a:pPr>
+              <a:spcAft>
+                <a:spcPts val="1400"/>
+              </a:spcAft>
+            </a:pPr>
+            <a:r>
+              <a:rPr sz="2800">
+                <a:solidFill>
+                  <a:srgbClr val="01AEFD"/>
+                </a:solidFill>
+              </a:rPr>
+              <a:t>Press Run. You should see the title, an empty white chat box, and a text box with a blue Send button - all styled. Clicking Send does nothing yet; that is next week.</a:t>
+            </a:r>
+          </a:p>
+          <a:p>
+            <a:pPr>
+              <a:spcAft>
+                <a:spcPts val="1400"/>
+              </a:spcAft>
+            </a:pPr>
+            <a:r>
+              <a:rPr sz="2400">
+                <a:solidFill>
+                  <a:srgbClr val="1F2A37"/>
+                </a:solidFill>
+              </a:rPr>
+              <a:t>• Run it in the classroom, or press Show the output in the web deck.</a:t>
+            </a:r>
+          </a:p>
+          <a:p>
+            <a:pPr>
+              <a:spcAft>
+                <a:spcPts val="1400"/>
+              </a:spcAft>
+            </a:pPr>
+            <a:r>
+              <a:rPr sz="2400">
+                <a:solidFill>
+                  <a:srgbClr val="1F2A37"/>
+                </a:solidFill>
+              </a:rPr>
+              <a:t>• Everyone's screen should match this.</a:t>
+            </a:r>
+          </a:p>
+        </p:txBody>
+      </p:sp>
+    </p:spTree>
+  </p:cSld>
+  <p:clrMapOvr>
+    <a:masterClrMapping/>
+  </p:clrMapOvr>
+</p:sld>
+</file>
+
+<file path=ppt/slides/slide112.xml><?xml version="1.0" encoding="utf-8"?>
 <p:sld xmlns:a="http://schemas.openxmlformats.org/drawingml/2006/main" xmlns:p="http://schemas.openxmlformats.org/presentationml/2006/main" xmlns:r="http://schemas.openxmlformats.org/officeDocument/2006/relationships">
   <p:cSld>
     <p:spTree>

</xml_diff>

<commit_message>
Write every slide in the student voice
The deck spoke about the student in the third person in a few places (the
input the student types in, everything the student sees). Rewritten so
every slide addresses the reader directly - you type, you see, your code
reads. A scan of all slide text confirms no third-person or
teacher-directed phrasing remains on the slides (teacher guidance lives
in teacher.html, not the deck).

Co-Authored-By: Claude Opus 5 <noreply@anthropic.com>
</commit_message>
<xml_diff>
--- a/ai101/slides/week-01.pptx
+++ b/ai101/slides/week-01.pptx
@@ -7684,7 +7684,7 @@
                   <a:srgbClr val="1F2A37"/>
                 </a:solidFill>
               </a:rPr>
-              <a:t>• A box the student types into.</a:t>
+              <a:t>• A box you type into.</a:t>
             </a:r>
           </a:p>
           <a:p>
@@ -7864,7 +7864,7 @@
                   <a:srgbClr val="DCECEF"/>
                 </a:solidFill>
               </a:rPr>
-              <a:t>The &lt;input&gt; the student types in. placeholder is the faint hint; autocomplete off hides suggestions.</a:t>
+              <a:t>The &lt;input&gt; you type in. placeholder is the faint hint; autocomplete off hides suggestions.</a:t>
             </a:r>
           </a:p>
         </p:txBody>
@@ -14710,7 +14710,7 @@
                   <a:srgbClr val="1F2A37"/>
                 </a:solidFill>
               </a:rPr>
-              <a:t>• Everything the student sees lives inside it.</a:t>
+              <a:t>• Everything you see on the page lives inside it.</a:t>
             </a:r>
           </a:p>
         </p:txBody>

</xml_diff>

<commit_message>
Expand weeks 6, 7 and 8 slides (personality, memory, the wall)
Roll weeks 6-8 into the concept-first, one-line-per-slide format, same as
weeks 1-5: an explainer slide before the first line that uses each new idea,
one slide per typed line showing the block-so-far with that line highlighted,
an all-together slide per block, and a run-it checkpoint.

New concepts explained at first use: the <details>/<summary>/<textarea> tags;
the CSS margin-bottom/top/left, width, font-weight, white-space, height,
overflow-y, flex-direction and single-corner radii; and the JavaScript ideas
these weeks lean on - arrays with .push/.shift/.length, spread (...), for...of,
while, let, and .className. line_concepts learns to spot the new JS ideas.

margin-top now gets its explainer in week 1, where it is first used.

Co-Authored-By: Claude Opus 4.8 <noreply@anthropic.com>
</commit_message>
<xml_diff>
--- a/ai101/slides/week-01.pptx
+++ b/ai101/slides/week-01.pptx
@@ -117,6 +117,7 @@
     <p:sldId id="365" r:id="rId116"/>
     <p:sldId id="366" r:id="rId117"/>
     <p:sldId id="367" r:id="rId118"/>
+    <p:sldId id="368" r:id="rId119"/>
   </p:sldIdLst>
   <p:sldSz cx="12191695" cy="6858000" type="screen4x3"/>
   <p:notesSz cx="6858000" cy="9144000"/>
@@ -3432,7 +3433,7 @@
                   <a:srgbClr val="1F2A37"/>
                 </a:solidFill>
               </a:rPr>
-              <a:t>Calling a function</a:t>
+              <a:t>Strings: text in quotes</a:t>
             </a:r>
           </a:p>
         </p:txBody>
@@ -3503,7 +3504,7 @@
                   <a:srgbClr val="1F2A37"/>
                 </a:solidFill>
               </a:rPr>
-              <a:t>• A name followed by ( ) runs that function.</a:t>
+              <a:t>• Text the computer treats as data goes in quotes: 'hello'.</a:t>
             </a:r>
           </a:p>
           <a:p>
@@ -3518,7 +3519,7 @@
                   <a:srgbClr val="1F2A37"/>
                 </a:solidFill>
               </a:rPr>
-              <a:t>• Whatever is inside the ( ) is what you hand it.</a:t>
+              <a:t>• Single or double quotes both work.</a:t>
             </a:r>
           </a:p>
         </p:txBody>
@@ -3562,7 +3563,7 @@
                   <a:srgbClr val="1F2A37"/>
                 </a:solidFill>
               </a:rPr>
-              <a:t>Dot notation</a:t>
+              <a:t>Calling a function</a:t>
             </a:r>
           </a:p>
         </p:txBody>
@@ -3633,7 +3634,7 @@
                   <a:srgbClr val="1F2A37"/>
                 </a:solidFill>
               </a:rPr>
-              <a:t>• thing.name reaches INTO thing for one of its parts or actions.</a:t>
+              <a:t>• A name followed by ( ) runs that function.</a:t>
             </a:r>
           </a:p>
           <a:p>
@@ -3648,7 +3649,7 @@
                   <a:srgbClr val="1F2A37"/>
                 </a:solidFill>
               </a:rPr>
-              <a:t>• document.getElementById asks document to find something.</a:t>
+              <a:t>• Whatever is inside the ( ) is what you hand it.</a:t>
             </a:r>
           </a:p>
         </p:txBody>
@@ -3692,7 +3693,7 @@
                   <a:srgbClr val="1F2A37"/>
                 </a:solidFill>
               </a:rPr>
-              <a:t>console.log()</a:t>
+              <a:t>Dot notation</a:t>
             </a:r>
           </a:p>
         </p:txBody>
@@ -3763,7 +3764,7 @@
                   <a:srgbClr val="1F2A37"/>
                 </a:solidFill>
               </a:rPr>
-              <a:t>• A built-in that prints a message to the console panel.</a:t>
+              <a:t>• thing.name reaches INTO thing for one of its parts or actions.</a:t>
             </a:r>
           </a:p>
           <a:p>
@@ -3778,7 +3779,7 @@
                   <a:srgbClr val="1F2A37"/>
                 </a:solidFill>
               </a:rPr>
-              <a:t>• Your window into what the code is doing.</a:t>
+              <a:t>• document.getElementById asks document to find something.</a:t>
             </a:r>
           </a:p>
         </p:txBody>
@@ -3794,14 +3795,6 @@
 <file path=ppt/slides/slide103.xml><?xml version="1.0" encoding="utf-8"?>
 <p:sld xmlns:a="http://schemas.openxmlformats.org/drawingml/2006/main" xmlns:p="http://schemas.openxmlformats.org/presentationml/2006/main" xmlns:r="http://schemas.openxmlformats.org/officeDocument/2006/relationships">
   <p:cSld>
-    <p:bg>
-      <p:bgPr>
-        <a:solidFill>
-          <a:srgbClr val="102127"/>
-        </a:solidFill>
-        <a:effectLst/>
-      </p:bgPr>
-    </p:bg>
     <p:spTree>
       <p:nvGrpSpPr>
         <p:cNvPr id="1" name=""/>
@@ -3811,14 +3804,40 @@
       <p:grpSpPr/>
       <p:sp>
         <p:nvSpPr>
-          <p:cNvPr id="2" name="TextBox 1"/>
-          <p:cNvSpPr txBox="1"/>
-          <p:nvPr/>
-        </p:nvSpPr>
-        <p:spPr>
-          <a:xfrm>
-            <a:off x="502920" y="274320"/>
-            <a:ext cx="11155680" cy="548640"/>
+          <p:cNvPr id="2" name="Title 1"/>
+          <p:cNvSpPr>
+            <a:spLocks noGrp="1"/>
+          </p:cNvSpPr>
+          <p:nvPr>
+            <p:ph type="title"/>
+          </p:nvPr>
+        </p:nvSpPr>
+        <p:spPr/>
+        <p:txBody>
+          <a:bodyPr/>
+          <a:lstStyle/>
+          <a:p>
+            <a:r>
+              <a:rPr sz="3800" b="1">
+                <a:solidFill>
+                  <a:srgbClr val="1F2A37"/>
+                </a:solidFill>
+              </a:rPr>
+              <a:t>console.log()</a:t>
+            </a:r>
+          </a:p>
+        </p:txBody>
+      </p:sp>
+      <p:sp>
+        <p:nvSpPr>
+          <p:cNvPr id="3" name="TextBox 2"/>
+          <p:cNvSpPr txBox="1"/>
+          <p:nvPr/>
+        </p:nvSpPr>
+        <p:spPr>
+          <a:xfrm>
+            <a:off x="868680" y="502920"/>
+            <a:ext cx="5486400" cy="457200"/>
           </a:xfrm>
           <a:prstGeom prst="rect">
             <a:avLst/>
@@ -3832,85 +3851,12 @@
           <a:lstStyle/>
           <a:p>
             <a:r>
-              <a:rPr sz="2200" b="1">
+              <a:rPr sz="1500" b="1">
                 <a:solidFill>
                   <a:srgbClr val="01AEFD"/>
                 </a:solidFill>
               </a:rPr>
-              <a:t>Type this into script.js   -   line 2</a:t>
-            </a:r>
-          </a:p>
-        </p:txBody>
-      </p:sp>
-      <p:sp>
-        <p:nvSpPr>
-          <p:cNvPr id="3" name="TextBox 2"/>
-          <p:cNvSpPr txBox="1"/>
-          <p:nvPr/>
-        </p:nvSpPr>
-        <p:spPr>
-          <a:xfrm>
-            <a:off x="502920" y="960120"/>
-            <a:ext cx="11155680" cy="4297680"/>
-          </a:xfrm>
-          <a:prstGeom prst="rect">
-            <a:avLst/>
-          </a:prstGeom>
-          <a:noFill/>
-        </p:spPr>
-        <p:txBody>
-          <a:bodyPr wrap="none">
-            <a:spAutoFit/>
-          </a:bodyPr>
-          <a:lstStyle/>
-          <a:p>
-            <a:pPr>
-              <a:spcAft>
-                <a:spcPts val="0"/>
-              </a:spcAft>
-            </a:pPr>
-            <a:r>
-              <a:rPr sz="1800">
-                <a:solidFill>
-                  <a:srgbClr val="6D8C97"/>
-                </a:solidFill>
-                <a:latin typeface="Consolas"/>
-              </a:rPr>
-              <a:t>   1  </a:t>
-            </a:r>
-            <a:r>
-              <a:rPr sz="1800">
-                <a:solidFill>
-                  <a:srgbClr val="6D8C97"/>
-                </a:solidFill>
-                <a:latin typeface="Consolas"/>
-              </a:rPr>
-              <a:t>// Week 1: prove the JavaScript file is really running.</a:t>
-            </a:r>
-          </a:p>
-          <a:p>
-            <a:pPr>
-              <a:spcAft>
-                <a:spcPts val="0"/>
-              </a:spcAft>
-            </a:pPr>
-            <a:r>
-              <a:rPr sz="1800">
-                <a:solidFill>
-                  <a:srgbClr val="6D8C97"/>
-                </a:solidFill>
-                <a:latin typeface="Consolas"/>
-              </a:rPr>
-              <a:t>   2  </a:t>
-            </a:r>
-            <a:r>
-              <a:rPr sz="1800">
-                <a:solidFill>
-                  <a:srgbClr val="7FE0A0"/>
-                </a:solidFill>
-                <a:latin typeface="Consolas"/>
-              </a:rPr>
-              <a:t>console.log('My AI companion is starting up.');</a:t>
+              <a:t>JAVASCRIPT</a:t>
             </a:r>
           </a:p>
         </p:txBody>
@@ -3923,8 +3869,8 @@
         </p:nvSpPr>
         <p:spPr>
           <a:xfrm>
-            <a:off x="548640" y="5623560"/>
-            <a:ext cx="11064240" cy="1051560"/>
+            <a:off x="822960" y="1828800"/>
+            <a:ext cx="10515600" cy="4206240"/>
           </a:xfrm>
           <a:prstGeom prst="rect">
             <a:avLst/>
@@ -3937,13 +3883,33 @@
           </a:bodyPr>
           <a:lstStyle/>
           <a:p>
-            <a:r>
-              <a:rPr sz="2000">
-                <a:solidFill>
-                  <a:srgbClr val="DCECEF"/>
-                </a:solidFill>
-              </a:rPr>
-              <a:t>console.log prints a message to the console panel - proof the file is running.</a:t>
+            <a:pPr>
+              <a:spcAft>
+                <a:spcPts val="1400"/>
+              </a:spcAft>
+            </a:pPr>
+            <a:r>
+              <a:rPr sz="2400">
+                <a:solidFill>
+                  <a:srgbClr val="1F2A37"/>
+                </a:solidFill>
+              </a:rPr>
+              <a:t>• A built-in that prints a message to the console panel.</a:t>
+            </a:r>
+          </a:p>
+          <a:p>
+            <a:pPr>
+              <a:spcAft>
+                <a:spcPts val="1400"/>
+              </a:spcAft>
+            </a:pPr>
+            <a:r>
+              <a:rPr sz="2400">
+                <a:solidFill>
+                  <a:srgbClr val="1F2A37"/>
+                </a:solidFill>
+              </a:rPr>
+              <a:t>• Your window into what the code is doing.</a:t>
             </a:r>
           </a:p>
         </p:txBody>
@@ -4002,7 +3968,7 @@
                   <a:srgbClr val="01AEFD"/>
                 </a:solidFill>
               </a:rPr>
-              <a:t>Type this into script.js   -   line 4</a:t>
+              <a:t>Type this into script.js   -   line 2</a:t>
             </a:r>
           </a:p>
         </p:txBody>
@@ -4071,61 +4037,11 @@
             <a:r>
               <a:rPr sz="1800">
                 <a:solidFill>
-                  <a:srgbClr val="6D8C97"/>
+                  <a:srgbClr val="7FE0A0"/>
                 </a:solidFill>
                 <a:latin typeface="Consolas"/>
               </a:rPr>
               <a:t>console.log('My AI companion is starting up.');</a:t>
-            </a:r>
-          </a:p>
-          <a:p>
-            <a:pPr>
-              <a:spcAft>
-                <a:spcPts val="0"/>
-              </a:spcAft>
-            </a:pPr>
-            <a:r>
-              <a:rPr sz="1800">
-                <a:solidFill>
-                  <a:srgbClr val="6D8C97"/>
-                </a:solidFill>
-                <a:latin typeface="Consolas"/>
-              </a:rPr>
-              <a:t>   3  </a:t>
-            </a:r>
-            <a:r>
-              <a:rPr sz="1800">
-                <a:solidFill>
-                  <a:srgbClr val="6D8C97"/>
-                </a:solidFill>
-                <a:latin typeface="Consolas"/>
-              </a:rPr>
-              <a:t> </a:t>
-            </a:r>
-          </a:p>
-          <a:p>
-            <a:pPr>
-              <a:spcAft>
-                <a:spcPts val="0"/>
-              </a:spcAft>
-            </a:pPr>
-            <a:r>
-              <a:rPr sz="1800">
-                <a:solidFill>
-                  <a:srgbClr val="6D8C97"/>
-                </a:solidFill>
-                <a:latin typeface="Consolas"/>
-              </a:rPr>
-              <a:t>   4  </a:t>
-            </a:r>
-            <a:r>
-              <a:rPr sz="1800">
-                <a:solidFill>
-                  <a:srgbClr val="7FE0A0"/>
-                </a:solidFill>
-                <a:latin typeface="Consolas"/>
-              </a:rPr>
-              <a:t>// Can this script see the page yet? Down here, yes.</a:t>
             </a:r>
           </a:p>
         </p:txBody>
@@ -4158,7 +4074,7 @@
                   <a:srgbClr val="DCECEF"/>
                 </a:solidFill>
               </a:rPr>
-              <a:t>Another comment, explaining the check below.</a:t>
+              <a:t>console.log prints a message to the console panel - proof the file is running.</a:t>
             </a:r>
           </a:p>
         </p:txBody>
@@ -4217,7 +4133,7 @@
                   <a:srgbClr val="01AEFD"/>
                 </a:solidFill>
               </a:rPr>
-              <a:t>Type this into script.js   -   line 5</a:t>
+              <a:t>Type this into script.js   -   line 4</a:t>
             </a:r>
           </a:p>
         </p:txBody>
@@ -4336,36 +4252,11 @@
             <a:r>
               <a:rPr sz="1800">
                 <a:solidFill>
-                  <a:srgbClr val="6D8C97"/>
+                  <a:srgbClr val="7FE0A0"/>
                 </a:solidFill>
                 <a:latin typeface="Consolas"/>
               </a:rPr>
               <a:t>// Can this script see the page yet? Down here, yes.</a:t>
-            </a:r>
-          </a:p>
-          <a:p>
-            <a:pPr>
-              <a:spcAft>
-                <a:spcPts val="0"/>
-              </a:spcAft>
-            </a:pPr>
-            <a:r>
-              <a:rPr sz="1800">
-                <a:solidFill>
-                  <a:srgbClr val="6D8C97"/>
-                </a:solidFill>
-                <a:latin typeface="Consolas"/>
-              </a:rPr>
-              <a:t>   5  </a:t>
-            </a:r>
-            <a:r>
-              <a:rPr sz="1800">
-                <a:solidFill>
-                  <a:srgbClr val="7FE0A0"/>
-                </a:solidFill>
-                <a:latin typeface="Consolas"/>
-              </a:rPr>
-              <a:t>// Move the &lt;script&gt; tag to the TOP of index.html and this prints false,</a:t>
             </a:r>
           </a:p>
         </p:txBody>
@@ -4398,7 +4289,7 @@
                   <a:srgbClr val="DCECEF"/>
                 </a:solidFill>
               </a:rPr>
-              <a:t>A comment continued: what would happen if the script ran too early.</a:t>
+              <a:t>Another comment, explaining the check below.</a:t>
             </a:r>
           </a:p>
         </p:txBody>
@@ -4457,7 +4348,7 @@
                   <a:srgbClr val="01AEFD"/>
                 </a:solidFill>
               </a:rPr>
-              <a:t>Type this into script.js   -   line 6</a:t>
+              <a:t>Type this into script.js   -   line 5</a:t>
             </a:r>
           </a:p>
         </p:txBody>
@@ -4601,36 +4492,11 @@
             <a:r>
               <a:rPr sz="1800">
                 <a:solidFill>
-                  <a:srgbClr val="6D8C97"/>
+                  <a:srgbClr val="7FE0A0"/>
                 </a:solidFill>
                 <a:latin typeface="Consolas"/>
               </a:rPr>
               <a:t>// Move the &lt;script&gt; tag to the TOP of index.html and this prints false,</a:t>
-            </a:r>
-          </a:p>
-          <a:p>
-            <a:pPr>
-              <a:spcAft>
-                <a:spcPts val="0"/>
-              </a:spcAft>
-            </a:pPr>
-            <a:r>
-              <a:rPr sz="1800">
-                <a:solidFill>
-                  <a:srgbClr val="6D8C97"/>
-                </a:solidFill>
-                <a:latin typeface="Consolas"/>
-              </a:rPr>
-              <a:t>   6  </a:t>
-            </a:r>
-            <a:r>
-              <a:rPr sz="1800">
-                <a:solidFill>
-                  <a:srgbClr val="7FE0A0"/>
-                </a:solidFill>
-                <a:latin typeface="Consolas"/>
-              </a:rPr>
-              <a:t>// because the boxes have not been made yet. That is why it goes last.</a:t>
             </a:r>
           </a:p>
         </p:txBody>
@@ -4663,7 +4529,7 @@
                   <a:srgbClr val="DCECEF"/>
                 </a:solidFill>
               </a:rPr>
-              <a:t>The comment's last line: which is why the &lt;script&gt; tag goes at the bottom.</a:t>
+              <a:t>A comment continued: what would happen if the script ran too early.</a:t>
             </a:r>
           </a:p>
         </p:txBody>
@@ -4677,136 +4543,6 @@
 </file>
 
 <file path=ppt/slides/slide107.xml><?xml version="1.0" encoding="utf-8"?>
-<p:sld xmlns:a="http://schemas.openxmlformats.org/drawingml/2006/main" xmlns:p="http://schemas.openxmlformats.org/presentationml/2006/main" xmlns:r="http://schemas.openxmlformats.org/officeDocument/2006/relationships">
-  <p:cSld>
-    <p:spTree>
-      <p:nvGrpSpPr>
-        <p:cNvPr id="1" name=""/>
-        <p:cNvGrpSpPr/>
-        <p:nvPr/>
-      </p:nvGrpSpPr>
-      <p:grpSpPr/>
-      <p:sp>
-        <p:nvSpPr>
-          <p:cNvPr id="2" name="Title 1"/>
-          <p:cNvSpPr>
-            <a:spLocks noGrp="1"/>
-          </p:cNvSpPr>
-          <p:nvPr>
-            <p:ph type="title"/>
-          </p:nvPr>
-        </p:nvSpPr>
-        <p:spPr/>
-        <p:txBody>
-          <a:bodyPr/>
-          <a:lstStyle/>
-          <a:p>
-            <a:r>
-              <a:rPr sz="3800" b="1">
-                <a:solidFill>
-                  <a:srgbClr val="1F2A37"/>
-                </a:solidFill>
-              </a:rPr>
-              <a:t>document.getElementById()</a:t>
-            </a:r>
-          </a:p>
-        </p:txBody>
-      </p:sp>
-      <p:sp>
-        <p:nvSpPr>
-          <p:cNvPr id="3" name="TextBox 2"/>
-          <p:cNvSpPr txBox="1"/>
-          <p:nvPr/>
-        </p:nvSpPr>
-        <p:spPr>
-          <a:xfrm>
-            <a:off x="868680" y="502920"/>
-            <a:ext cx="5486400" cy="457200"/>
-          </a:xfrm>
-          <a:prstGeom prst="rect">
-            <a:avLst/>
-          </a:prstGeom>
-          <a:noFill/>
-        </p:spPr>
-        <p:txBody>
-          <a:bodyPr wrap="none">
-            <a:spAutoFit/>
-          </a:bodyPr>
-          <a:lstStyle/>
-          <a:p>
-            <a:r>
-              <a:rPr sz="1500" b="1">
-                <a:solidFill>
-                  <a:srgbClr val="01AEFD"/>
-                </a:solidFill>
-              </a:rPr>
-              <a:t>JAVASCRIPT</a:t>
-            </a:r>
-          </a:p>
-        </p:txBody>
-      </p:sp>
-      <p:sp>
-        <p:nvSpPr>
-          <p:cNvPr id="4" name="TextBox 3"/>
-          <p:cNvSpPr txBox="1"/>
-          <p:nvPr/>
-        </p:nvSpPr>
-        <p:spPr>
-          <a:xfrm>
-            <a:off x="822960" y="1828800"/>
-            <a:ext cx="10515600" cy="4206240"/>
-          </a:xfrm>
-          <a:prstGeom prst="rect">
-            <a:avLst/>
-          </a:prstGeom>
-          <a:noFill/>
-        </p:spPr>
-        <p:txBody>
-          <a:bodyPr wrap="square">
-            <a:spAutoFit/>
-          </a:bodyPr>
-          <a:lstStyle/>
-          <a:p>
-            <a:pPr>
-              <a:spcAft>
-                <a:spcPts val="1400"/>
-              </a:spcAft>
-            </a:pPr>
-            <a:r>
-              <a:rPr sz="2400">
-                <a:solidFill>
-                  <a:srgbClr val="1F2A37"/>
-                </a:solidFill>
-              </a:rPr>
-              <a:t>• A built-in that finds a box on the page by its id.</a:t>
-            </a:r>
-          </a:p>
-          <a:p>
-            <a:pPr>
-              <a:spcAft>
-                <a:spcPts val="1400"/>
-              </a:spcAft>
-            </a:pPr>
-            <a:r>
-              <a:rPr sz="2400">
-                <a:solidFill>
-                  <a:srgbClr val="1F2A37"/>
-                </a:solidFill>
-              </a:rPr>
-              <a:t>• Hands you the box, or null if it is not there.</a:t>
-            </a:r>
-          </a:p>
-        </p:txBody>
-      </p:sp>
-    </p:spTree>
-  </p:cSld>
-  <p:clrMapOvr>
-    <a:masterClrMapping/>
-  </p:clrMapOvr>
-</p:sld>
-</file>
-
-<file path=ppt/slides/slide108.xml><?xml version="1.0" encoding="utf-8"?>
 <p:sld xmlns:a="http://schemas.openxmlformats.org/drawingml/2006/main" xmlns:p="http://schemas.openxmlformats.org/presentationml/2006/main" xmlns:r="http://schemas.openxmlformats.org/officeDocument/2006/relationships">
   <p:cSld>
     <p:bg>
@@ -4852,7 +4588,7 @@
                   <a:srgbClr val="01AEFD"/>
                 </a:solidFill>
               </a:rPr>
-              <a:t>Type this into script.js   -   line 7</a:t>
+              <a:t>Type this into script.js   -   line 6</a:t>
             </a:r>
           </a:p>
         </p:txBody>
@@ -5021,36 +4757,11 @@
             <a:r>
               <a:rPr sz="1800">
                 <a:solidFill>
-                  <a:srgbClr val="6D8C97"/>
+                  <a:srgbClr val="7FE0A0"/>
                 </a:solidFill>
                 <a:latin typeface="Consolas"/>
               </a:rPr>
               <a:t>// because the boxes have not been made yet. That is why it goes last.</a:t>
-            </a:r>
-          </a:p>
-          <a:p>
-            <a:pPr>
-              <a:spcAft>
-                <a:spcPts val="0"/>
-              </a:spcAft>
-            </a:pPr>
-            <a:r>
-              <a:rPr sz="1800">
-                <a:solidFill>
-                  <a:srgbClr val="6D8C97"/>
-                </a:solidFill>
-                <a:latin typeface="Consolas"/>
-              </a:rPr>
-              <a:t>   7  </a:t>
-            </a:r>
-            <a:r>
-              <a:rPr sz="1800">
-                <a:solidFill>
-                  <a:srgbClr val="7FE0A0"/>
-                </a:solidFill>
-                <a:latin typeface="Consolas"/>
-              </a:rPr>
-              <a:t>console.log('Can I see the chat box?', document.getElementById('chat') !== null);</a:t>
             </a:r>
           </a:p>
         </p:txBody>
@@ -5083,7 +4794,137 @@
                   <a:srgbClr val="DCECEF"/>
                 </a:solidFill>
               </a:rPr>
-              <a:t>getElementById looks for the chat box; !== null is true only if it was found. Because the script is at the bottom, it prints true.</a:t>
+              <a:t>The comment's last line: which is why the &lt;script&gt; tag goes at the bottom.</a:t>
+            </a:r>
+          </a:p>
+        </p:txBody>
+      </p:sp>
+    </p:spTree>
+  </p:cSld>
+  <p:clrMapOvr>
+    <a:masterClrMapping/>
+  </p:clrMapOvr>
+</p:sld>
+</file>
+
+<file path=ppt/slides/slide108.xml><?xml version="1.0" encoding="utf-8"?>
+<p:sld xmlns:a="http://schemas.openxmlformats.org/drawingml/2006/main" xmlns:p="http://schemas.openxmlformats.org/presentationml/2006/main" xmlns:r="http://schemas.openxmlformats.org/officeDocument/2006/relationships">
+  <p:cSld>
+    <p:spTree>
+      <p:nvGrpSpPr>
+        <p:cNvPr id="1" name=""/>
+        <p:cNvGrpSpPr/>
+        <p:nvPr/>
+      </p:nvGrpSpPr>
+      <p:grpSpPr/>
+      <p:sp>
+        <p:nvSpPr>
+          <p:cNvPr id="2" name="Title 1"/>
+          <p:cNvSpPr>
+            <a:spLocks noGrp="1"/>
+          </p:cNvSpPr>
+          <p:nvPr>
+            <p:ph type="title"/>
+          </p:nvPr>
+        </p:nvSpPr>
+        <p:spPr/>
+        <p:txBody>
+          <a:bodyPr/>
+          <a:lstStyle/>
+          <a:p>
+            <a:r>
+              <a:rPr sz="3800" b="1">
+                <a:solidFill>
+                  <a:srgbClr val="1F2A37"/>
+                </a:solidFill>
+              </a:rPr>
+              <a:t>document.getElementById()</a:t>
+            </a:r>
+          </a:p>
+        </p:txBody>
+      </p:sp>
+      <p:sp>
+        <p:nvSpPr>
+          <p:cNvPr id="3" name="TextBox 2"/>
+          <p:cNvSpPr txBox="1"/>
+          <p:nvPr/>
+        </p:nvSpPr>
+        <p:spPr>
+          <a:xfrm>
+            <a:off x="868680" y="502920"/>
+            <a:ext cx="5486400" cy="457200"/>
+          </a:xfrm>
+          <a:prstGeom prst="rect">
+            <a:avLst/>
+          </a:prstGeom>
+          <a:noFill/>
+        </p:spPr>
+        <p:txBody>
+          <a:bodyPr wrap="none">
+            <a:spAutoFit/>
+          </a:bodyPr>
+          <a:lstStyle/>
+          <a:p>
+            <a:r>
+              <a:rPr sz="1500" b="1">
+                <a:solidFill>
+                  <a:srgbClr val="01AEFD"/>
+                </a:solidFill>
+              </a:rPr>
+              <a:t>JAVASCRIPT</a:t>
+            </a:r>
+          </a:p>
+        </p:txBody>
+      </p:sp>
+      <p:sp>
+        <p:nvSpPr>
+          <p:cNvPr id="4" name="TextBox 3"/>
+          <p:cNvSpPr txBox="1"/>
+          <p:nvPr/>
+        </p:nvSpPr>
+        <p:spPr>
+          <a:xfrm>
+            <a:off x="822960" y="1828800"/>
+            <a:ext cx="10515600" cy="4206240"/>
+          </a:xfrm>
+          <a:prstGeom prst="rect">
+            <a:avLst/>
+          </a:prstGeom>
+          <a:noFill/>
+        </p:spPr>
+        <p:txBody>
+          <a:bodyPr wrap="square">
+            <a:spAutoFit/>
+          </a:bodyPr>
+          <a:lstStyle/>
+          <a:p>
+            <a:pPr>
+              <a:spcAft>
+                <a:spcPts val="1400"/>
+              </a:spcAft>
+            </a:pPr>
+            <a:r>
+              <a:rPr sz="2400">
+                <a:solidFill>
+                  <a:srgbClr val="1F2A37"/>
+                </a:solidFill>
+              </a:rPr>
+              <a:t>• A built-in that finds a box on the page by its id.</a:t>
+            </a:r>
+          </a:p>
+          <a:p>
+            <a:pPr>
+              <a:spcAft>
+                <a:spcPts val="1400"/>
+              </a:spcAft>
+            </a:pPr>
+            <a:r>
+              <a:rPr sz="2400">
+                <a:solidFill>
+                  <a:srgbClr val="1F2A37"/>
+                </a:solidFill>
+              </a:rPr>
+              <a:t>• Hands you the box, or null if it is not there.</a:t>
             </a:r>
           </a:p>
         </p:txBody>
@@ -5142,7 +4983,7 @@
                   <a:srgbClr val="01AEFD"/>
                 </a:solidFill>
               </a:rPr>
-              <a:t>All together in script.js</a:t>
+              <a:t>Type this into script.js   -   line 7</a:t>
             </a:r>
           </a:p>
         </p:txBody>
@@ -5186,7 +5027,7 @@
             <a:r>
               <a:rPr sz="1800">
                 <a:solidFill>
-                  <a:srgbClr val="7FE0A0"/>
+                  <a:srgbClr val="6D8C97"/>
                 </a:solidFill>
                 <a:latin typeface="Consolas"/>
               </a:rPr>
@@ -5211,7 +5052,7 @@
             <a:r>
               <a:rPr sz="1800">
                 <a:solidFill>
-                  <a:srgbClr val="7FE0A0"/>
+                  <a:srgbClr val="6D8C97"/>
                 </a:solidFill>
                 <a:latin typeface="Consolas"/>
               </a:rPr>
@@ -5236,7 +5077,7 @@
             <a:r>
               <a:rPr sz="1800">
                 <a:solidFill>
-                  <a:srgbClr val="7FE0A0"/>
+                  <a:srgbClr val="6D8C97"/>
                 </a:solidFill>
                 <a:latin typeface="Consolas"/>
               </a:rPr>
@@ -5261,7 +5102,7 @@
             <a:r>
               <a:rPr sz="1800">
                 <a:solidFill>
-                  <a:srgbClr val="7FE0A0"/>
+                  <a:srgbClr val="6D8C97"/>
                 </a:solidFill>
                 <a:latin typeface="Consolas"/>
               </a:rPr>
@@ -5286,7 +5127,7 @@
             <a:r>
               <a:rPr sz="1800">
                 <a:solidFill>
-                  <a:srgbClr val="7FE0A0"/>
+                  <a:srgbClr val="6D8C97"/>
                 </a:solidFill>
                 <a:latin typeface="Consolas"/>
               </a:rPr>
@@ -5311,7 +5152,7 @@
             <a:r>
               <a:rPr sz="1800">
                 <a:solidFill>
-                  <a:srgbClr val="7FE0A0"/>
+                  <a:srgbClr val="6D8C97"/>
                 </a:solidFill>
                 <a:latin typeface="Consolas"/>
               </a:rPr>
@@ -5373,7 +5214,7 @@
                   <a:srgbClr val="DCECEF"/>
                 </a:solidFill>
               </a:rPr>
-              <a:t>That is the whole piece. Check yours looks the same before moving on.</a:t>
+              <a:t>getElementById looks for the chat box; !== null is true only if it was found. Because the script is at the bottom, it prints true.</a:t>
             </a:r>
           </a:p>
         </p:txBody>
@@ -5579,6 +5420,14 @@
 <file path=ppt/slides/slide110.xml><?xml version="1.0" encoding="utf-8"?>
 <p:sld xmlns:a="http://schemas.openxmlformats.org/drawingml/2006/main" xmlns:p="http://schemas.openxmlformats.org/presentationml/2006/main" xmlns:r="http://schemas.openxmlformats.org/officeDocument/2006/relationships">
   <p:cSld>
+    <p:bg>
+      <p:bgPr>
+        <a:solidFill>
+          <a:srgbClr val="102127"/>
+        </a:solidFill>
+        <a:effectLst/>
+      </p:bgPr>
+    </p:bg>
     <p:spTree>
       <p:nvGrpSpPr>
         <p:cNvPr id="1" name=""/>
@@ -5588,26 +5437,33 @@
       <p:grpSpPr/>
       <p:sp>
         <p:nvSpPr>
-          <p:cNvPr id="2" name="Title 1"/>
-          <p:cNvSpPr>
-            <a:spLocks noGrp="1"/>
-          </p:cNvSpPr>
-          <p:nvPr>
-            <p:ph type="title"/>
-          </p:nvPr>
-        </p:nvSpPr>
-        <p:spPr/>
-        <p:txBody>
-          <a:bodyPr/>
-          <a:lstStyle/>
-          <a:p>
-            <a:r>
-              <a:rPr sz="3800" b="1">
-                <a:solidFill>
-                  <a:srgbClr val="1F2A37"/>
-                </a:solidFill>
-              </a:rPr>
-              <a:t>id = a name</a:t>
+          <p:cNvPr id="2" name="TextBox 1"/>
+          <p:cNvSpPr txBox="1"/>
+          <p:nvPr/>
+        </p:nvSpPr>
+        <p:spPr>
+          <a:xfrm>
+            <a:off x="502920" y="274320"/>
+            <a:ext cx="11155680" cy="548640"/>
+          </a:xfrm>
+          <a:prstGeom prst="rect">
+            <a:avLst/>
+          </a:prstGeom>
+          <a:noFill/>
+        </p:spPr>
+        <p:txBody>
+          <a:bodyPr wrap="none">
+            <a:spAutoFit/>
+          </a:bodyPr>
+          <a:lstStyle/>
+          <a:p>
+            <a:r>
+              <a:rPr sz="2200" b="1">
+                <a:solidFill>
+                  <a:srgbClr val="01AEFD"/>
+                </a:solidFill>
+              </a:rPr>
+              <a:t>All together in script.js</a:t>
             </a:r>
           </a:p>
         </p:txBody>
@@ -5620,8 +5476,206 @@
         </p:nvSpPr>
         <p:spPr>
           <a:xfrm>
-            <a:off x="822960" y="1828800"/>
-            <a:ext cx="10515600" cy="4206240"/>
+            <a:off x="502920" y="960120"/>
+            <a:ext cx="11155680" cy="4297680"/>
+          </a:xfrm>
+          <a:prstGeom prst="rect">
+            <a:avLst/>
+          </a:prstGeom>
+          <a:noFill/>
+        </p:spPr>
+        <p:txBody>
+          <a:bodyPr wrap="none">
+            <a:spAutoFit/>
+          </a:bodyPr>
+          <a:lstStyle/>
+          <a:p>
+            <a:pPr>
+              <a:spcAft>
+                <a:spcPts val="0"/>
+              </a:spcAft>
+            </a:pPr>
+            <a:r>
+              <a:rPr sz="1800">
+                <a:solidFill>
+                  <a:srgbClr val="6D8C97"/>
+                </a:solidFill>
+                <a:latin typeface="Consolas"/>
+              </a:rPr>
+              <a:t>   1  </a:t>
+            </a:r>
+            <a:r>
+              <a:rPr sz="1800">
+                <a:solidFill>
+                  <a:srgbClr val="7FE0A0"/>
+                </a:solidFill>
+                <a:latin typeface="Consolas"/>
+              </a:rPr>
+              <a:t>// Week 1: prove the JavaScript file is really running.</a:t>
+            </a:r>
+          </a:p>
+          <a:p>
+            <a:pPr>
+              <a:spcAft>
+                <a:spcPts val="0"/>
+              </a:spcAft>
+            </a:pPr>
+            <a:r>
+              <a:rPr sz="1800">
+                <a:solidFill>
+                  <a:srgbClr val="6D8C97"/>
+                </a:solidFill>
+                <a:latin typeface="Consolas"/>
+              </a:rPr>
+              <a:t>   2  </a:t>
+            </a:r>
+            <a:r>
+              <a:rPr sz="1800">
+                <a:solidFill>
+                  <a:srgbClr val="7FE0A0"/>
+                </a:solidFill>
+                <a:latin typeface="Consolas"/>
+              </a:rPr>
+              <a:t>console.log('My AI companion is starting up.');</a:t>
+            </a:r>
+          </a:p>
+          <a:p>
+            <a:pPr>
+              <a:spcAft>
+                <a:spcPts val="0"/>
+              </a:spcAft>
+            </a:pPr>
+            <a:r>
+              <a:rPr sz="1800">
+                <a:solidFill>
+                  <a:srgbClr val="6D8C97"/>
+                </a:solidFill>
+                <a:latin typeface="Consolas"/>
+              </a:rPr>
+              <a:t>   3  </a:t>
+            </a:r>
+            <a:r>
+              <a:rPr sz="1800">
+                <a:solidFill>
+                  <a:srgbClr val="7FE0A0"/>
+                </a:solidFill>
+                <a:latin typeface="Consolas"/>
+              </a:rPr>
+              <a:t> </a:t>
+            </a:r>
+          </a:p>
+          <a:p>
+            <a:pPr>
+              <a:spcAft>
+                <a:spcPts val="0"/>
+              </a:spcAft>
+            </a:pPr>
+            <a:r>
+              <a:rPr sz="1800">
+                <a:solidFill>
+                  <a:srgbClr val="6D8C97"/>
+                </a:solidFill>
+                <a:latin typeface="Consolas"/>
+              </a:rPr>
+              <a:t>   4  </a:t>
+            </a:r>
+            <a:r>
+              <a:rPr sz="1800">
+                <a:solidFill>
+                  <a:srgbClr val="7FE0A0"/>
+                </a:solidFill>
+                <a:latin typeface="Consolas"/>
+              </a:rPr>
+              <a:t>// Can this script see the page yet? Down here, yes.</a:t>
+            </a:r>
+          </a:p>
+          <a:p>
+            <a:pPr>
+              <a:spcAft>
+                <a:spcPts val="0"/>
+              </a:spcAft>
+            </a:pPr>
+            <a:r>
+              <a:rPr sz="1800">
+                <a:solidFill>
+                  <a:srgbClr val="6D8C97"/>
+                </a:solidFill>
+                <a:latin typeface="Consolas"/>
+              </a:rPr>
+              <a:t>   5  </a:t>
+            </a:r>
+            <a:r>
+              <a:rPr sz="1800">
+                <a:solidFill>
+                  <a:srgbClr val="7FE0A0"/>
+                </a:solidFill>
+                <a:latin typeface="Consolas"/>
+              </a:rPr>
+              <a:t>// Move the &lt;script&gt; tag to the TOP of index.html and this prints false,</a:t>
+            </a:r>
+          </a:p>
+          <a:p>
+            <a:pPr>
+              <a:spcAft>
+                <a:spcPts val="0"/>
+              </a:spcAft>
+            </a:pPr>
+            <a:r>
+              <a:rPr sz="1800">
+                <a:solidFill>
+                  <a:srgbClr val="6D8C97"/>
+                </a:solidFill>
+                <a:latin typeface="Consolas"/>
+              </a:rPr>
+              <a:t>   6  </a:t>
+            </a:r>
+            <a:r>
+              <a:rPr sz="1800">
+                <a:solidFill>
+                  <a:srgbClr val="7FE0A0"/>
+                </a:solidFill>
+                <a:latin typeface="Consolas"/>
+              </a:rPr>
+              <a:t>// because the boxes have not been made yet. That is why it goes last.</a:t>
+            </a:r>
+          </a:p>
+          <a:p>
+            <a:pPr>
+              <a:spcAft>
+                <a:spcPts val="0"/>
+              </a:spcAft>
+            </a:pPr>
+            <a:r>
+              <a:rPr sz="1800">
+                <a:solidFill>
+                  <a:srgbClr val="6D8C97"/>
+                </a:solidFill>
+                <a:latin typeface="Consolas"/>
+              </a:rPr>
+              <a:t>   7  </a:t>
+            </a:r>
+            <a:r>
+              <a:rPr sz="1800">
+                <a:solidFill>
+                  <a:srgbClr val="7FE0A0"/>
+                </a:solidFill>
+                <a:latin typeface="Consolas"/>
+              </a:rPr>
+              <a:t>console.log('Can I see the chat box?', document.getElementById('chat') !== null);</a:t>
+            </a:r>
+          </a:p>
+        </p:txBody>
+      </p:sp>
+      <p:sp>
+        <p:nvSpPr>
+          <p:cNvPr id="4" name="TextBox 3"/>
+          <p:cNvSpPr txBox="1"/>
+          <p:nvPr/>
+        </p:nvSpPr>
+        <p:spPr>
+          <a:xfrm>
+            <a:off x="548640" y="5623560"/>
+            <a:ext cx="11064240" cy="1051560"/>
           </a:xfrm>
           <a:prstGeom prst="rect">
             <a:avLst/>
@@ -5634,48 +5688,13 @@
           </a:bodyPr>
           <a:lstStyle/>
           <a:p>
-            <a:pPr>
-              <a:spcAft>
-                <a:spcPts val="1400"/>
-              </a:spcAft>
-            </a:pPr>
-            <a:r>
-              <a:rPr sz="2400">
-                <a:solidFill>
-                  <a:srgbClr val="1F2A37"/>
-                </a:solidFill>
-              </a:rPr>
-              <a:t>• &lt;div id="chat"&gt;</a:t>
-            </a:r>
-          </a:p>
-          <a:p>
-            <a:pPr>
-              <a:spcAft>
-                <a:spcPts val="1400"/>
-              </a:spcAft>
-            </a:pPr>
-            <a:r>
-              <a:rPr sz="2400">
-                <a:solidFill>
-                  <a:srgbClr val="1F2A37"/>
-                </a:solidFill>
-              </a:rPr>
-              <a:t>• Next week JavaScript uses that name to find the box</a:t>
-            </a:r>
-          </a:p>
-          <a:p>
-            <a:pPr>
-              <a:spcAft>
-                <a:spcPts val="1400"/>
-              </a:spcAft>
-            </a:pPr>
-            <a:r>
-              <a:rPr sz="2400">
-                <a:solidFill>
-                  <a:srgbClr val="1F2A37"/>
-                </a:solidFill>
-              </a:rPr>
-              <a:t>• Names must be spelled exactly the same in both files</a:t>
+            <a:r>
+              <a:rPr sz="2000">
+                <a:solidFill>
+                  <a:srgbClr val="DCECEF"/>
+                </a:solidFill>
+              </a:rPr>
+              <a:t>That is the whole piece. Check yours looks the same before moving on.</a:t>
             </a:r>
           </a:p>
         </p:txBody>
@@ -5719,7 +5738,7 @@
                   <a:srgbClr val="1F2A37"/>
                 </a:solidFill>
               </a:rPr>
-              <a:t>Checkpoint: your page</a:t>
+              <a:t>id = a name</a:t>
             </a:r>
           </a:p>
         </p:txBody>
@@ -5727,39 +5746,6 @@
       <p:sp>
         <p:nvSpPr>
           <p:cNvPr id="3" name="TextBox 2"/>
-          <p:cNvSpPr txBox="1"/>
-          <p:nvPr/>
-        </p:nvSpPr>
-        <p:spPr>
-          <a:xfrm>
-            <a:off x="868680" y="502920"/>
-            <a:ext cx="5486400" cy="457200"/>
-          </a:xfrm>
-          <a:prstGeom prst="rect">
-            <a:avLst/>
-          </a:prstGeom>
-          <a:noFill/>
-        </p:spPr>
-        <p:txBody>
-          <a:bodyPr wrap="none">
-            <a:spAutoFit/>
-          </a:bodyPr>
-          <a:lstStyle/>
-          <a:p>
-            <a:r>
-              <a:rPr sz="1500" b="1">
-                <a:solidFill>
-                  <a:srgbClr val="01AEFD"/>
-                </a:solidFill>
-              </a:rPr>
-              <a:t>CHECKPOINT - RUN IT</a:t>
-            </a:r>
-          </a:p>
-        </p:txBody>
-      </p:sp>
-      <p:sp>
-        <p:nvSpPr>
-          <p:cNvPr id="4" name="TextBox 3"/>
           <p:cNvSpPr txBox="1"/>
           <p:nvPr/>
         </p:nvSpPr>
@@ -5785,12 +5771,12 @@
               </a:spcAft>
             </a:pPr>
             <a:r>
-              <a:rPr sz="2800">
-                <a:solidFill>
-                  <a:srgbClr val="01AEFD"/>
-                </a:solidFill>
-              </a:rPr>
-              <a:t>Press Run. You should see the title, an empty white chat box, and a text box with a blue Send button - all styled. Clicking Send does nothing yet; that is next week.</a:t>
+              <a:rPr sz="2400">
+                <a:solidFill>
+                  <a:srgbClr val="1F2A37"/>
+                </a:solidFill>
+              </a:rPr>
+              <a:t>• &lt;div id="chat"&gt;</a:t>
             </a:r>
           </a:p>
           <a:p>
@@ -5805,7 +5791,7 @@
                   <a:srgbClr val="1F2A37"/>
                 </a:solidFill>
               </a:rPr>
-              <a:t>• Run it in the classroom, or press Show the output in the web deck.</a:t>
+              <a:t>• Next week JavaScript uses that name to find the box</a:t>
             </a:r>
           </a:p>
           <a:p>
@@ -5820,7 +5806,7 @@
                   <a:srgbClr val="1F2A37"/>
                 </a:solidFill>
               </a:rPr>
-              <a:t>• Everyone's screen should match this.</a:t>
+              <a:t>• Names must be spelled exactly the same in both files</a:t>
             </a:r>
           </a:p>
         </p:txBody>
@@ -5834,6 +5820,151 @@
 </file>
 
 <file path=ppt/slides/slide112.xml><?xml version="1.0" encoding="utf-8"?>
+<p:sld xmlns:a="http://schemas.openxmlformats.org/drawingml/2006/main" xmlns:p="http://schemas.openxmlformats.org/presentationml/2006/main" xmlns:r="http://schemas.openxmlformats.org/officeDocument/2006/relationships">
+  <p:cSld>
+    <p:spTree>
+      <p:nvGrpSpPr>
+        <p:cNvPr id="1" name=""/>
+        <p:cNvGrpSpPr/>
+        <p:nvPr/>
+      </p:nvGrpSpPr>
+      <p:grpSpPr/>
+      <p:sp>
+        <p:nvSpPr>
+          <p:cNvPr id="2" name="Title 1"/>
+          <p:cNvSpPr>
+            <a:spLocks noGrp="1"/>
+          </p:cNvSpPr>
+          <p:nvPr>
+            <p:ph type="title"/>
+          </p:nvPr>
+        </p:nvSpPr>
+        <p:spPr/>
+        <p:txBody>
+          <a:bodyPr/>
+          <a:lstStyle/>
+          <a:p>
+            <a:r>
+              <a:rPr sz="3800" b="1">
+                <a:solidFill>
+                  <a:srgbClr val="1F2A37"/>
+                </a:solidFill>
+              </a:rPr>
+              <a:t>Checkpoint: your page</a:t>
+            </a:r>
+          </a:p>
+        </p:txBody>
+      </p:sp>
+      <p:sp>
+        <p:nvSpPr>
+          <p:cNvPr id="3" name="TextBox 2"/>
+          <p:cNvSpPr txBox="1"/>
+          <p:nvPr/>
+        </p:nvSpPr>
+        <p:spPr>
+          <a:xfrm>
+            <a:off x="868680" y="502920"/>
+            <a:ext cx="5486400" cy="457200"/>
+          </a:xfrm>
+          <a:prstGeom prst="rect">
+            <a:avLst/>
+          </a:prstGeom>
+          <a:noFill/>
+        </p:spPr>
+        <p:txBody>
+          <a:bodyPr wrap="none">
+            <a:spAutoFit/>
+          </a:bodyPr>
+          <a:lstStyle/>
+          <a:p>
+            <a:r>
+              <a:rPr sz="1500" b="1">
+                <a:solidFill>
+                  <a:srgbClr val="01AEFD"/>
+                </a:solidFill>
+              </a:rPr>
+              <a:t>CHECKPOINT - RUN IT</a:t>
+            </a:r>
+          </a:p>
+        </p:txBody>
+      </p:sp>
+      <p:sp>
+        <p:nvSpPr>
+          <p:cNvPr id="4" name="TextBox 3"/>
+          <p:cNvSpPr txBox="1"/>
+          <p:nvPr/>
+        </p:nvSpPr>
+        <p:spPr>
+          <a:xfrm>
+            <a:off x="822960" y="1828800"/>
+            <a:ext cx="10515600" cy="4206240"/>
+          </a:xfrm>
+          <a:prstGeom prst="rect">
+            <a:avLst/>
+          </a:prstGeom>
+          <a:noFill/>
+        </p:spPr>
+        <p:txBody>
+          <a:bodyPr wrap="square">
+            <a:spAutoFit/>
+          </a:bodyPr>
+          <a:lstStyle/>
+          <a:p>
+            <a:pPr>
+              <a:spcAft>
+                <a:spcPts val="1400"/>
+              </a:spcAft>
+            </a:pPr>
+            <a:r>
+              <a:rPr sz="2800">
+                <a:solidFill>
+                  <a:srgbClr val="01AEFD"/>
+                </a:solidFill>
+              </a:rPr>
+              <a:t>Press Run. You should see the title, an empty white chat box, and a text box with a blue Send button - all styled. Clicking Send does nothing yet; that is next week.</a:t>
+            </a:r>
+          </a:p>
+          <a:p>
+            <a:pPr>
+              <a:spcAft>
+                <a:spcPts val="1400"/>
+              </a:spcAft>
+            </a:pPr>
+            <a:r>
+              <a:rPr sz="2400">
+                <a:solidFill>
+                  <a:srgbClr val="1F2A37"/>
+                </a:solidFill>
+              </a:rPr>
+              <a:t>• Run it in the classroom, or press Show the output in the web deck.</a:t>
+            </a:r>
+          </a:p>
+          <a:p>
+            <a:pPr>
+              <a:spcAft>
+                <a:spcPts val="1400"/>
+              </a:spcAft>
+            </a:pPr>
+            <a:r>
+              <a:rPr sz="2400">
+                <a:solidFill>
+                  <a:srgbClr val="1F2A37"/>
+                </a:solidFill>
+              </a:rPr>
+              <a:t>• Everyone's screen should match this.</a:t>
+            </a:r>
+          </a:p>
+        </p:txBody>
+      </p:sp>
+    </p:spTree>
+  </p:cSld>
+  <p:clrMapOvr>
+    <a:masterClrMapping/>
+  </p:clrMapOvr>
+</p:sld>
+</file>
+
+<file path=ppt/slides/slide113.xml><?xml version="1.0" encoding="utf-8"?>
 <p:sld xmlns:a="http://schemas.openxmlformats.org/drawingml/2006/main" xmlns:p="http://schemas.openxmlformats.org/presentationml/2006/main" xmlns:r="http://schemas.openxmlformats.org/officeDocument/2006/relationships">
   <p:cSld>
     <p:spTree>
@@ -18336,14 +18467,6 @@
 <file path=ppt/slides/slide72.xml><?xml version="1.0" encoding="utf-8"?>
 <p:sld xmlns:a="http://schemas.openxmlformats.org/drawingml/2006/main" xmlns:p="http://schemas.openxmlformats.org/presentationml/2006/main" xmlns:r="http://schemas.openxmlformats.org/officeDocument/2006/relationships">
   <p:cSld>
-    <p:bg>
-      <p:bgPr>
-        <a:solidFill>
-          <a:srgbClr val="102127"/>
-        </a:solidFill>
-        <a:effectLst/>
-      </p:bgPr>
-    </p:bg>
     <p:spTree>
       <p:nvGrpSpPr>
         <p:cNvPr id="1" name=""/>
@@ -18353,14 +18476,40 @@
       <p:grpSpPr/>
       <p:sp>
         <p:nvSpPr>
-          <p:cNvPr id="2" name="TextBox 1"/>
-          <p:cNvSpPr txBox="1"/>
-          <p:nvPr/>
-        </p:nvSpPr>
-        <p:spPr>
-          <a:xfrm>
-            <a:off x="502920" y="274320"/>
-            <a:ext cx="11155680" cy="548640"/>
+          <p:cNvPr id="2" name="Title 1"/>
+          <p:cNvSpPr>
+            <a:spLocks noGrp="1"/>
+          </p:cNvSpPr>
+          <p:nvPr>
+            <p:ph type="title"/>
+          </p:nvPr>
+        </p:nvSpPr>
+        <p:spPr/>
+        <p:txBody>
+          <a:bodyPr/>
+          <a:lstStyle/>
+          <a:p>
+            <a:r>
+              <a:rPr sz="3800" b="1">
+                <a:solidFill>
+                  <a:srgbClr val="1F2A37"/>
+                </a:solidFill>
+              </a:rPr>
+              <a:t>margin-top</a:t>
+            </a:r>
+          </a:p>
+        </p:txBody>
+      </p:sp>
+      <p:sp>
+        <p:nvSpPr>
+          <p:cNvPr id="3" name="TextBox 2"/>
+          <p:cNvSpPr txBox="1"/>
+          <p:nvPr/>
+        </p:nvSpPr>
+        <p:spPr>
+          <a:xfrm>
+            <a:off x="868680" y="502920"/>
+            <a:ext cx="5486400" cy="457200"/>
           </a:xfrm>
           <a:prstGeom prst="rect">
             <a:avLst/>
@@ -18374,60 +18523,12 @@
           <a:lstStyle/>
           <a:p>
             <a:r>
-              <a:rPr sz="2200" b="1">
+              <a:rPr sz="1500" b="1">
                 <a:solidFill>
                   <a:srgbClr val="01AEFD"/>
                 </a:solidFill>
               </a:rPr>
-              <a:t>Type this into style.css   -   line 21</a:t>
-            </a:r>
-          </a:p>
-        </p:txBody>
-      </p:sp>
-      <p:sp>
-        <p:nvSpPr>
-          <p:cNvPr id="3" name="TextBox 2"/>
-          <p:cNvSpPr txBox="1"/>
-          <p:nvPr/>
-        </p:nvSpPr>
-        <p:spPr>
-          <a:xfrm>
-            <a:off x="502920" y="960120"/>
-            <a:ext cx="11155680" cy="4297680"/>
-          </a:xfrm>
-          <a:prstGeom prst="rect">
-            <a:avLst/>
-          </a:prstGeom>
-          <a:noFill/>
-        </p:spPr>
-        <p:txBody>
-          <a:bodyPr wrap="none">
-            <a:spAutoFit/>
-          </a:bodyPr>
-          <a:lstStyle/>
-          <a:p>
-            <a:pPr>
-              <a:spcAft>
-                <a:spcPts val="0"/>
-              </a:spcAft>
-            </a:pPr>
-            <a:r>
-              <a:rPr sz="1800">
-                <a:solidFill>
-                  <a:srgbClr val="6D8C97"/>
-                </a:solidFill>
-                <a:latin typeface="Consolas"/>
-              </a:rPr>
-              <a:t>  21  </a:t>
-            </a:r>
-            <a:r>
-              <a:rPr sz="1800">
-                <a:solidFill>
-                  <a:srgbClr val="7FE0A0"/>
-                </a:solidFill>
-                <a:latin typeface="Consolas"/>
-              </a:rPr>
-              <a:t>.composer { display: flex; gap: 8px; margin-top: 12px; }</a:t>
+              <a:t>CSS</a:t>
             </a:r>
           </a:p>
         </p:txBody>
@@ -18440,8 +18541,8 @@
         </p:nvSpPr>
         <p:spPr>
           <a:xfrm>
-            <a:off x="548640" y="5623560"/>
-            <a:ext cx="11064240" cy="1051560"/>
+            <a:off x="822960" y="1828800"/>
+            <a:ext cx="10515600" cy="4206240"/>
           </a:xfrm>
           <a:prstGeom prst="rect">
             <a:avLst/>
@@ -18454,13 +18555,18 @@
           </a:bodyPr>
           <a:lstStyle/>
           <a:p>
-            <a:r>
-              <a:rPr sz="2000">
-                <a:solidFill>
-                  <a:srgbClr val="DCECEF"/>
-                </a:solidFill>
-              </a:rPr>
-              <a:t>Lays the form's children in a row with a small gap and a little space above. display: flex is the key part.</a:t>
+            <a:pPr>
+              <a:spcAft>
+                <a:spcPts val="1400"/>
+              </a:spcAft>
+            </a:pPr>
+            <a:r>
+              <a:rPr sz="2400">
+                <a:solidFill>
+                  <a:srgbClr val="1F2A37"/>
+                </a:solidFill>
+              </a:rPr>
+              <a:t>• Space above the box, pushing it down from what is above it.</a:t>
             </a:r>
           </a:p>
         </p:txBody>
@@ -18519,7 +18625,7 @@
                   <a:srgbClr val="01AEFD"/>
                 </a:solidFill>
               </a:rPr>
-              <a:t>Type this into style.css   -   line 22</a:t>
+              <a:t>Type this into style.css   -   line 21</a:t>
             </a:r>
           </a:p>
         </p:txBody>
@@ -18563,36 +18669,11 @@
             <a:r>
               <a:rPr sz="1800">
                 <a:solidFill>
-                  <a:srgbClr val="6D8C97"/>
+                  <a:srgbClr val="7FE0A0"/>
                 </a:solidFill>
                 <a:latin typeface="Consolas"/>
               </a:rPr>
               <a:t>.composer { display: flex; gap: 8px; margin-top: 12px; }</a:t>
-            </a:r>
-          </a:p>
-          <a:p>
-            <a:pPr>
-              <a:spcAft>
-                <a:spcPts val="0"/>
-              </a:spcAft>
-            </a:pPr>
-            <a:r>
-              <a:rPr sz="1800">
-                <a:solidFill>
-                  <a:srgbClr val="6D8C97"/>
-                </a:solidFill>
-                <a:latin typeface="Consolas"/>
-              </a:rPr>
-              <a:t>  22  </a:t>
-            </a:r>
-            <a:r>
-              <a:rPr sz="1800">
-                <a:solidFill>
-                  <a:srgbClr val="7FE0A0"/>
-                </a:solidFill>
-                <a:latin typeface="Consolas"/>
-              </a:rPr>
-              <a:t>.composer input {</a:t>
             </a:r>
           </a:p>
         </p:txBody>
@@ -18625,7 +18706,7 @@
                   <a:srgbClr val="DCECEF"/>
                 </a:solidFill>
               </a:rPr>
-              <a:t>Starts a rule for the input inside .composer.</a:t>
+              <a:t>Lays the form's children in a row with a small gap and a little space above. display: flex is the key part.</a:t>
             </a:r>
           </a:p>
         </p:txBody>
@@ -18639,136 +18720,6 @@
 </file>
 
 <file path=ppt/slides/slide74.xml><?xml version="1.0" encoding="utf-8"?>
-<p:sld xmlns:a="http://schemas.openxmlformats.org/drawingml/2006/main" xmlns:p="http://schemas.openxmlformats.org/presentationml/2006/main" xmlns:r="http://schemas.openxmlformats.org/officeDocument/2006/relationships">
-  <p:cSld>
-    <p:spTree>
-      <p:nvGrpSpPr>
-        <p:cNvPr id="1" name=""/>
-        <p:cNvGrpSpPr/>
-        <p:nvPr/>
-      </p:nvGrpSpPr>
-      <p:grpSpPr/>
-      <p:sp>
-        <p:nvSpPr>
-          <p:cNvPr id="2" name="Title 1"/>
-          <p:cNvSpPr>
-            <a:spLocks noGrp="1"/>
-          </p:cNvSpPr>
-          <p:nvPr>
-            <p:ph type="title"/>
-          </p:nvPr>
-        </p:nvSpPr>
-        <p:spPr/>
-        <p:txBody>
-          <a:bodyPr/>
-          <a:lstStyle/>
-          <a:p>
-            <a:r>
-              <a:rPr sz="3800" b="1">
-                <a:solidFill>
-                  <a:srgbClr val="1F2A37"/>
-                </a:solidFill>
-              </a:rPr>
-              <a:t>flex: 1</a:t>
-            </a:r>
-          </a:p>
-        </p:txBody>
-      </p:sp>
-      <p:sp>
-        <p:nvSpPr>
-          <p:cNvPr id="3" name="TextBox 2"/>
-          <p:cNvSpPr txBox="1"/>
-          <p:nvPr/>
-        </p:nvSpPr>
-        <p:spPr>
-          <a:xfrm>
-            <a:off x="868680" y="502920"/>
-            <a:ext cx="5486400" cy="457200"/>
-          </a:xfrm>
-          <a:prstGeom prst="rect">
-            <a:avLst/>
-          </a:prstGeom>
-          <a:noFill/>
-        </p:spPr>
-        <p:txBody>
-          <a:bodyPr wrap="none">
-            <a:spAutoFit/>
-          </a:bodyPr>
-          <a:lstStyle/>
-          <a:p>
-            <a:r>
-              <a:rPr sz="1500" b="1">
-                <a:solidFill>
-                  <a:srgbClr val="01AEFD"/>
-                </a:solidFill>
-              </a:rPr>
-              <a:t>CSS</a:t>
-            </a:r>
-          </a:p>
-        </p:txBody>
-      </p:sp>
-      <p:sp>
-        <p:nvSpPr>
-          <p:cNvPr id="4" name="TextBox 3"/>
-          <p:cNvSpPr txBox="1"/>
-          <p:nvPr/>
-        </p:nvSpPr>
-        <p:spPr>
-          <a:xfrm>
-            <a:off x="822960" y="1828800"/>
-            <a:ext cx="10515600" cy="4206240"/>
-          </a:xfrm>
-          <a:prstGeom prst="rect">
-            <a:avLst/>
-          </a:prstGeom>
-          <a:noFill/>
-        </p:spPr>
-        <p:txBody>
-          <a:bodyPr wrap="square">
-            <a:spAutoFit/>
-          </a:bodyPr>
-          <a:lstStyle/>
-          <a:p>
-            <a:pPr>
-              <a:spcAft>
-                <a:spcPts val="1400"/>
-              </a:spcAft>
-            </a:pPr>
-            <a:r>
-              <a:rPr sz="2400">
-                <a:solidFill>
-                  <a:srgbClr val="1F2A37"/>
-                </a:solidFill>
-              </a:rPr>
-              <a:t>• Tells one flex child to stretch and fill the leftover space.</a:t>
-            </a:r>
-          </a:p>
-          <a:p>
-            <a:pPr>
-              <a:spcAft>
-                <a:spcPts val="1400"/>
-              </a:spcAft>
-            </a:pPr>
-            <a:r>
-              <a:rPr sz="2400">
-                <a:solidFill>
-                  <a:srgbClr val="1F2A37"/>
-                </a:solidFill>
-              </a:rPr>
-              <a:t>• The text box grows; the button stays its own size.</a:t>
-            </a:r>
-          </a:p>
-        </p:txBody>
-      </p:sp>
-    </p:spTree>
-  </p:cSld>
-  <p:clrMapOvr>
-    <a:masterClrMapping/>
-  </p:clrMapOvr>
-</p:sld>
-</file>
-
-<file path=ppt/slides/slide75.xml><?xml version="1.0" encoding="utf-8"?>
 <p:sld xmlns:a="http://schemas.openxmlformats.org/drawingml/2006/main" xmlns:p="http://schemas.openxmlformats.org/presentationml/2006/main" xmlns:r="http://schemas.openxmlformats.org/officeDocument/2006/relationships">
   <p:cSld>
     <p:bg>
@@ -18814,7 +18765,7 @@
                   <a:srgbClr val="01AEFD"/>
                 </a:solidFill>
               </a:rPr>
-              <a:t>Type this into style.css   -   line 23</a:t>
+              <a:t>Type this into style.css   -   line 22</a:t>
             </a:r>
           </a:p>
         </p:txBody>
@@ -18883,36 +18834,11 @@
             <a:r>
               <a:rPr sz="1800">
                 <a:solidFill>
-                  <a:srgbClr val="6D8C97"/>
+                  <a:srgbClr val="7FE0A0"/>
                 </a:solidFill>
                 <a:latin typeface="Consolas"/>
               </a:rPr>
               <a:t>.composer input {</a:t>
-            </a:r>
-          </a:p>
-          <a:p>
-            <a:pPr>
-              <a:spcAft>
-                <a:spcPts val="0"/>
-              </a:spcAft>
-            </a:pPr>
-            <a:r>
-              <a:rPr sz="1800">
-                <a:solidFill>
-                  <a:srgbClr val="6D8C97"/>
-                </a:solidFill>
-                <a:latin typeface="Consolas"/>
-              </a:rPr>
-              <a:t>  23  </a:t>
-            </a:r>
-            <a:r>
-              <a:rPr sz="1800">
-                <a:solidFill>
-                  <a:srgbClr val="7FE0A0"/>
-                </a:solidFill>
-                <a:latin typeface="Consolas"/>
-              </a:rPr>
-              <a:t>  flex: 1;</a:t>
             </a:r>
           </a:p>
         </p:txBody>
@@ -18945,7 +18871,137 @@
                   <a:srgbClr val="DCECEF"/>
                 </a:solidFill>
               </a:rPr>
-              <a:t>flex: 1 makes the text box stretch to fill the space the button leaves.</a:t>
+              <a:t>Starts a rule for the input inside .composer.</a:t>
+            </a:r>
+          </a:p>
+        </p:txBody>
+      </p:sp>
+    </p:spTree>
+  </p:cSld>
+  <p:clrMapOvr>
+    <a:masterClrMapping/>
+  </p:clrMapOvr>
+</p:sld>
+</file>
+
+<file path=ppt/slides/slide75.xml><?xml version="1.0" encoding="utf-8"?>
+<p:sld xmlns:a="http://schemas.openxmlformats.org/drawingml/2006/main" xmlns:p="http://schemas.openxmlformats.org/presentationml/2006/main" xmlns:r="http://schemas.openxmlformats.org/officeDocument/2006/relationships">
+  <p:cSld>
+    <p:spTree>
+      <p:nvGrpSpPr>
+        <p:cNvPr id="1" name=""/>
+        <p:cNvGrpSpPr/>
+        <p:nvPr/>
+      </p:nvGrpSpPr>
+      <p:grpSpPr/>
+      <p:sp>
+        <p:nvSpPr>
+          <p:cNvPr id="2" name="Title 1"/>
+          <p:cNvSpPr>
+            <a:spLocks noGrp="1"/>
+          </p:cNvSpPr>
+          <p:nvPr>
+            <p:ph type="title"/>
+          </p:nvPr>
+        </p:nvSpPr>
+        <p:spPr/>
+        <p:txBody>
+          <a:bodyPr/>
+          <a:lstStyle/>
+          <a:p>
+            <a:r>
+              <a:rPr sz="3800" b="1">
+                <a:solidFill>
+                  <a:srgbClr val="1F2A37"/>
+                </a:solidFill>
+              </a:rPr>
+              <a:t>flex: 1</a:t>
+            </a:r>
+          </a:p>
+        </p:txBody>
+      </p:sp>
+      <p:sp>
+        <p:nvSpPr>
+          <p:cNvPr id="3" name="TextBox 2"/>
+          <p:cNvSpPr txBox="1"/>
+          <p:nvPr/>
+        </p:nvSpPr>
+        <p:spPr>
+          <a:xfrm>
+            <a:off x="868680" y="502920"/>
+            <a:ext cx="5486400" cy="457200"/>
+          </a:xfrm>
+          <a:prstGeom prst="rect">
+            <a:avLst/>
+          </a:prstGeom>
+          <a:noFill/>
+        </p:spPr>
+        <p:txBody>
+          <a:bodyPr wrap="none">
+            <a:spAutoFit/>
+          </a:bodyPr>
+          <a:lstStyle/>
+          <a:p>
+            <a:r>
+              <a:rPr sz="1500" b="1">
+                <a:solidFill>
+                  <a:srgbClr val="01AEFD"/>
+                </a:solidFill>
+              </a:rPr>
+              <a:t>CSS</a:t>
+            </a:r>
+          </a:p>
+        </p:txBody>
+      </p:sp>
+      <p:sp>
+        <p:nvSpPr>
+          <p:cNvPr id="4" name="TextBox 3"/>
+          <p:cNvSpPr txBox="1"/>
+          <p:nvPr/>
+        </p:nvSpPr>
+        <p:spPr>
+          <a:xfrm>
+            <a:off x="822960" y="1828800"/>
+            <a:ext cx="10515600" cy="4206240"/>
+          </a:xfrm>
+          <a:prstGeom prst="rect">
+            <a:avLst/>
+          </a:prstGeom>
+          <a:noFill/>
+        </p:spPr>
+        <p:txBody>
+          <a:bodyPr wrap="square">
+            <a:spAutoFit/>
+          </a:bodyPr>
+          <a:lstStyle/>
+          <a:p>
+            <a:pPr>
+              <a:spcAft>
+                <a:spcPts val="1400"/>
+              </a:spcAft>
+            </a:pPr>
+            <a:r>
+              <a:rPr sz="2400">
+                <a:solidFill>
+                  <a:srgbClr val="1F2A37"/>
+                </a:solidFill>
+              </a:rPr>
+              <a:t>• Tells one flex child to stretch and fill the leftover space.</a:t>
+            </a:r>
+          </a:p>
+          <a:p>
+            <a:pPr>
+              <a:spcAft>
+                <a:spcPts val="1400"/>
+              </a:spcAft>
+            </a:pPr>
+            <a:r>
+              <a:rPr sz="2400">
+                <a:solidFill>
+                  <a:srgbClr val="1F2A37"/>
+                </a:solidFill>
+              </a:rPr>
+              <a:t>• The text box grows; the button stays its own size.</a:t>
             </a:r>
           </a:p>
         </p:txBody>
@@ -19004,7 +19060,7 @@
                   <a:srgbClr val="01AEFD"/>
                 </a:solidFill>
               </a:rPr>
-              <a:t>Type this into style.css   -   line 24</a:t>
+              <a:t>Type this into style.css   -   line 23</a:t>
             </a:r>
           </a:p>
         </p:txBody>
@@ -19098,36 +19154,11 @@
             <a:r>
               <a:rPr sz="1800">
                 <a:solidFill>
-                  <a:srgbClr val="6D8C97"/>
+                  <a:srgbClr val="7FE0A0"/>
                 </a:solidFill>
                 <a:latin typeface="Consolas"/>
               </a:rPr>
               <a:t>  flex: 1;</a:t>
-            </a:r>
-          </a:p>
-          <a:p>
-            <a:pPr>
-              <a:spcAft>
-                <a:spcPts val="0"/>
-              </a:spcAft>
-            </a:pPr>
-            <a:r>
-              <a:rPr sz="1800">
-                <a:solidFill>
-                  <a:srgbClr val="6D8C97"/>
-                </a:solidFill>
-                <a:latin typeface="Consolas"/>
-              </a:rPr>
-              <a:t>  24  </a:t>
-            </a:r>
-            <a:r>
-              <a:rPr sz="1800">
-                <a:solidFill>
-                  <a:srgbClr val="7FE0A0"/>
-                </a:solidFill>
-                <a:latin typeface="Consolas"/>
-              </a:rPr>
-              <a:t>  padding: 11px;</a:t>
             </a:r>
           </a:p>
         </p:txBody>
@@ -19160,7 +19191,7 @@
                   <a:srgbClr val="DCECEF"/>
                 </a:solidFill>
               </a:rPr>
-              <a:t>Space inside the text box.</a:t>
+              <a:t>flex: 1 makes the text box stretch to fill the space the button leaves.</a:t>
             </a:r>
           </a:p>
         </p:txBody>
@@ -19219,7 +19250,7 @@
                   <a:srgbClr val="01AEFD"/>
                 </a:solidFill>
               </a:rPr>
-              <a:t>Type this into style.css   -   line 25</a:t>
+              <a:t>Type this into style.css   -   line 24</a:t>
             </a:r>
           </a:p>
         </p:txBody>
@@ -19338,36 +19369,11 @@
             <a:r>
               <a:rPr sz="1800">
                 <a:solidFill>
-                  <a:srgbClr val="6D8C97"/>
+                  <a:srgbClr val="7FE0A0"/>
                 </a:solidFill>
                 <a:latin typeface="Consolas"/>
               </a:rPr>
               <a:t>  padding: 11px;</a:t>
-            </a:r>
-          </a:p>
-          <a:p>
-            <a:pPr>
-              <a:spcAft>
-                <a:spcPts val="0"/>
-              </a:spcAft>
-            </a:pPr>
-            <a:r>
-              <a:rPr sz="1800">
-                <a:solidFill>
-                  <a:srgbClr val="6D8C97"/>
-                </a:solidFill>
-                <a:latin typeface="Consolas"/>
-              </a:rPr>
-              <a:t>  25  </a:t>
-            </a:r>
-            <a:r>
-              <a:rPr sz="1800">
-                <a:solidFill>
-                  <a:srgbClr val="7FE0A0"/>
-                </a:solidFill>
-                <a:latin typeface="Consolas"/>
-              </a:rPr>
-              <a:t>  border: 1px solid #dbe3ec;</a:t>
             </a:r>
           </a:p>
         </p:txBody>
@@ -19400,7 +19406,7 @@
                   <a:srgbClr val="DCECEF"/>
                 </a:solidFill>
               </a:rPr>
-              <a:t>A thin grey border to match the chat box.</a:t>
+              <a:t>Space inside the text box.</a:t>
             </a:r>
           </a:p>
         </p:txBody>
@@ -19459,7 +19465,7 @@
                   <a:srgbClr val="01AEFD"/>
                 </a:solidFill>
               </a:rPr>
-              <a:t>Type this into style.css   -   line 26</a:t>
+              <a:t>Type this into style.css   -   line 25</a:t>
             </a:r>
           </a:p>
         </p:txBody>
@@ -19603,36 +19609,11 @@
             <a:r>
               <a:rPr sz="1800">
                 <a:solidFill>
-                  <a:srgbClr val="6D8C97"/>
+                  <a:srgbClr val="7FE0A0"/>
                 </a:solidFill>
                 <a:latin typeface="Consolas"/>
               </a:rPr>
               <a:t>  border: 1px solid #dbe3ec;</a:t>
-            </a:r>
-          </a:p>
-          <a:p>
-            <a:pPr>
-              <a:spcAft>
-                <a:spcPts val="0"/>
-              </a:spcAft>
-            </a:pPr>
-            <a:r>
-              <a:rPr sz="1800">
-                <a:solidFill>
-                  <a:srgbClr val="6D8C97"/>
-                </a:solidFill>
-                <a:latin typeface="Consolas"/>
-              </a:rPr>
-              <a:t>  26  </a:t>
-            </a:r>
-            <a:r>
-              <a:rPr sz="1800">
-                <a:solidFill>
-                  <a:srgbClr val="7FE0A0"/>
-                </a:solidFill>
-                <a:latin typeface="Consolas"/>
-              </a:rPr>
-              <a:t>  border-radius: 6px;</a:t>
             </a:r>
           </a:p>
         </p:txBody>
@@ -19665,7 +19646,7 @@
                   <a:srgbClr val="DCECEF"/>
                 </a:solidFill>
               </a:rPr>
-              <a:t>Rounded corners.</a:t>
+              <a:t>A thin grey border to match the chat box.</a:t>
             </a:r>
           </a:p>
         </p:txBody>
@@ -19724,7 +19705,7 @@
                   <a:srgbClr val="01AEFD"/>
                 </a:solidFill>
               </a:rPr>
-              <a:t>Type this into style.css   -   line 27</a:t>
+              <a:t>Type this into style.css   -   line 26</a:t>
             </a:r>
           </a:p>
         </p:txBody>
@@ -19893,36 +19874,11 @@
             <a:r>
               <a:rPr sz="1800">
                 <a:solidFill>
-                  <a:srgbClr val="6D8C97"/>
+                  <a:srgbClr val="7FE0A0"/>
                 </a:solidFill>
                 <a:latin typeface="Consolas"/>
               </a:rPr>
               <a:t>  border-radius: 6px;</a:t>
-            </a:r>
-          </a:p>
-          <a:p>
-            <a:pPr>
-              <a:spcAft>
-                <a:spcPts val="0"/>
-              </a:spcAft>
-            </a:pPr>
-            <a:r>
-              <a:rPr sz="1800">
-                <a:solidFill>
-                  <a:srgbClr val="6D8C97"/>
-                </a:solidFill>
-                <a:latin typeface="Consolas"/>
-              </a:rPr>
-              <a:t>  27  </a:t>
-            </a:r>
-            <a:r>
-              <a:rPr sz="1800">
-                <a:solidFill>
-                  <a:srgbClr val="7FE0A0"/>
-                </a:solidFill>
-                <a:latin typeface="Consolas"/>
-              </a:rPr>
-              <a:t>  font-size: 15px;</a:t>
             </a:r>
           </a:p>
         </p:txBody>
@@ -19955,7 +19911,7 @@
                   <a:srgbClr val="DCECEF"/>
                 </a:solidFill>
               </a:rPr>
-              <a:t>Comfortable text size.</a:t>
+              <a:t>Rounded corners.</a:t>
             </a:r>
           </a:p>
         </p:txBody>
@@ -20129,7 +20085,7 @@
                   <a:srgbClr val="01AEFD"/>
                 </a:solidFill>
               </a:rPr>
-              <a:t>Type this into style.css   -   line 28</a:t>
+              <a:t>Type this into style.css   -   line 27</a:t>
             </a:r>
           </a:p>
         </p:txBody>
@@ -20323,36 +20279,11 @@
             <a:r>
               <a:rPr sz="1800">
                 <a:solidFill>
-                  <a:srgbClr val="6D8C97"/>
+                  <a:srgbClr val="7FE0A0"/>
                 </a:solidFill>
                 <a:latin typeface="Consolas"/>
               </a:rPr>
               <a:t>  font-size: 15px;</a:t>
-            </a:r>
-          </a:p>
-          <a:p>
-            <a:pPr>
-              <a:spcAft>
-                <a:spcPts val="0"/>
-              </a:spcAft>
-            </a:pPr>
-            <a:r>
-              <a:rPr sz="1800">
-                <a:solidFill>
-                  <a:srgbClr val="6D8C97"/>
-                </a:solidFill>
-                <a:latin typeface="Consolas"/>
-              </a:rPr>
-              <a:t>  28  </a:t>
-            </a:r>
-            <a:r>
-              <a:rPr sz="1800">
-                <a:solidFill>
-                  <a:srgbClr val="7FE0A0"/>
-                </a:solidFill>
-                <a:latin typeface="Consolas"/>
-              </a:rPr>
-              <a:t>}</a:t>
             </a:r>
           </a:p>
         </p:txBody>
@@ -20385,7 +20316,7 @@
                   <a:srgbClr val="DCECEF"/>
                 </a:solidFill>
               </a:rPr>
-              <a:t>Closes the input rule.</a:t>
+              <a:t>Comfortable text size.</a:t>
             </a:r>
           </a:p>
         </p:txBody>
@@ -20444,7 +20375,7 @@
                   <a:srgbClr val="01AEFD"/>
                 </a:solidFill>
               </a:rPr>
-              <a:t>Type this into style.css   -   line 29</a:t>
+              <a:t>Type this into style.css   -   line 28</a:t>
             </a:r>
           </a:p>
         </p:txBody>
@@ -20663,36 +20594,11 @@
             <a:r>
               <a:rPr sz="1800">
                 <a:solidFill>
-                  <a:srgbClr val="6D8C97"/>
+                  <a:srgbClr val="7FE0A0"/>
                 </a:solidFill>
                 <a:latin typeface="Consolas"/>
               </a:rPr>
               <a:t>}</a:t>
-            </a:r>
-          </a:p>
-          <a:p>
-            <a:pPr>
-              <a:spcAft>
-                <a:spcPts val="0"/>
-              </a:spcAft>
-            </a:pPr>
-            <a:r>
-              <a:rPr sz="1800">
-                <a:solidFill>
-                  <a:srgbClr val="6D8C97"/>
-                </a:solidFill>
-                <a:latin typeface="Consolas"/>
-              </a:rPr>
-              <a:t>  29  </a:t>
-            </a:r>
-            <a:r>
-              <a:rPr sz="1800">
-                <a:solidFill>
-                  <a:srgbClr val="7FE0A0"/>
-                </a:solidFill>
-                <a:latin typeface="Consolas"/>
-              </a:rPr>
-              <a:t>.composer button {</a:t>
             </a:r>
           </a:p>
         </p:txBody>
@@ -20725,7 +20631,7 @@
                   <a:srgbClr val="DCECEF"/>
                 </a:solidFill>
               </a:rPr>
-              <a:t>Starts a rule for the button inside .composer.</a:t>
+              <a:t>Closes the input rule.</a:t>
             </a:r>
           </a:p>
         </p:txBody>
@@ -20784,7 +20690,7 @@
                   <a:srgbClr val="01AEFD"/>
                 </a:solidFill>
               </a:rPr>
-              <a:t>Type this into style.css   -   line 30</a:t>
+              <a:t>Type this into style.css   -   line 29</a:t>
             </a:r>
           </a:p>
         </p:txBody>
@@ -21028,36 +20934,11 @@
             <a:r>
               <a:rPr sz="1800">
                 <a:solidFill>
-                  <a:srgbClr val="6D8C97"/>
+                  <a:srgbClr val="7FE0A0"/>
                 </a:solidFill>
                 <a:latin typeface="Consolas"/>
               </a:rPr>
               <a:t>.composer button {</a:t>
-            </a:r>
-          </a:p>
-          <a:p>
-            <a:pPr>
-              <a:spcAft>
-                <a:spcPts val="0"/>
-              </a:spcAft>
-            </a:pPr>
-            <a:r>
-              <a:rPr sz="1800">
-                <a:solidFill>
-                  <a:srgbClr val="6D8C97"/>
-                </a:solidFill>
-                <a:latin typeface="Consolas"/>
-              </a:rPr>
-              <a:t>  30  </a:t>
-            </a:r>
-            <a:r>
-              <a:rPr sz="1800">
-                <a:solidFill>
-                  <a:srgbClr val="7FE0A0"/>
-                </a:solidFill>
-                <a:latin typeface="Consolas"/>
-              </a:rPr>
-              <a:t>  padding: 11px 18px;</a:t>
             </a:r>
           </a:p>
         </p:txBody>
@@ -21090,7 +20971,7 @@
                   <a:srgbClr val="DCECEF"/>
                 </a:solidFill>
               </a:rPr>
-              <a:t>Padding to make the button a comfortable size to tap.</a:t>
+              <a:t>Starts a rule for the button inside .composer.</a:t>
             </a:r>
           </a:p>
         </p:txBody>
@@ -21149,7 +21030,7 @@
                   <a:srgbClr val="01AEFD"/>
                 </a:solidFill>
               </a:rPr>
-              <a:t>Type this into style.css   -   line 31</a:t>
+              <a:t>Type this into style.css   -   line 30</a:t>
             </a:r>
           </a:p>
         </p:txBody>
@@ -21182,7 +21063,7 @@
               </a:spcAft>
             </a:pPr>
             <a:r>
-              <a:rPr sz="1300">
+              <a:rPr sz="1800">
                 <a:solidFill>
                   <a:srgbClr val="6D8C97"/>
                 </a:solidFill>
@@ -21191,7 +21072,7 @@
               <a:t>  21  </a:t>
             </a:r>
             <a:r>
-              <a:rPr sz="1300">
+              <a:rPr sz="1800">
                 <a:solidFill>
                   <a:srgbClr val="6D8C97"/>
                 </a:solidFill>
@@ -21207,7 +21088,7 @@
               </a:spcAft>
             </a:pPr>
             <a:r>
-              <a:rPr sz="1300">
+              <a:rPr sz="1800">
                 <a:solidFill>
                   <a:srgbClr val="6D8C97"/>
                 </a:solidFill>
@@ -21216,7 +21097,7 @@
               <a:t>  22  </a:t>
             </a:r>
             <a:r>
-              <a:rPr sz="1300">
+              <a:rPr sz="1800">
                 <a:solidFill>
                   <a:srgbClr val="6D8C97"/>
                 </a:solidFill>
@@ -21232,7 +21113,7 @@
               </a:spcAft>
             </a:pPr>
             <a:r>
-              <a:rPr sz="1300">
+              <a:rPr sz="1800">
                 <a:solidFill>
                   <a:srgbClr val="6D8C97"/>
                 </a:solidFill>
@@ -21241,7 +21122,7 @@
               <a:t>  23  </a:t>
             </a:r>
             <a:r>
-              <a:rPr sz="1300">
+              <a:rPr sz="1800">
                 <a:solidFill>
                   <a:srgbClr val="6D8C97"/>
                 </a:solidFill>
@@ -21257,7 +21138,7 @@
               </a:spcAft>
             </a:pPr>
             <a:r>
-              <a:rPr sz="1300">
+              <a:rPr sz="1800">
                 <a:solidFill>
                   <a:srgbClr val="6D8C97"/>
                 </a:solidFill>
@@ -21266,7 +21147,7 @@
               <a:t>  24  </a:t>
             </a:r>
             <a:r>
-              <a:rPr sz="1300">
+              <a:rPr sz="1800">
                 <a:solidFill>
                   <a:srgbClr val="6D8C97"/>
                 </a:solidFill>
@@ -21282,7 +21163,7 @@
               </a:spcAft>
             </a:pPr>
             <a:r>
-              <a:rPr sz="1300">
+              <a:rPr sz="1800">
                 <a:solidFill>
                   <a:srgbClr val="6D8C97"/>
                 </a:solidFill>
@@ -21291,7 +21172,7 @@
               <a:t>  25  </a:t>
             </a:r>
             <a:r>
-              <a:rPr sz="1300">
+              <a:rPr sz="1800">
                 <a:solidFill>
                   <a:srgbClr val="6D8C97"/>
                 </a:solidFill>
@@ -21307,7 +21188,7 @@
               </a:spcAft>
             </a:pPr>
             <a:r>
-              <a:rPr sz="1300">
+              <a:rPr sz="1800">
                 <a:solidFill>
                   <a:srgbClr val="6D8C97"/>
                 </a:solidFill>
@@ -21316,7 +21197,7 @@
               <a:t>  26  </a:t>
             </a:r>
             <a:r>
-              <a:rPr sz="1300">
+              <a:rPr sz="1800">
                 <a:solidFill>
                   <a:srgbClr val="6D8C97"/>
                 </a:solidFill>
@@ -21332,7 +21213,7 @@
               </a:spcAft>
             </a:pPr>
             <a:r>
-              <a:rPr sz="1300">
+              <a:rPr sz="1800">
                 <a:solidFill>
                   <a:srgbClr val="6D8C97"/>
                 </a:solidFill>
@@ -21341,7 +21222,7 @@
               <a:t>  27  </a:t>
             </a:r>
             <a:r>
-              <a:rPr sz="1300">
+              <a:rPr sz="1800">
                 <a:solidFill>
                   <a:srgbClr val="6D8C97"/>
                 </a:solidFill>
@@ -21357,7 +21238,7 @@
               </a:spcAft>
             </a:pPr>
             <a:r>
-              <a:rPr sz="1300">
+              <a:rPr sz="1800">
                 <a:solidFill>
                   <a:srgbClr val="6D8C97"/>
                 </a:solidFill>
@@ -21366,7 +21247,7 @@
               <a:t>  28  </a:t>
             </a:r>
             <a:r>
-              <a:rPr sz="1300">
+              <a:rPr sz="1800">
                 <a:solidFill>
                   <a:srgbClr val="6D8C97"/>
                 </a:solidFill>
@@ -21382,7 +21263,7 @@
               </a:spcAft>
             </a:pPr>
             <a:r>
-              <a:rPr sz="1300">
+              <a:rPr sz="1800">
                 <a:solidFill>
                   <a:srgbClr val="6D8C97"/>
                 </a:solidFill>
@@ -21391,7 +21272,7 @@
               <a:t>  29  </a:t>
             </a:r>
             <a:r>
-              <a:rPr sz="1300">
+              <a:rPr sz="1800">
                 <a:solidFill>
                   <a:srgbClr val="6D8C97"/>
                 </a:solidFill>
@@ -21407,7 +21288,7 @@
               </a:spcAft>
             </a:pPr>
             <a:r>
-              <a:rPr sz="1300">
+              <a:rPr sz="1800">
                 <a:solidFill>
                   <a:srgbClr val="6D8C97"/>
                 </a:solidFill>
@@ -21416,38 +21297,13 @@
               <a:t>  30  </a:t>
             </a:r>
             <a:r>
-              <a:rPr sz="1300">
-                <a:solidFill>
-                  <a:srgbClr val="6D8C97"/>
+              <a:rPr sz="1800">
+                <a:solidFill>
+                  <a:srgbClr val="7FE0A0"/>
                 </a:solidFill>
                 <a:latin typeface="Consolas"/>
               </a:rPr>
               <a:t>  padding: 11px 18px;</a:t>
-            </a:r>
-          </a:p>
-          <a:p>
-            <a:pPr>
-              <a:spcAft>
-                <a:spcPts val="0"/>
-              </a:spcAft>
-            </a:pPr>
-            <a:r>
-              <a:rPr sz="1300">
-                <a:solidFill>
-                  <a:srgbClr val="6D8C97"/>
-                </a:solidFill>
-                <a:latin typeface="Consolas"/>
-              </a:rPr>
-              <a:t>  31  </a:t>
-            </a:r>
-            <a:r>
-              <a:rPr sz="1300">
-                <a:solidFill>
-                  <a:srgbClr val="7FE0A0"/>
-                </a:solidFill>
-                <a:latin typeface="Consolas"/>
-              </a:rPr>
-              <a:t>  border: 0;</a:t>
             </a:r>
           </a:p>
         </p:txBody>
@@ -21480,7 +21336,7 @@
                   <a:srgbClr val="DCECEF"/>
                 </a:solidFill>
               </a:rPr>
-              <a:t>border: 0 removes the default button outline.</a:t>
+              <a:t>Padding to make the button a comfortable size to tap.</a:t>
             </a:r>
           </a:p>
         </p:txBody>
@@ -21539,7 +21395,7 @@
                   <a:srgbClr val="01AEFD"/>
                 </a:solidFill>
               </a:rPr>
-              <a:t>Type this into style.css   -   line 32</a:t>
+              <a:t>Type this into style.css   -   line 31</a:t>
             </a:r>
           </a:p>
         </p:txBody>
@@ -21833,36 +21689,11 @@
             <a:r>
               <a:rPr sz="1300">
                 <a:solidFill>
-                  <a:srgbClr val="6D8C97"/>
+                  <a:srgbClr val="7FE0A0"/>
                 </a:solidFill>
                 <a:latin typeface="Consolas"/>
               </a:rPr>
               <a:t>  border: 0;</a:t>
-            </a:r>
-          </a:p>
-          <a:p>
-            <a:pPr>
-              <a:spcAft>
-                <a:spcPts val="0"/>
-              </a:spcAft>
-            </a:pPr>
-            <a:r>
-              <a:rPr sz="1300">
-                <a:solidFill>
-                  <a:srgbClr val="6D8C97"/>
-                </a:solidFill>
-                <a:latin typeface="Consolas"/>
-              </a:rPr>
-              <a:t>  32  </a:t>
-            </a:r>
-            <a:r>
-              <a:rPr sz="1300">
-                <a:solidFill>
-                  <a:srgbClr val="7FE0A0"/>
-                </a:solidFill>
-                <a:latin typeface="Consolas"/>
-              </a:rPr>
-              <a:t>  border-radius: 6px;</a:t>
             </a:r>
           </a:p>
         </p:txBody>
@@ -21895,7 +21726,7 @@
                   <a:srgbClr val="DCECEF"/>
                 </a:solidFill>
               </a:rPr>
-              <a:t>Rounded corners.</a:t>
+              <a:t>border: 0 removes the default button outline.</a:t>
             </a:r>
           </a:p>
         </p:txBody>
@@ -21954,7 +21785,7 @@
                   <a:srgbClr val="01AEFD"/>
                 </a:solidFill>
               </a:rPr>
-              <a:t>Type this into style.css   -   line 33</a:t>
+              <a:t>Type this into style.css   -   line 32</a:t>
             </a:r>
           </a:p>
         </p:txBody>
@@ -22273,36 +22104,11 @@
             <a:r>
               <a:rPr sz="1300">
                 <a:solidFill>
-                  <a:srgbClr val="6D8C97"/>
+                  <a:srgbClr val="7FE0A0"/>
                 </a:solidFill>
                 <a:latin typeface="Consolas"/>
               </a:rPr>
               <a:t>  border-radius: 6px;</a:t>
-            </a:r>
-          </a:p>
-          <a:p>
-            <a:pPr>
-              <a:spcAft>
-                <a:spcPts val="0"/>
-              </a:spcAft>
-            </a:pPr>
-            <a:r>
-              <a:rPr sz="1300">
-                <a:solidFill>
-                  <a:srgbClr val="6D8C97"/>
-                </a:solidFill>
-                <a:latin typeface="Consolas"/>
-              </a:rPr>
-              <a:t>  33  </a:t>
-            </a:r>
-            <a:r>
-              <a:rPr sz="1300">
-                <a:solidFill>
-                  <a:srgbClr val="7FE0A0"/>
-                </a:solidFill>
-                <a:latin typeface="Consolas"/>
-              </a:rPr>
-              <a:t>  background: #01aefd;</a:t>
             </a:r>
           </a:p>
         </p:txBody>
@@ -22335,7 +22141,7 @@
                   <a:srgbClr val="DCECEF"/>
                 </a:solidFill>
               </a:rPr>
-              <a:t>The brand blue as its background.</a:t>
+              <a:t>Rounded corners.</a:t>
             </a:r>
           </a:p>
         </p:txBody>
@@ -22394,7 +22200,7 @@
                   <a:srgbClr val="01AEFD"/>
                 </a:solidFill>
               </a:rPr>
-              <a:t>Type this into style.css   -   line 34</a:t>
+              <a:t>Type this into style.css   -   line 33</a:t>
             </a:r>
           </a:p>
         </p:txBody>
@@ -22738,36 +22544,11 @@
             <a:r>
               <a:rPr sz="1300">
                 <a:solidFill>
-                  <a:srgbClr val="6D8C97"/>
+                  <a:srgbClr val="7FE0A0"/>
                 </a:solidFill>
                 <a:latin typeface="Consolas"/>
               </a:rPr>
               <a:t>  background: #01aefd;</a:t>
-            </a:r>
-          </a:p>
-          <a:p>
-            <a:pPr>
-              <a:spcAft>
-                <a:spcPts val="0"/>
-              </a:spcAft>
-            </a:pPr>
-            <a:r>
-              <a:rPr sz="1300">
-                <a:solidFill>
-                  <a:srgbClr val="6D8C97"/>
-                </a:solidFill>
-                <a:latin typeface="Consolas"/>
-              </a:rPr>
-              <a:t>  34  </a:t>
-            </a:r>
-            <a:r>
-              <a:rPr sz="1300">
-                <a:solidFill>
-                  <a:srgbClr val="7FE0A0"/>
-                </a:solidFill>
-                <a:latin typeface="Consolas"/>
-              </a:rPr>
-              <a:t>  color: #ffffff;</a:t>
             </a:r>
           </a:p>
         </p:txBody>
@@ -22800,7 +22581,7 @@
                   <a:srgbClr val="DCECEF"/>
                 </a:solidFill>
               </a:rPr>
-              <a:t>White text on the blue.</a:t>
+              <a:t>The brand blue as its background.</a:t>
             </a:r>
           </a:p>
         </p:txBody>
@@ -22859,7 +22640,7 @@
                   <a:srgbClr val="01AEFD"/>
                 </a:solidFill>
               </a:rPr>
-              <a:t>Type this into style.css   -   line 35</a:t>
+              <a:t>Type this into style.css   -   line 34</a:t>
             </a:r>
           </a:p>
         </p:txBody>
@@ -23228,36 +23009,11 @@
             <a:r>
               <a:rPr sz="1300">
                 <a:solidFill>
-                  <a:srgbClr val="6D8C97"/>
+                  <a:srgbClr val="7FE0A0"/>
                 </a:solidFill>
                 <a:latin typeface="Consolas"/>
               </a:rPr>
               <a:t>  color: #ffffff;</a:t>
-            </a:r>
-          </a:p>
-          <a:p>
-            <a:pPr>
-              <a:spcAft>
-                <a:spcPts val="0"/>
-              </a:spcAft>
-            </a:pPr>
-            <a:r>
-              <a:rPr sz="1300">
-                <a:solidFill>
-                  <a:srgbClr val="6D8C97"/>
-                </a:solidFill>
-                <a:latin typeface="Consolas"/>
-              </a:rPr>
-              <a:t>  35  </a:t>
-            </a:r>
-            <a:r>
-              <a:rPr sz="1300">
-                <a:solidFill>
-                  <a:srgbClr val="7FE0A0"/>
-                </a:solidFill>
-                <a:latin typeface="Consolas"/>
-              </a:rPr>
-              <a:t>  font-size: 15px;</a:t>
             </a:r>
           </a:p>
         </p:txBody>
@@ -23290,7 +23046,7 @@
                   <a:srgbClr val="DCECEF"/>
                 </a:solidFill>
               </a:rPr>
-              <a:t>Readable text size.</a:t>
+              <a:t>White text on the blue.</a:t>
             </a:r>
           </a:p>
         </p:txBody>
@@ -23304,136 +23060,6 @@
 </file>
 
 <file path=ppt/slides/slide88.xml><?xml version="1.0" encoding="utf-8"?>
-<p:sld xmlns:a="http://schemas.openxmlformats.org/drawingml/2006/main" xmlns:p="http://schemas.openxmlformats.org/presentationml/2006/main" xmlns:r="http://schemas.openxmlformats.org/officeDocument/2006/relationships">
-  <p:cSld>
-    <p:spTree>
-      <p:nvGrpSpPr>
-        <p:cNvPr id="1" name=""/>
-        <p:cNvGrpSpPr/>
-        <p:nvPr/>
-      </p:nvGrpSpPr>
-      <p:grpSpPr/>
-      <p:sp>
-        <p:nvSpPr>
-          <p:cNvPr id="2" name="Title 1"/>
-          <p:cNvSpPr>
-            <a:spLocks noGrp="1"/>
-          </p:cNvSpPr>
-          <p:nvPr>
-            <p:ph type="title"/>
-          </p:nvPr>
-        </p:nvSpPr>
-        <p:spPr/>
-        <p:txBody>
-          <a:bodyPr/>
-          <a:lstStyle/>
-          <a:p>
-            <a:r>
-              <a:rPr sz="3800" b="1">
-                <a:solidFill>
-                  <a:srgbClr val="1F2A37"/>
-                </a:solidFill>
-              </a:rPr>
-              <a:t>cursor</a:t>
-            </a:r>
-          </a:p>
-        </p:txBody>
-      </p:sp>
-      <p:sp>
-        <p:nvSpPr>
-          <p:cNvPr id="3" name="TextBox 2"/>
-          <p:cNvSpPr txBox="1"/>
-          <p:nvPr/>
-        </p:nvSpPr>
-        <p:spPr>
-          <a:xfrm>
-            <a:off x="868680" y="502920"/>
-            <a:ext cx="5486400" cy="457200"/>
-          </a:xfrm>
-          <a:prstGeom prst="rect">
-            <a:avLst/>
-          </a:prstGeom>
-          <a:noFill/>
-        </p:spPr>
-        <p:txBody>
-          <a:bodyPr wrap="none">
-            <a:spAutoFit/>
-          </a:bodyPr>
-          <a:lstStyle/>
-          <a:p>
-            <a:r>
-              <a:rPr sz="1500" b="1">
-                <a:solidFill>
-                  <a:srgbClr val="01AEFD"/>
-                </a:solidFill>
-              </a:rPr>
-              <a:t>CSS</a:t>
-            </a:r>
-          </a:p>
-        </p:txBody>
-      </p:sp>
-      <p:sp>
-        <p:nvSpPr>
-          <p:cNvPr id="4" name="TextBox 3"/>
-          <p:cNvSpPr txBox="1"/>
-          <p:nvPr/>
-        </p:nvSpPr>
-        <p:spPr>
-          <a:xfrm>
-            <a:off x="822960" y="1828800"/>
-            <a:ext cx="10515600" cy="4206240"/>
-          </a:xfrm>
-          <a:prstGeom prst="rect">
-            <a:avLst/>
-          </a:prstGeom>
-          <a:noFill/>
-        </p:spPr>
-        <p:txBody>
-          <a:bodyPr wrap="square">
-            <a:spAutoFit/>
-          </a:bodyPr>
-          <a:lstStyle/>
-          <a:p>
-            <a:pPr>
-              <a:spcAft>
-                <a:spcPts val="1400"/>
-              </a:spcAft>
-            </a:pPr>
-            <a:r>
-              <a:rPr sz="2400">
-                <a:solidFill>
-                  <a:srgbClr val="1F2A37"/>
-                </a:solidFill>
-              </a:rPr>
-              <a:t>• The mouse-pointer shape.</a:t>
-            </a:r>
-          </a:p>
-          <a:p>
-            <a:pPr>
-              <a:spcAft>
-                <a:spcPts val="1400"/>
-              </a:spcAft>
-            </a:pPr>
-            <a:r>
-              <a:rPr sz="2400">
-                <a:solidFill>
-                  <a:srgbClr val="1F2A37"/>
-                </a:solidFill>
-              </a:rPr>
-              <a:t>• pointer shows a hand, so it looks clickable.</a:t>
-            </a:r>
-          </a:p>
-        </p:txBody>
-      </p:sp>
-    </p:spTree>
-  </p:cSld>
-  <p:clrMapOvr>
-    <a:masterClrMapping/>
-  </p:clrMapOvr>
-</p:sld>
-</file>
-
-<file path=ppt/slides/slide89.xml><?xml version="1.0" encoding="utf-8"?>
 <p:sld xmlns:a="http://schemas.openxmlformats.org/drawingml/2006/main" xmlns:p="http://schemas.openxmlformats.org/presentationml/2006/main" xmlns:r="http://schemas.openxmlformats.org/officeDocument/2006/relationships">
   <p:cSld>
     <p:bg>
@@ -23479,7 +23105,7 @@
                   <a:srgbClr val="01AEFD"/>
                 </a:solidFill>
               </a:rPr>
-              <a:t>Type this into style.css   -   line 36</a:t>
+              <a:t>Type this into style.css   -   line 35</a:t>
             </a:r>
           </a:p>
         </p:txBody>
@@ -23873,36 +23499,11 @@
             <a:r>
               <a:rPr sz="1300">
                 <a:solidFill>
-                  <a:srgbClr val="6D8C97"/>
+                  <a:srgbClr val="7FE0A0"/>
                 </a:solidFill>
                 <a:latin typeface="Consolas"/>
               </a:rPr>
               <a:t>  font-size: 15px;</a:t>
-            </a:r>
-          </a:p>
-          <a:p>
-            <a:pPr>
-              <a:spcAft>
-                <a:spcPts val="0"/>
-              </a:spcAft>
-            </a:pPr>
-            <a:r>
-              <a:rPr sz="1300">
-                <a:solidFill>
-                  <a:srgbClr val="6D8C97"/>
-                </a:solidFill>
-                <a:latin typeface="Consolas"/>
-              </a:rPr>
-              <a:t>  36  </a:t>
-            </a:r>
-            <a:r>
-              <a:rPr sz="1300">
-                <a:solidFill>
-                  <a:srgbClr val="7FE0A0"/>
-                </a:solidFill>
-                <a:latin typeface="Consolas"/>
-              </a:rPr>
-              <a:t>  cursor: pointer;</a:t>
             </a:r>
           </a:p>
         </p:txBody>
@@ -23935,7 +23536,137 @@
                   <a:srgbClr val="DCECEF"/>
                 </a:solidFill>
               </a:rPr>
-              <a:t>cursor: pointer shows a hand so it looks clickable.</a:t>
+              <a:t>Readable text size.</a:t>
+            </a:r>
+          </a:p>
+        </p:txBody>
+      </p:sp>
+    </p:spTree>
+  </p:cSld>
+  <p:clrMapOvr>
+    <a:masterClrMapping/>
+  </p:clrMapOvr>
+</p:sld>
+</file>
+
+<file path=ppt/slides/slide89.xml><?xml version="1.0" encoding="utf-8"?>
+<p:sld xmlns:a="http://schemas.openxmlformats.org/drawingml/2006/main" xmlns:p="http://schemas.openxmlformats.org/presentationml/2006/main" xmlns:r="http://schemas.openxmlformats.org/officeDocument/2006/relationships">
+  <p:cSld>
+    <p:spTree>
+      <p:nvGrpSpPr>
+        <p:cNvPr id="1" name=""/>
+        <p:cNvGrpSpPr/>
+        <p:nvPr/>
+      </p:nvGrpSpPr>
+      <p:grpSpPr/>
+      <p:sp>
+        <p:nvSpPr>
+          <p:cNvPr id="2" name="Title 1"/>
+          <p:cNvSpPr>
+            <a:spLocks noGrp="1"/>
+          </p:cNvSpPr>
+          <p:nvPr>
+            <p:ph type="title"/>
+          </p:nvPr>
+        </p:nvSpPr>
+        <p:spPr/>
+        <p:txBody>
+          <a:bodyPr/>
+          <a:lstStyle/>
+          <a:p>
+            <a:r>
+              <a:rPr sz="3800" b="1">
+                <a:solidFill>
+                  <a:srgbClr val="1F2A37"/>
+                </a:solidFill>
+              </a:rPr>
+              <a:t>cursor</a:t>
+            </a:r>
+          </a:p>
+        </p:txBody>
+      </p:sp>
+      <p:sp>
+        <p:nvSpPr>
+          <p:cNvPr id="3" name="TextBox 2"/>
+          <p:cNvSpPr txBox="1"/>
+          <p:nvPr/>
+        </p:nvSpPr>
+        <p:spPr>
+          <a:xfrm>
+            <a:off x="868680" y="502920"/>
+            <a:ext cx="5486400" cy="457200"/>
+          </a:xfrm>
+          <a:prstGeom prst="rect">
+            <a:avLst/>
+          </a:prstGeom>
+          <a:noFill/>
+        </p:spPr>
+        <p:txBody>
+          <a:bodyPr wrap="none">
+            <a:spAutoFit/>
+          </a:bodyPr>
+          <a:lstStyle/>
+          <a:p>
+            <a:r>
+              <a:rPr sz="1500" b="1">
+                <a:solidFill>
+                  <a:srgbClr val="01AEFD"/>
+                </a:solidFill>
+              </a:rPr>
+              <a:t>CSS</a:t>
+            </a:r>
+          </a:p>
+        </p:txBody>
+      </p:sp>
+      <p:sp>
+        <p:nvSpPr>
+          <p:cNvPr id="4" name="TextBox 3"/>
+          <p:cNvSpPr txBox="1"/>
+          <p:nvPr/>
+        </p:nvSpPr>
+        <p:spPr>
+          <a:xfrm>
+            <a:off x="822960" y="1828800"/>
+            <a:ext cx="10515600" cy="4206240"/>
+          </a:xfrm>
+          <a:prstGeom prst="rect">
+            <a:avLst/>
+          </a:prstGeom>
+          <a:noFill/>
+        </p:spPr>
+        <p:txBody>
+          <a:bodyPr wrap="square">
+            <a:spAutoFit/>
+          </a:bodyPr>
+          <a:lstStyle/>
+          <a:p>
+            <a:pPr>
+              <a:spcAft>
+                <a:spcPts val="1400"/>
+              </a:spcAft>
+            </a:pPr>
+            <a:r>
+              <a:rPr sz="2400">
+                <a:solidFill>
+                  <a:srgbClr val="1F2A37"/>
+                </a:solidFill>
+              </a:rPr>
+              <a:t>• The mouse-pointer shape.</a:t>
+            </a:r>
+          </a:p>
+          <a:p>
+            <a:pPr>
+              <a:spcAft>
+                <a:spcPts val="1400"/>
+              </a:spcAft>
+            </a:pPr>
+            <a:r>
+              <a:rPr sz="2400">
+                <a:solidFill>
+                  <a:srgbClr val="1F2A37"/>
+                </a:solidFill>
+              </a:rPr>
+              <a:t>• pointer shows a hand, so it looks clickable.</a:t>
             </a:r>
           </a:p>
         </p:txBody>
@@ -24159,7 +23890,7 @@
                   <a:srgbClr val="01AEFD"/>
                 </a:solidFill>
               </a:rPr>
-              <a:t>Type this into style.css   -   line 37</a:t>
+              <a:t>Type this into style.css   -   line 36</a:t>
             </a:r>
           </a:p>
         </p:txBody>
@@ -24578,36 +24309,11 @@
             <a:r>
               <a:rPr sz="1300">
                 <a:solidFill>
-                  <a:srgbClr val="6D8C97"/>
+                  <a:srgbClr val="7FE0A0"/>
                 </a:solidFill>
                 <a:latin typeface="Consolas"/>
               </a:rPr>
               <a:t>  cursor: pointer;</a:t>
-            </a:r>
-          </a:p>
-          <a:p>
-            <a:pPr>
-              <a:spcAft>
-                <a:spcPts val="0"/>
-              </a:spcAft>
-            </a:pPr>
-            <a:r>
-              <a:rPr sz="1300">
-                <a:solidFill>
-                  <a:srgbClr val="6D8C97"/>
-                </a:solidFill>
-                <a:latin typeface="Consolas"/>
-              </a:rPr>
-              <a:t>  37  </a:t>
-            </a:r>
-            <a:r>
-              <a:rPr sz="1300">
-                <a:solidFill>
-                  <a:srgbClr val="7FE0A0"/>
-                </a:solidFill>
-                <a:latin typeface="Consolas"/>
-              </a:rPr>
-              <a:t>}</a:t>
             </a:r>
           </a:p>
         </p:txBody>
@@ -24640,7 +24346,7 @@
                   <a:srgbClr val="DCECEF"/>
                 </a:solidFill>
               </a:rPr>
-              <a:t>Closes the button rule.</a:t>
+              <a:t>cursor: pointer shows a hand so it looks clickable.</a:t>
             </a:r>
           </a:p>
         </p:txBody>
@@ -24699,7 +24405,7 @@
                   <a:srgbClr val="01AEFD"/>
                 </a:solidFill>
               </a:rPr>
-              <a:t>All together in style.css</a:t>
+              <a:t>Type this into style.css   -   line 37</a:t>
             </a:r>
           </a:p>
         </p:txBody>
@@ -24743,7 +24449,7 @@
             <a:r>
               <a:rPr sz="1300">
                 <a:solidFill>
-                  <a:srgbClr val="7FE0A0"/>
+                  <a:srgbClr val="6D8C97"/>
                 </a:solidFill>
                 <a:latin typeface="Consolas"/>
               </a:rPr>
@@ -24768,7 +24474,7 @@
             <a:r>
               <a:rPr sz="1300">
                 <a:solidFill>
-                  <a:srgbClr val="7FE0A0"/>
+                  <a:srgbClr val="6D8C97"/>
                 </a:solidFill>
                 <a:latin typeface="Consolas"/>
               </a:rPr>
@@ -24793,7 +24499,7 @@
             <a:r>
               <a:rPr sz="1300">
                 <a:solidFill>
-                  <a:srgbClr val="7FE0A0"/>
+                  <a:srgbClr val="6D8C97"/>
                 </a:solidFill>
                 <a:latin typeface="Consolas"/>
               </a:rPr>
@@ -24818,7 +24524,7 @@
             <a:r>
               <a:rPr sz="1300">
                 <a:solidFill>
-                  <a:srgbClr val="7FE0A0"/>
+                  <a:srgbClr val="6D8C97"/>
                 </a:solidFill>
                 <a:latin typeface="Consolas"/>
               </a:rPr>
@@ -24843,7 +24549,7 @@
             <a:r>
               <a:rPr sz="1300">
                 <a:solidFill>
-                  <a:srgbClr val="7FE0A0"/>
+                  <a:srgbClr val="6D8C97"/>
                 </a:solidFill>
                 <a:latin typeface="Consolas"/>
               </a:rPr>
@@ -24868,7 +24574,7 @@
             <a:r>
               <a:rPr sz="1300">
                 <a:solidFill>
-                  <a:srgbClr val="7FE0A0"/>
+                  <a:srgbClr val="6D8C97"/>
                 </a:solidFill>
                 <a:latin typeface="Consolas"/>
               </a:rPr>
@@ -24893,7 +24599,7 @@
             <a:r>
               <a:rPr sz="1300">
                 <a:solidFill>
-                  <a:srgbClr val="7FE0A0"/>
+                  <a:srgbClr val="6D8C97"/>
                 </a:solidFill>
                 <a:latin typeface="Consolas"/>
               </a:rPr>
@@ -24918,7 +24624,7 @@
             <a:r>
               <a:rPr sz="1300">
                 <a:solidFill>
-                  <a:srgbClr val="7FE0A0"/>
+                  <a:srgbClr val="6D8C97"/>
                 </a:solidFill>
                 <a:latin typeface="Consolas"/>
               </a:rPr>
@@ -24943,7 +24649,7 @@
             <a:r>
               <a:rPr sz="1300">
                 <a:solidFill>
-                  <a:srgbClr val="7FE0A0"/>
+                  <a:srgbClr val="6D8C97"/>
                 </a:solidFill>
                 <a:latin typeface="Consolas"/>
               </a:rPr>
@@ -24968,7 +24674,7 @@
             <a:r>
               <a:rPr sz="1300">
                 <a:solidFill>
-                  <a:srgbClr val="7FE0A0"/>
+                  <a:srgbClr val="6D8C97"/>
                 </a:solidFill>
                 <a:latin typeface="Consolas"/>
               </a:rPr>
@@ -24993,7 +24699,7 @@
             <a:r>
               <a:rPr sz="1300">
                 <a:solidFill>
-                  <a:srgbClr val="7FE0A0"/>
+                  <a:srgbClr val="6D8C97"/>
                 </a:solidFill>
                 <a:latin typeface="Consolas"/>
               </a:rPr>
@@ -25018,7 +24724,7 @@
             <a:r>
               <a:rPr sz="1300">
                 <a:solidFill>
-                  <a:srgbClr val="7FE0A0"/>
+                  <a:srgbClr val="6D8C97"/>
                 </a:solidFill>
                 <a:latin typeface="Consolas"/>
               </a:rPr>
@@ -25043,7 +24749,7 @@
             <a:r>
               <a:rPr sz="1300">
                 <a:solidFill>
-                  <a:srgbClr val="7FE0A0"/>
+                  <a:srgbClr val="6D8C97"/>
                 </a:solidFill>
                 <a:latin typeface="Consolas"/>
               </a:rPr>
@@ -25068,7 +24774,7 @@
             <a:r>
               <a:rPr sz="1300">
                 <a:solidFill>
-                  <a:srgbClr val="7FE0A0"/>
+                  <a:srgbClr val="6D8C97"/>
                 </a:solidFill>
                 <a:latin typeface="Consolas"/>
               </a:rPr>
@@ -25093,7 +24799,7 @@
             <a:r>
               <a:rPr sz="1300">
                 <a:solidFill>
-                  <a:srgbClr val="7FE0A0"/>
+                  <a:srgbClr val="6D8C97"/>
                 </a:solidFill>
                 <a:latin typeface="Consolas"/>
               </a:rPr>
@@ -25118,7 +24824,7 @@
             <a:r>
               <a:rPr sz="1300">
                 <a:solidFill>
-                  <a:srgbClr val="7FE0A0"/>
+                  <a:srgbClr val="6D8C97"/>
                 </a:solidFill>
                 <a:latin typeface="Consolas"/>
               </a:rPr>
@@ -25180,7 +24886,7 @@
                   <a:srgbClr val="DCECEF"/>
                 </a:solidFill>
               </a:rPr>
-              <a:t>That is the whole piece. Check yours looks the same before moving on.</a:t>
+              <a:t>Closes the button rule.</a:t>
             </a:r>
           </a:p>
         </p:txBody>
@@ -25196,6 +24902,14 @@
 <file path=ppt/slides/slide92.xml><?xml version="1.0" encoding="utf-8"?>
 <p:sld xmlns:a="http://schemas.openxmlformats.org/drawingml/2006/main" xmlns:p="http://schemas.openxmlformats.org/presentationml/2006/main" xmlns:r="http://schemas.openxmlformats.org/officeDocument/2006/relationships">
   <p:cSld>
+    <p:bg>
+      <p:bgPr>
+        <a:solidFill>
+          <a:srgbClr val="102127"/>
+        </a:solidFill>
+        <a:effectLst/>
+      </p:bgPr>
+    </p:bg>
     <p:spTree>
       <p:nvGrpSpPr>
         <p:cNvPr id="1" name=""/>
@@ -25205,26 +24919,33 @@
       <p:grpSpPr/>
       <p:sp>
         <p:nvSpPr>
-          <p:cNvPr id="2" name="Title 1"/>
-          <p:cNvSpPr>
-            <a:spLocks noGrp="1"/>
-          </p:cNvSpPr>
-          <p:nvPr>
-            <p:ph type="title"/>
-          </p:nvPr>
-        </p:nvSpPr>
-        <p:spPr/>
-        <p:txBody>
-          <a:bodyPr/>
-          <a:lstStyle/>
-          <a:p>
-            <a:r>
-              <a:rPr sz="3800" b="1">
-                <a:solidFill>
-                  <a:srgbClr val="1F2A37"/>
-                </a:solidFill>
-              </a:rPr>
-              <a:t>The script goes at the BOTTOM</a:t>
+          <p:cNvPr id="2" name="TextBox 1"/>
+          <p:cNvSpPr txBox="1"/>
+          <p:nvPr/>
+        </p:nvSpPr>
+        <p:spPr>
+          <a:xfrm>
+            <a:off x="502920" y="274320"/>
+            <a:ext cx="11155680" cy="548640"/>
+          </a:xfrm>
+          <a:prstGeom prst="rect">
+            <a:avLst/>
+          </a:prstGeom>
+          <a:noFill/>
+        </p:spPr>
+        <p:txBody>
+          <a:bodyPr wrap="none">
+            <a:spAutoFit/>
+          </a:bodyPr>
+          <a:lstStyle/>
+          <a:p>
+            <a:r>
+              <a:rPr sz="2200" b="1">
+                <a:solidFill>
+                  <a:srgbClr val="01AEFD"/>
+                </a:solidFill>
+              </a:rPr>
+              <a:t>All together in style.css</a:t>
             </a:r>
           </a:p>
         </p:txBody>
@@ -25237,8 +24958,456 @@
         </p:nvSpPr>
         <p:spPr>
           <a:xfrm>
-            <a:off x="822960" y="1828800"/>
-            <a:ext cx="10515600" cy="4206240"/>
+            <a:off x="502920" y="960120"/>
+            <a:ext cx="11155680" cy="4297680"/>
+          </a:xfrm>
+          <a:prstGeom prst="rect">
+            <a:avLst/>
+          </a:prstGeom>
+          <a:noFill/>
+        </p:spPr>
+        <p:txBody>
+          <a:bodyPr wrap="none">
+            <a:spAutoFit/>
+          </a:bodyPr>
+          <a:lstStyle/>
+          <a:p>
+            <a:pPr>
+              <a:spcAft>
+                <a:spcPts val="0"/>
+              </a:spcAft>
+            </a:pPr>
+            <a:r>
+              <a:rPr sz="1300">
+                <a:solidFill>
+                  <a:srgbClr val="6D8C97"/>
+                </a:solidFill>
+                <a:latin typeface="Consolas"/>
+              </a:rPr>
+              <a:t>  21  </a:t>
+            </a:r>
+            <a:r>
+              <a:rPr sz="1300">
+                <a:solidFill>
+                  <a:srgbClr val="7FE0A0"/>
+                </a:solidFill>
+                <a:latin typeface="Consolas"/>
+              </a:rPr>
+              <a:t>.composer { display: flex; gap: 8px; margin-top: 12px; }</a:t>
+            </a:r>
+          </a:p>
+          <a:p>
+            <a:pPr>
+              <a:spcAft>
+                <a:spcPts val="0"/>
+              </a:spcAft>
+            </a:pPr>
+            <a:r>
+              <a:rPr sz="1300">
+                <a:solidFill>
+                  <a:srgbClr val="6D8C97"/>
+                </a:solidFill>
+                <a:latin typeface="Consolas"/>
+              </a:rPr>
+              <a:t>  22  </a:t>
+            </a:r>
+            <a:r>
+              <a:rPr sz="1300">
+                <a:solidFill>
+                  <a:srgbClr val="7FE0A0"/>
+                </a:solidFill>
+                <a:latin typeface="Consolas"/>
+              </a:rPr>
+              <a:t>.composer input {</a:t>
+            </a:r>
+          </a:p>
+          <a:p>
+            <a:pPr>
+              <a:spcAft>
+                <a:spcPts val="0"/>
+              </a:spcAft>
+            </a:pPr>
+            <a:r>
+              <a:rPr sz="1300">
+                <a:solidFill>
+                  <a:srgbClr val="6D8C97"/>
+                </a:solidFill>
+                <a:latin typeface="Consolas"/>
+              </a:rPr>
+              <a:t>  23  </a:t>
+            </a:r>
+            <a:r>
+              <a:rPr sz="1300">
+                <a:solidFill>
+                  <a:srgbClr val="7FE0A0"/>
+                </a:solidFill>
+                <a:latin typeface="Consolas"/>
+              </a:rPr>
+              <a:t>  flex: 1;</a:t>
+            </a:r>
+          </a:p>
+          <a:p>
+            <a:pPr>
+              <a:spcAft>
+                <a:spcPts val="0"/>
+              </a:spcAft>
+            </a:pPr>
+            <a:r>
+              <a:rPr sz="1300">
+                <a:solidFill>
+                  <a:srgbClr val="6D8C97"/>
+                </a:solidFill>
+                <a:latin typeface="Consolas"/>
+              </a:rPr>
+              <a:t>  24  </a:t>
+            </a:r>
+            <a:r>
+              <a:rPr sz="1300">
+                <a:solidFill>
+                  <a:srgbClr val="7FE0A0"/>
+                </a:solidFill>
+                <a:latin typeface="Consolas"/>
+              </a:rPr>
+              <a:t>  padding: 11px;</a:t>
+            </a:r>
+          </a:p>
+          <a:p>
+            <a:pPr>
+              <a:spcAft>
+                <a:spcPts val="0"/>
+              </a:spcAft>
+            </a:pPr>
+            <a:r>
+              <a:rPr sz="1300">
+                <a:solidFill>
+                  <a:srgbClr val="6D8C97"/>
+                </a:solidFill>
+                <a:latin typeface="Consolas"/>
+              </a:rPr>
+              <a:t>  25  </a:t>
+            </a:r>
+            <a:r>
+              <a:rPr sz="1300">
+                <a:solidFill>
+                  <a:srgbClr val="7FE0A0"/>
+                </a:solidFill>
+                <a:latin typeface="Consolas"/>
+              </a:rPr>
+              <a:t>  border: 1px solid #dbe3ec;</a:t>
+            </a:r>
+          </a:p>
+          <a:p>
+            <a:pPr>
+              <a:spcAft>
+                <a:spcPts val="0"/>
+              </a:spcAft>
+            </a:pPr>
+            <a:r>
+              <a:rPr sz="1300">
+                <a:solidFill>
+                  <a:srgbClr val="6D8C97"/>
+                </a:solidFill>
+                <a:latin typeface="Consolas"/>
+              </a:rPr>
+              <a:t>  26  </a:t>
+            </a:r>
+            <a:r>
+              <a:rPr sz="1300">
+                <a:solidFill>
+                  <a:srgbClr val="7FE0A0"/>
+                </a:solidFill>
+                <a:latin typeface="Consolas"/>
+              </a:rPr>
+              <a:t>  border-radius: 6px;</a:t>
+            </a:r>
+          </a:p>
+          <a:p>
+            <a:pPr>
+              <a:spcAft>
+                <a:spcPts val="0"/>
+              </a:spcAft>
+            </a:pPr>
+            <a:r>
+              <a:rPr sz="1300">
+                <a:solidFill>
+                  <a:srgbClr val="6D8C97"/>
+                </a:solidFill>
+                <a:latin typeface="Consolas"/>
+              </a:rPr>
+              <a:t>  27  </a:t>
+            </a:r>
+            <a:r>
+              <a:rPr sz="1300">
+                <a:solidFill>
+                  <a:srgbClr val="7FE0A0"/>
+                </a:solidFill>
+                <a:latin typeface="Consolas"/>
+              </a:rPr>
+              <a:t>  font-size: 15px;</a:t>
+            </a:r>
+          </a:p>
+          <a:p>
+            <a:pPr>
+              <a:spcAft>
+                <a:spcPts val="0"/>
+              </a:spcAft>
+            </a:pPr>
+            <a:r>
+              <a:rPr sz="1300">
+                <a:solidFill>
+                  <a:srgbClr val="6D8C97"/>
+                </a:solidFill>
+                <a:latin typeface="Consolas"/>
+              </a:rPr>
+              <a:t>  28  </a:t>
+            </a:r>
+            <a:r>
+              <a:rPr sz="1300">
+                <a:solidFill>
+                  <a:srgbClr val="7FE0A0"/>
+                </a:solidFill>
+                <a:latin typeface="Consolas"/>
+              </a:rPr>
+              <a:t>}</a:t>
+            </a:r>
+          </a:p>
+          <a:p>
+            <a:pPr>
+              <a:spcAft>
+                <a:spcPts val="0"/>
+              </a:spcAft>
+            </a:pPr>
+            <a:r>
+              <a:rPr sz="1300">
+                <a:solidFill>
+                  <a:srgbClr val="6D8C97"/>
+                </a:solidFill>
+                <a:latin typeface="Consolas"/>
+              </a:rPr>
+              <a:t>  29  </a:t>
+            </a:r>
+            <a:r>
+              <a:rPr sz="1300">
+                <a:solidFill>
+                  <a:srgbClr val="7FE0A0"/>
+                </a:solidFill>
+                <a:latin typeface="Consolas"/>
+              </a:rPr>
+              <a:t>.composer button {</a:t>
+            </a:r>
+          </a:p>
+          <a:p>
+            <a:pPr>
+              <a:spcAft>
+                <a:spcPts val="0"/>
+              </a:spcAft>
+            </a:pPr>
+            <a:r>
+              <a:rPr sz="1300">
+                <a:solidFill>
+                  <a:srgbClr val="6D8C97"/>
+                </a:solidFill>
+                <a:latin typeface="Consolas"/>
+              </a:rPr>
+              <a:t>  30  </a:t>
+            </a:r>
+            <a:r>
+              <a:rPr sz="1300">
+                <a:solidFill>
+                  <a:srgbClr val="7FE0A0"/>
+                </a:solidFill>
+                <a:latin typeface="Consolas"/>
+              </a:rPr>
+              <a:t>  padding: 11px 18px;</a:t>
+            </a:r>
+          </a:p>
+          <a:p>
+            <a:pPr>
+              <a:spcAft>
+                <a:spcPts val="0"/>
+              </a:spcAft>
+            </a:pPr>
+            <a:r>
+              <a:rPr sz="1300">
+                <a:solidFill>
+                  <a:srgbClr val="6D8C97"/>
+                </a:solidFill>
+                <a:latin typeface="Consolas"/>
+              </a:rPr>
+              <a:t>  31  </a:t>
+            </a:r>
+            <a:r>
+              <a:rPr sz="1300">
+                <a:solidFill>
+                  <a:srgbClr val="7FE0A0"/>
+                </a:solidFill>
+                <a:latin typeface="Consolas"/>
+              </a:rPr>
+              <a:t>  border: 0;</a:t>
+            </a:r>
+          </a:p>
+          <a:p>
+            <a:pPr>
+              <a:spcAft>
+                <a:spcPts val="0"/>
+              </a:spcAft>
+            </a:pPr>
+            <a:r>
+              <a:rPr sz="1300">
+                <a:solidFill>
+                  <a:srgbClr val="6D8C97"/>
+                </a:solidFill>
+                <a:latin typeface="Consolas"/>
+              </a:rPr>
+              <a:t>  32  </a:t>
+            </a:r>
+            <a:r>
+              <a:rPr sz="1300">
+                <a:solidFill>
+                  <a:srgbClr val="7FE0A0"/>
+                </a:solidFill>
+                <a:latin typeface="Consolas"/>
+              </a:rPr>
+              <a:t>  border-radius: 6px;</a:t>
+            </a:r>
+          </a:p>
+          <a:p>
+            <a:pPr>
+              <a:spcAft>
+                <a:spcPts val="0"/>
+              </a:spcAft>
+            </a:pPr>
+            <a:r>
+              <a:rPr sz="1300">
+                <a:solidFill>
+                  <a:srgbClr val="6D8C97"/>
+                </a:solidFill>
+                <a:latin typeface="Consolas"/>
+              </a:rPr>
+              <a:t>  33  </a:t>
+            </a:r>
+            <a:r>
+              <a:rPr sz="1300">
+                <a:solidFill>
+                  <a:srgbClr val="7FE0A0"/>
+                </a:solidFill>
+                <a:latin typeface="Consolas"/>
+              </a:rPr>
+              <a:t>  background: #01aefd;</a:t>
+            </a:r>
+          </a:p>
+          <a:p>
+            <a:pPr>
+              <a:spcAft>
+                <a:spcPts val="0"/>
+              </a:spcAft>
+            </a:pPr>
+            <a:r>
+              <a:rPr sz="1300">
+                <a:solidFill>
+                  <a:srgbClr val="6D8C97"/>
+                </a:solidFill>
+                <a:latin typeface="Consolas"/>
+              </a:rPr>
+              <a:t>  34  </a:t>
+            </a:r>
+            <a:r>
+              <a:rPr sz="1300">
+                <a:solidFill>
+                  <a:srgbClr val="7FE0A0"/>
+                </a:solidFill>
+                <a:latin typeface="Consolas"/>
+              </a:rPr>
+              <a:t>  color: #ffffff;</a:t>
+            </a:r>
+          </a:p>
+          <a:p>
+            <a:pPr>
+              <a:spcAft>
+                <a:spcPts val="0"/>
+              </a:spcAft>
+            </a:pPr>
+            <a:r>
+              <a:rPr sz="1300">
+                <a:solidFill>
+                  <a:srgbClr val="6D8C97"/>
+                </a:solidFill>
+                <a:latin typeface="Consolas"/>
+              </a:rPr>
+              <a:t>  35  </a:t>
+            </a:r>
+            <a:r>
+              <a:rPr sz="1300">
+                <a:solidFill>
+                  <a:srgbClr val="7FE0A0"/>
+                </a:solidFill>
+                <a:latin typeface="Consolas"/>
+              </a:rPr>
+              <a:t>  font-size: 15px;</a:t>
+            </a:r>
+          </a:p>
+          <a:p>
+            <a:pPr>
+              <a:spcAft>
+                <a:spcPts val="0"/>
+              </a:spcAft>
+            </a:pPr>
+            <a:r>
+              <a:rPr sz="1300">
+                <a:solidFill>
+                  <a:srgbClr val="6D8C97"/>
+                </a:solidFill>
+                <a:latin typeface="Consolas"/>
+              </a:rPr>
+              <a:t>  36  </a:t>
+            </a:r>
+            <a:r>
+              <a:rPr sz="1300">
+                <a:solidFill>
+                  <a:srgbClr val="7FE0A0"/>
+                </a:solidFill>
+                <a:latin typeface="Consolas"/>
+              </a:rPr>
+              <a:t>  cursor: pointer;</a:t>
+            </a:r>
+          </a:p>
+          <a:p>
+            <a:pPr>
+              <a:spcAft>
+                <a:spcPts val="0"/>
+              </a:spcAft>
+            </a:pPr>
+            <a:r>
+              <a:rPr sz="1300">
+                <a:solidFill>
+                  <a:srgbClr val="6D8C97"/>
+                </a:solidFill>
+                <a:latin typeface="Consolas"/>
+              </a:rPr>
+              <a:t>  37  </a:t>
+            </a:r>
+            <a:r>
+              <a:rPr sz="1300">
+                <a:solidFill>
+                  <a:srgbClr val="7FE0A0"/>
+                </a:solidFill>
+                <a:latin typeface="Consolas"/>
+              </a:rPr>
+              <a:t>}</a:t>
+            </a:r>
+          </a:p>
+        </p:txBody>
+      </p:sp>
+      <p:sp>
+        <p:nvSpPr>
+          <p:cNvPr id="4" name="TextBox 3"/>
+          <p:cNvSpPr txBox="1"/>
+          <p:nvPr/>
+        </p:nvSpPr>
+        <p:spPr>
+          <a:xfrm>
+            <a:off x="548640" y="5623560"/>
+            <a:ext cx="11064240" cy="1051560"/>
           </a:xfrm>
           <a:prstGeom prst="rect">
             <a:avLst/>
@@ -25251,63 +25420,13 @@
           </a:bodyPr>
           <a:lstStyle/>
           <a:p>
-            <a:pPr>
-              <a:spcAft>
-                <a:spcPts val="1400"/>
-              </a:spcAft>
-            </a:pPr>
-            <a:r>
-              <a:rPr sz="2400">
-                <a:solidFill>
-                  <a:srgbClr val="1F2A37"/>
-                </a:solidFill>
-              </a:rPr>
-              <a:t>• The browser reads top to bottom</a:t>
-            </a:r>
-          </a:p>
-          <a:p>
-            <a:pPr>
-              <a:spcAft>
-                <a:spcPts val="1400"/>
-              </a:spcAft>
-            </a:pPr>
-            <a:r>
-              <a:rPr sz="2400">
-                <a:solidFill>
-                  <a:srgbClr val="1F2A37"/>
-                </a:solidFill>
-              </a:rPr>
-              <a:t>• At the top, the boxes do not exist yet</a:t>
-            </a:r>
-          </a:p>
-          <a:p>
-            <a:pPr>
-              <a:spcAft>
-                <a:spcPts val="1400"/>
-              </a:spcAft>
-            </a:pPr>
-            <a:r>
-              <a:rPr sz="2400">
-                <a:solidFill>
-                  <a:srgbClr val="1F2A37"/>
-                </a:solidFill>
-              </a:rPr>
-              <a:t>• A script cannot find a page that has not been made</a:t>
-            </a:r>
-          </a:p>
-          <a:p>
-            <a:pPr>
-              <a:spcAft>
-                <a:spcPts val="1400"/>
-              </a:spcAft>
-            </a:pPr>
-            <a:r>
-              <a:rPr sz="2400">
-                <a:solidFill>
-                  <a:srgbClr val="1F2A37"/>
-                </a:solidFill>
-              </a:rPr>
-              <a:t>• Move it up, press Run, watch it break</a:t>
+            <a:r>
+              <a:rPr sz="2000">
+                <a:solidFill>
+                  <a:srgbClr val="DCECEF"/>
+                </a:solidFill>
+              </a:rPr>
+              <a:t>That is the whole piece. Check yours looks the same before moving on.</a:t>
             </a:r>
           </a:p>
         </p:txBody>
@@ -25351,7 +25470,7 @@
                   <a:srgbClr val="1F2A37"/>
                 </a:solidFill>
               </a:rPr>
-              <a:t>The &lt;script&gt; tag</a:t>
+              <a:t>The script goes at the BOTTOM</a:t>
             </a:r>
           </a:p>
         </p:txBody>
@@ -25359,39 +25478,6 @@
       <p:sp>
         <p:nvSpPr>
           <p:cNvPr id="3" name="TextBox 2"/>
-          <p:cNvSpPr txBox="1"/>
-          <p:nvPr/>
-        </p:nvSpPr>
-        <p:spPr>
-          <a:xfrm>
-            <a:off x="868680" y="502920"/>
-            <a:ext cx="5486400" cy="457200"/>
-          </a:xfrm>
-          <a:prstGeom prst="rect">
-            <a:avLst/>
-          </a:prstGeom>
-          <a:noFill/>
-        </p:spPr>
-        <p:txBody>
-          <a:bodyPr wrap="none">
-            <a:spAutoFit/>
-          </a:bodyPr>
-          <a:lstStyle/>
-          <a:p>
-            <a:r>
-              <a:rPr sz="1500" b="1">
-                <a:solidFill>
-                  <a:srgbClr val="01AEFD"/>
-                </a:solidFill>
-              </a:rPr>
-              <a:t>HTML</a:t>
-            </a:r>
-          </a:p>
-        </p:txBody>
-      </p:sp>
-      <p:sp>
-        <p:nvSpPr>
-          <p:cNvPr id="4" name="TextBox 3"/>
           <p:cNvSpPr txBox="1"/>
           <p:nvPr/>
         </p:nvSpPr>
@@ -25422,7 +25508,7 @@
                   <a:srgbClr val="1F2A37"/>
                 </a:solidFill>
               </a:rPr>
-              <a:t>• Loads script.js, the code that makes the page do things.</a:t>
+              <a:t>• The browser reads top to bottom</a:t>
             </a:r>
           </a:p>
           <a:p>
@@ -25437,7 +25523,37 @@
                   <a:srgbClr val="1F2A37"/>
                 </a:solidFill>
               </a:rPr>
-              <a:t>• It goes LAST so the boxes exist before the code looks for them.</a:t>
+              <a:t>• At the top, the boxes do not exist yet</a:t>
+            </a:r>
+          </a:p>
+          <a:p>
+            <a:pPr>
+              <a:spcAft>
+                <a:spcPts val="1400"/>
+              </a:spcAft>
+            </a:pPr>
+            <a:r>
+              <a:rPr sz="2400">
+                <a:solidFill>
+                  <a:srgbClr val="1F2A37"/>
+                </a:solidFill>
+              </a:rPr>
+              <a:t>• A script cannot find a page that has not been made</a:t>
+            </a:r>
+          </a:p>
+          <a:p>
+            <a:pPr>
+              <a:spcAft>
+                <a:spcPts val="1400"/>
+              </a:spcAft>
+            </a:pPr>
+            <a:r>
+              <a:rPr sz="2400">
+                <a:solidFill>
+                  <a:srgbClr val="1F2A37"/>
+                </a:solidFill>
+              </a:rPr>
+              <a:t>• Move it up, press Run, watch it break</a:t>
             </a:r>
           </a:p>
         </p:txBody>
@@ -25451,6 +25567,136 @@
 </file>
 
 <file path=ppt/slides/slide94.xml><?xml version="1.0" encoding="utf-8"?>
+<p:sld xmlns:a="http://schemas.openxmlformats.org/drawingml/2006/main" xmlns:p="http://schemas.openxmlformats.org/presentationml/2006/main" xmlns:r="http://schemas.openxmlformats.org/officeDocument/2006/relationships">
+  <p:cSld>
+    <p:spTree>
+      <p:nvGrpSpPr>
+        <p:cNvPr id="1" name=""/>
+        <p:cNvGrpSpPr/>
+        <p:nvPr/>
+      </p:nvGrpSpPr>
+      <p:grpSpPr/>
+      <p:sp>
+        <p:nvSpPr>
+          <p:cNvPr id="2" name="Title 1"/>
+          <p:cNvSpPr>
+            <a:spLocks noGrp="1"/>
+          </p:cNvSpPr>
+          <p:nvPr>
+            <p:ph type="title"/>
+          </p:nvPr>
+        </p:nvSpPr>
+        <p:spPr/>
+        <p:txBody>
+          <a:bodyPr/>
+          <a:lstStyle/>
+          <a:p>
+            <a:r>
+              <a:rPr sz="3800" b="1">
+                <a:solidFill>
+                  <a:srgbClr val="1F2A37"/>
+                </a:solidFill>
+              </a:rPr>
+              <a:t>The &lt;script&gt; tag</a:t>
+            </a:r>
+          </a:p>
+        </p:txBody>
+      </p:sp>
+      <p:sp>
+        <p:nvSpPr>
+          <p:cNvPr id="3" name="TextBox 2"/>
+          <p:cNvSpPr txBox="1"/>
+          <p:nvPr/>
+        </p:nvSpPr>
+        <p:spPr>
+          <a:xfrm>
+            <a:off x="868680" y="502920"/>
+            <a:ext cx="5486400" cy="457200"/>
+          </a:xfrm>
+          <a:prstGeom prst="rect">
+            <a:avLst/>
+          </a:prstGeom>
+          <a:noFill/>
+        </p:spPr>
+        <p:txBody>
+          <a:bodyPr wrap="none">
+            <a:spAutoFit/>
+          </a:bodyPr>
+          <a:lstStyle/>
+          <a:p>
+            <a:r>
+              <a:rPr sz="1500" b="1">
+                <a:solidFill>
+                  <a:srgbClr val="01AEFD"/>
+                </a:solidFill>
+              </a:rPr>
+              <a:t>HTML</a:t>
+            </a:r>
+          </a:p>
+        </p:txBody>
+      </p:sp>
+      <p:sp>
+        <p:nvSpPr>
+          <p:cNvPr id="4" name="TextBox 3"/>
+          <p:cNvSpPr txBox="1"/>
+          <p:nvPr/>
+        </p:nvSpPr>
+        <p:spPr>
+          <a:xfrm>
+            <a:off x="822960" y="1828800"/>
+            <a:ext cx="10515600" cy="4206240"/>
+          </a:xfrm>
+          <a:prstGeom prst="rect">
+            <a:avLst/>
+          </a:prstGeom>
+          <a:noFill/>
+        </p:spPr>
+        <p:txBody>
+          <a:bodyPr wrap="square">
+            <a:spAutoFit/>
+          </a:bodyPr>
+          <a:lstStyle/>
+          <a:p>
+            <a:pPr>
+              <a:spcAft>
+                <a:spcPts val="1400"/>
+              </a:spcAft>
+            </a:pPr>
+            <a:r>
+              <a:rPr sz="2400">
+                <a:solidFill>
+                  <a:srgbClr val="1F2A37"/>
+                </a:solidFill>
+              </a:rPr>
+              <a:t>• Loads script.js, the code that makes the page do things.</a:t>
+            </a:r>
+          </a:p>
+          <a:p>
+            <a:pPr>
+              <a:spcAft>
+                <a:spcPts val="1400"/>
+              </a:spcAft>
+            </a:pPr>
+            <a:r>
+              <a:rPr sz="2400">
+                <a:solidFill>
+                  <a:srgbClr val="1F2A37"/>
+                </a:solidFill>
+              </a:rPr>
+              <a:t>• It goes LAST so the boxes exist before the code looks for them.</a:t>
+            </a:r>
+          </a:p>
+        </p:txBody>
+      </p:sp>
+    </p:spTree>
+  </p:cSld>
+  <p:clrMapOvr>
+    <a:masterClrMapping/>
+  </p:clrMapOvr>
+</p:sld>
+</file>
+
+<file path=ppt/slides/slide95.xml><?xml version="1.0" encoding="utf-8"?>
 <p:sld xmlns:a="http://schemas.openxmlformats.org/drawingml/2006/main" xmlns:p="http://schemas.openxmlformats.org/presentationml/2006/main" xmlns:r="http://schemas.openxmlformats.org/officeDocument/2006/relationships">
   <p:cSld>
     <p:bg>
@@ -25603,103 +25849,6 @@
                 </a:solidFill>
               </a:rPr>
               <a:t>Loads your JavaScript. It sits at the very bottom so every box above already exists when the code runs.</a:t>
-            </a:r>
-          </a:p>
-        </p:txBody>
-      </p:sp>
-    </p:spTree>
-  </p:cSld>
-  <p:clrMapOvr>
-    <a:masterClrMapping/>
-  </p:clrMapOvr>
-</p:sld>
-</file>
-
-<file path=ppt/slides/slide95.xml><?xml version="1.0" encoding="utf-8"?>
-<p:sld xmlns:a="http://schemas.openxmlformats.org/drawingml/2006/main" xmlns:p="http://schemas.openxmlformats.org/presentationml/2006/main" xmlns:r="http://schemas.openxmlformats.org/officeDocument/2006/relationships">
-  <p:cSld>
-    <p:spTree>
-      <p:nvGrpSpPr>
-        <p:cNvPr id="1" name=""/>
-        <p:cNvGrpSpPr/>
-        <p:nvPr/>
-      </p:nvGrpSpPr>
-      <p:grpSpPr/>
-      <p:sp>
-        <p:nvSpPr>
-          <p:cNvPr id="2" name="Title 1"/>
-          <p:cNvSpPr>
-            <a:spLocks noGrp="1"/>
-          </p:cNvSpPr>
-          <p:nvPr>
-            <p:ph type="title"/>
-          </p:nvPr>
-        </p:nvSpPr>
-        <p:spPr/>
-        <p:txBody>
-          <a:bodyPr/>
-          <a:lstStyle/>
-          <a:p>
-            <a:r>
-              <a:rPr sz="3800" b="1">
-                <a:solidFill>
-                  <a:srgbClr val="1F2A37"/>
-                </a:solidFill>
-              </a:rPr>
-              <a:t>Two buttons you will use every week</a:t>
-            </a:r>
-          </a:p>
-        </p:txBody>
-      </p:sp>
-      <p:sp>
-        <p:nvSpPr>
-          <p:cNvPr id="3" name="TextBox 2"/>
-          <p:cNvSpPr txBox="1"/>
-          <p:nvPr/>
-        </p:nvSpPr>
-        <p:spPr>
-          <a:xfrm>
-            <a:off x="822960" y="1828800"/>
-            <a:ext cx="10515600" cy="4206240"/>
-          </a:xfrm>
-          <a:prstGeom prst="rect">
-            <a:avLst/>
-          </a:prstGeom>
-          <a:noFill/>
-        </p:spPr>
-        <p:txBody>
-          <a:bodyPr wrap="square">
-            <a:spAutoFit/>
-          </a:bodyPr>
-          <a:lstStyle/>
-          <a:p>
-            <a:pPr>
-              <a:spcAft>
-                <a:spcPts val="1400"/>
-              </a:spcAft>
-            </a:pPr>
-            <a:r>
-              <a:rPr sz="2400">
-                <a:solidFill>
-                  <a:srgbClr val="1F2A37"/>
-                </a:solidFill>
-              </a:rPr>
-              <a:t>• Run - nothing happens until you press it</a:t>
-            </a:r>
-          </a:p>
-          <a:p>
-            <a:pPr>
-              <a:spcAft>
-                <a:spcPts val="1400"/>
-              </a:spcAft>
-            </a:pPr>
-            <a:r>
-              <a:rPr sz="2400">
-                <a:solidFill>
-                  <a:srgbClr val="1F2A37"/>
-                </a:solidFill>
-              </a:rPr>
-              <a:t>• Console - where your code talks to you</a:t>
             </a:r>
           </a:p>
         </p:txBody>
@@ -25743,7 +25892,7 @@
                   <a:srgbClr val="1F2A37"/>
                 </a:solidFill>
               </a:rPr>
-              <a:t>A comment</a:t>
+              <a:t>Two buttons you will use every week</a:t>
             </a:r>
           </a:p>
         </p:txBody>
@@ -25751,39 +25900,6 @@
       <p:sp>
         <p:nvSpPr>
           <p:cNvPr id="3" name="TextBox 2"/>
-          <p:cNvSpPr txBox="1"/>
-          <p:nvPr/>
-        </p:nvSpPr>
-        <p:spPr>
-          <a:xfrm>
-            <a:off x="868680" y="502920"/>
-            <a:ext cx="5486400" cy="457200"/>
-          </a:xfrm>
-          <a:prstGeom prst="rect">
-            <a:avLst/>
-          </a:prstGeom>
-          <a:noFill/>
-        </p:spPr>
-        <p:txBody>
-          <a:bodyPr wrap="none">
-            <a:spAutoFit/>
-          </a:bodyPr>
-          <a:lstStyle/>
-          <a:p>
-            <a:r>
-              <a:rPr sz="1500" b="1">
-                <a:solidFill>
-                  <a:srgbClr val="01AEFD"/>
-                </a:solidFill>
-              </a:rPr>
-              <a:t>JAVASCRIPT</a:t>
-            </a:r>
-          </a:p>
-        </p:txBody>
-      </p:sp>
-      <p:sp>
-        <p:nvSpPr>
-          <p:cNvPr id="4" name="TextBox 3"/>
           <p:cNvSpPr txBox="1"/>
           <p:nvPr/>
         </p:nvSpPr>
@@ -25814,7 +25930,7 @@
                   <a:srgbClr val="1F2A37"/>
                 </a:solidFill>
               </a:rPr>
-              <a:t>• A line starting with // that the computer ignores.</a:t>
+              <a:t>• Run - nothing happens until you press it</a:t>
             </a:r>
           </a:p>
           <a:p>
@@ -25829,7 +25945,7 @@
                   <a:srgbClr val="1F2A37"/>
                 </a:solidFill>
               </a:rPr>
-              <a:t>• It is a note for the humans reading the code.</a:t>
+              <a:t>• Console - where your code talks to you</a:t>
             </a:r>
           </a:p>
         </p:txBody>
@@ -25843,6 +25959,136 @@
 </file>
 
 <file path=ppt/slides/slide97.xml><?xml version="1.0" encoding="utf-8"?>
+<p:sld xmlns:a="http://schemas.openxmlformats.org/drawingml/2006/main" xmlns:p="http://schemas.openxmlformats.org/presentationml/2006/main" xmlns:r="http://schemas.openxmlformats.org/officeDocument/2006/relationships">
+  <p:cSld>
+    <p:spTree>
+      <p:nvGrpSpPr>
+        <p:cNvPr id="1" name=""/>
+        <p:cNvGrpSpPr/>
+        <p:nvPr/>
+      </p:nvGrpSpPr>
+      <p:grpSpPr/>
+      <p:sp>
+        <p:nvSpPr>
+          <p:cNvPr id="2" name="Title 1"/>
+          <p:cNvSpPr>
+            <a:spLocks noGrp="1"/>
+          </p:cNvSpPr>
+          <p:nvPr>
+            <p:ph type="title"/>
+          </p:nvPr>
+        </p:nvSpPr>
+        <p:spPr/>
+        <p:txBody>
+          <a:bodyPr/>
+          <a:lstStyle/>
+          <a:p>
+            <a:r>
+              <a:rPr sz="3800" b="1">
+                <a:solidFill>
+                  <a:srgbClr val="1F2A37"/>
+                </a:solidFill>
+              </a:rPr>
+              <a:t>A comment</a:t>
+            </a:r>
+          </a:p>
+        </p:txBody>
+      </p:sp>
+      <p:sp>
+        <p:nvSpPr>
+          <p:cNvPr id="3" name="TextBox 2"/>
+          <p:cNvSpPr txBox="1"/>
+          <p:nvPr/>
+        </p:nvSpPr>
+        <p:spPr>
+          <a:xfrm>
+            <a:off x="868680" y="502920"/>
+            <a:ext cx="5486400" cy="457200"/>
+          </a:xfrm>
+          <a:prstGeom prst="rect">
+            <a:avLst/>
+          </a:prstGeom>
+          <a:noFill/>
+        </p:spPr>
+        <p:txBody>
+          <a:bodyPr wrap="none">
+            <a:spAutoFit/>
+          </a:bodyPr>
+          <a:lstStyle/>
+          <a:p>
+            <a:r>
+              <a:rPr sz="1500" b="1">
+                <a:solidFill>
+                  <a:srgbClr val="01AEFD"/>
+                </a:solidFill>
+              </a:rPr>
+              <a:t>JAVASCRIPT</a:t>
+            </a:r>
+          </a:p>
+        </p:txBody>
+      </p:sp>
+      <p:sp>
+        <p:nvSpPr>
+          <p:cNvPr id="4" name="TextBox 3"/>
+          <p:cNvSpPr txBox="1"/>
+          <p:nvPr/>
+        </p:nvSpPr>
+        <p:spPr>
+          <a:xfrm>
+            <a:off x="822960" y="1828800"/>
+            <a:ext cx="10515600" cy="4206240"/>
+          </a:xfrm>
+          <a:prstGeom prst="rect">
+            <a:avLst/>
+          </a:prstGeom>
+          <a:noFill/>
+        </p:spPr>
+        <p:txBody>
+          <a:bodyPr wrap="square">
+            <a:spAutoFit/>
+          </a:bodyPr>
+          <a:lstStyle/>
+          <a:p>
+            <a:pPr>
+              <a:spcAft>
+                <a:spcPts val="1400"/>
+              </a:spcAft>
+            </a:pPr>
+            <a:r>
+              <a:rPr sz="2400">
+                <a:solidFill>
+                  <a:srgbClr val="1F2A37"/>
+                </a:solidFill>
+              </a:rPr>
+              <a:t>• A line starting with // that the computer ignores.</a:t>
+            </a:r>
+          </a:p>
+          <a:p>
+            <a:pPr>
+              <a:spcAft>
+                <a:spcPts val="1400"/>
+              </a:spcAft>
+            </a:pPr>
+            <a:r>
+              <a:rPr sz="2400">
+                <a:solidFill>
+                  <a:srgbClr val="1F2A37"/>
+                </a:solidFill>
+              </a:rPr>
+              <a:t>• It is a note for the humans reading the code.</a:t>
+            </a:r>
+          </a:p>
+        </p:txBody>
+      </p:sp>
+    </p:spTree>
+  </p:cSld>
+  <p:clrMapOvr>
+    <a:masterClrMapping/>
+  </p:clrMapOvr>
+</p:sld>
+</file>
+
+<file path=ppt/slides/slide98.xml><?xml version="1.0" encoding="utf-8"?>
 <p:sld xmlns:a="http://schemas.openxmlformats.org/drawingml/2006/main" xmlns:p="http://schemas.openxmlformats.org/presentationml/2006/main" xmlns:r="http://schemas.openxmlformats.org/officeDocument/2006/relationships">
   <p:cSld>
     <p:bg>
@@ -25970,136 +26216,6 @@
                 </a:solidFill>
               </a:rPr>
               <a:t>A comment: a note for you, ignored by the computer.</a:t>
-            </a:r>
-          </a:p>
-        </p:txBody>
-      </p:sp>
-    </p:spTree>
-  </p:cSld>
-  <p:clrMapOvr>
-    <a:masterClrMapping/>
-  </p:clrMapOvr>
-</p:sld>
-</file>
-
-<file path=ppt/slides/slide98.xml><?xml version="1.0" encoding="utf-8"?>
-<p:sld xmlns:a="http://schemas.openxmlformats.org/drawingml/2006/main" xmlns:p="http://schemas.openxmlformats.org/presentationml/2006/main" xmlns:r="http://schemas.openxmlformats.org/officeDocument/2006/relationships">
-  <p:cSld>
-    <p:spTree>
-      <p:nvGrpSpPr>
-        <p:cNvPr id="1" name=""/>
-        <p:cNvGrpSpPr/>
-        <p:nvPr/>
-      </p:nvGrpSpPr>
-      <p:grpSpPr/>
-      <p:sp>
-        <p:nvSpPr>
-          <p:cNvPr id="2" name="Title 1"/>
-          <p:cNvSpPr>
-            <a:spLocks noGrp="1"/>
-          </p:cNvSpPr>
-          <p:nvPr>
-            <p:ph type="title"/>
-          </p:nvPr>
-        </p:nvSpPr>
-        <p:spPr/>
-        <p:txBody>
-          <a:bodyPr/>
-          <a:lstStyle/>
-          <a:p>
-            <a:r>
-              <a:rPr sz="3800" b="1">
-                <a:solidFill>
-                  <a:srgbClr val="1F2A37"/>
-                </a:solidFill>
-              </a:rPr>
-              <a:t>A line of JavaScript</a:t>
-            </a:r>
-          </a:p>
-        </p:txBody>
-      </p:sp>
-      <p:sp>
-        <p:nvSpPr>
-          <p:cNvPr id="3" name="TextBox 2"/>
-          <p:cNvSpPr txBox="1"/>
-          <p:nvPr/>
-        </p:nvSpPr>
-        <p:spPr>
-          <a:xfrm>
-            <a:off x="868680" y="502920"/>
-            <a:ext cx="5486400" cy="457200"/>
-          </a:xfrm>
-          <a:prstGeom prst="rect">
-            <a:avLst/>
-          </a:prstGeom>
-          <a:noFill/>
-        </p:spPr>
-        <p:txBody>
-          <a:bodyPr wrap="none">
-            <a:spAutoFit/>
-          </a:bodyPr>
-          <a:lstStyle/>
-          <a:p>
-            <a:r>
-              <a:rPr sz="1500" b="1">
-                <a:solidFill>
-                  <a:srgbClr val="01AEFD"/>
-                </a:solidFill>
-              </a:rPr>
-              <a:t>JAVASCRIPT</a:t>
-            </a:r>
-          </a:p>
-        </p:txBody>
-      </p:sp>
-      <p:sp>
-        <p:nvSpPr>
-          <p:cNvPr id="4" name="TextBox 3"/>
-          <p:cNvSpPr txBox="1"/>
-          <p:nvPr/>
-        </p:nvSpPr>
-        <p:spPr>
-          <a:xfrm>
-            <a:off x="822960" y="1828800"/>
-            <a:ext cx="10515600" cy="4206240"/>
-          </a:xfrm>
-          <a:prstGeom prst="rect">
-            <a:avLst/>
-          </a:prstGeom>
-          <a:noFill/>
-        </p:spPr>
-        <p:txBody>
-          <a:bodyPr wrap="square">
-            <a:spAutoFit/>
-          </a:bodyPr>
-          <a:lstStyle/>
-          <a:p>
-            <a:pPr>
-              <a:spcAft>
-                <a:spcPts val="1400"/>
-              </a:spcAft>
-            </a:pPr>
-            <a:r>
-              <a:rPr sz="2400">
-                <a:solidFill>
-                  <a:srgbClr val="1F2A37"/>
-                </a:solidFill>
-              </a:rPr>
-              <a:t>• Most lines are one instruction, usually ending in a semicolon ;</a:t>
-            </a:r>
-          </a:p>
-          <a:p>
-            <a:pPr>
-              <a:spcAft>
-                <a:spcPts val="1400"/>
-              </a:spcAft>
-            </a:pPr>
-            <a:r>
-              <a:rPr sz="2400">
-                <a:solidFill>
-                  <a:srgbClr val="1F2A37"/>
-                </a:solidFill>
-              </a:rPr>
-              <a:t>• The computer runs them top to bottom.</a:t>
             </a:r>
           </a:p>
         </p:txBody>
@@ -26143,7 +26259,7 @@
                   <a:srgbClr val="1F2A37"/>
                 </a:solidFill>
               </a:rPr>
-              <a:t>Strings: text in quotes</a:t>
+              <a:t>A line of JavaScript</a:t>
             </a:r>
           </a:p>
         </p:txBody>
@@ -26214,7 +26330,7 @@
                   <a:srgbClr val="1F2A37"/>
                 </a:solidFill>
               </a:rPr>
-              <a:t>• Text the computer treats as data goes in quotes: 'hello'.</a:t>
+              <a:t>• Most lines are one instruction, usually ending in a semicolon ;</a:t>
             </a:r>
           </a:p>
           <a:p>
@@ -26229,7 +26345,7 @@
                   <a:srgbClr val="1F2A37"/>
                 </a:solidFill>
               </a:rPr>
-              <a:t>• Single or double quotes both work.</a:t>
+              <a:t>• The computer runs them top to bottom.</a:t>
             </a:r>
           </a:p>
         </p:txBody>

</xml_diff>

<commit_message>
Concept titles: name the CSS property, not a full declaration
Titles like "display: flex" / "visibility: hidden" read as literal CSS
property:value rules - the very syntax these slides teach - which was
confusing as a slide title. Retitle the eight value-bearing CSS concepts
to the bare property name (display, flex, flex-direction, flex-wrap,
margin-left, overflow-y, visibility, white-space). The specific value
still shows in the caption and the animation.

Co-Authored-By: Claude Opus 4.8 <noreply@anthropic.com>
</commit_message>
<xml_diff>
--- a/ai101/slides/week-01.pptx
+++ b/ai101/slides/week-01.pptx
@@ -18250,7 +18250,7 @@
                   <a:srgbClr val="1F2A37"/>
                 </a:solidFill>
               </a:rPr>
-              <a:t>display: flex</a:t>
+              <a:t>display</a:t>
             </a:r>
           </a:p>
         </p:txBody>
@@ -18915,7 +18915,7 @@
                   <a:srgbClr val="1F2A37"/>
                 </a:solidFill>
               </a:rPr>
-              <a:t>flex: 1</a:t>
+              <a:t>flex</a:t>
             </a:r>
           </a:p>
         </p:txBody>

</xml_diff>

<commit_message>
Add controls strip to app wireframe; place select/option/output/details/summary
Audit for completeness found five VISIBLE HTML elements with no on-page
mockup slide, because the wireframe had no controls area to point at:
<select>, <option>, <output>, <details>, <summary>.

- build.py: the wireframe now has a controls strip (a model dropdown +
  a persona/settings toggle), in both concept_mockup (SVG) and
  mockup_slide (pptx). New regions: controls, dropdown, settings.
- course.py: the five elements now have placements ringing those regions.

Every visible element now has an "on the page" slide; the remaining
mockup-less concepts are all genuinely behind-the-scenes logic. 905 slides.

Co-Authored-By: Claude Opus 4.8 <noreply@anthropic.com>
</commit_message>
<xml_diff>
--- a/ai101/slides/week-01.pptx
+++ b/ai101/slides/week-01.pptx
@@ -3803,7 +3803,7 @@
         <p:spPr>
           <a:xfrm>
             <a:off x="3606393" y="2554833"/>
-            <a:ext cx="4945075" cy="1806854"/>
+            <a:ext cx="4945075" cy="1730776"/>
           </a:xfrm>
           <a:prstGeom prst="roundRect">
             <a:avLst/>
@@ -3978,8 +3978,8 @@
         </p:nvSpPr>
         <p:spPr>
           <a:xfrm>
-            <a:off x="3701491" y="4856195"/>
-            <a:ext cx="3899001" cy="323331"/>
+            <a:off x="3701491" y="4409236"/>
+            <a:ext cx="1426463" cy="228234"/>
           </a:xfrm>
           <a:prstGeom prst="roundRect">
             <a:avLst/>
@@ -4022,6 +4022,94 @@
         </p:nvSpPr>
         <p:spPr>
           <a:xfrm>
+            <a:off x="5223052" y="4409236"/>
+            <a:ext cx="1426463" cy="228234"/>
+          </a:xfrm>
+          <a:prstGeom prst="roundRect">
+            <a:avLst/>
+          </a:prstGeom>
+          <a:solidFill>
+            <a:srgbClr val="16303A"/>
+          </a:solidFill>
+          <a:ln>
+            <a:noFill/>
+          </a:ln>
+          <a:effectLst/>
+        </p:spPr>
+        <p:style>
+          <a:lnRef idx="1">
+            <a:schemeClr val="accent1"/>
+          </a:lnRef>
+          <a:fillRef idx="3">
+            <a:schemeClr val="accent1"/>
+          </a:fillRef>
+          <a:effectRef idx="2">
+            <a:schemeClr val="accent1"/>
+          </a:effectRef>
+          <a:fontRef idx="minor">
+            <a:schemeClr val="lt1"/>
+          </a:fontRef>
+        </p:style>
+        <p:txBody>
+          <a:bodyPr rtlCol="0" anchor="ctr"/>
+          <a:lstStyle/>
+          <a:p>
+            <a:pPr algn="ctr"/>
+          </a:p>
+        </p:txBody>
+      </p:sp>
+      <p:sp>
+        <p:nvSpPr>
+          <p:cNvPr id="13" name="Rounded Rectangle 12"/>
+          <p:cNvSpPr/>
+          <p:nvPr/>
+        </p:nvSpPr>
+        <p:spPr>
+          <a:xfrm>
+            <a:off x="3701491" y="4856195"/>
+            <a:ext cx="3899001" cy="323331"/>
+          </a:xfrm>
+          <a:prstGeom prst="roundRect">
+            <a:avLst/>
+          </a:prstGeom>
+          <a:solidFill>
+            <a:srgbClr val="16303A"/>
+          </a:solidFill>
+          <a:ln>
+            <a:noFill/>
+          </a:ln>
+          <a:effectLst/>
+        </p:spPr>
+        <p:style>
+          <a:lnRef idx="1">
+            <a:schemeClr val="accent1"/>
+          </a:lnRef>
+          <a:fillRef idx="3">
+            <a:schemeClr val="accent1"/>
+          </a:fillRef>
+          <a:effectRef idx="2">
+            <a:schemeClr val="accent1"/>
+          </a:effectRef>
+          <a:fontRef idx="minor">
+            <a:schemeClr val="lt1"/>
+          </a:fontRef>
+        </p:style>
+        <p:txBody>
+          <a:bodyPr rtlCol="0" anchor="ctr"/>
+          <a:lstStyle/>
+          <a:p>
+            <a:pPr algn="ctr"/>
+          </a:p>
+        </p:txBody>
+      </p:sp>
+      <p:sp>
+        <p:nvSpPr>
+          <p:cNvPr id="14" name="Rounded Rectangle 13"/>
+          <p:cNvSpPr/>
+          <p:nvPr/>
+        </p:nvSpPr>
+        <p:spPr>
+          <a:xfrm>
             <a:off x="7695590" y="4856195"/>
             <a:ext cx="779800" cy="323331"/>
           </a:xfrm>
@@ -4060,7 +4148,7 @@
       </p:sp>
       <p:sp>
         <p:nvSpPr>
-          <p:cNvPr id="13" name="Rounded Rectangle 12"/>
+          <p:cNvPr id="15" name="Rounded Rectangle 14"/>
           <p:cNvSpPr/>
           <p:nvPr/>
         </p:nvSpPr>
@@ -4104,7 +4192,7 @@
       </p:sp>
       <p:sp>
         <p:nvSpPr>
-          <p:cNvPr id="14" name="Rounded Rectangle 13"/>
+          <p:cNvPr id="16" name="Rounded Rectangle 15"/>
           <p:cNvSpPr/>
           <p:nvPr/>
         </p:nvSpPr>
@@ -4148,7 +4236,7 @@
       </p:sp>
       <p:sp>
         <p:nvSpPr>
-          <p:cNvPr id="15" name="TextBox 14"/>
+          <p:cNvPr id="17" name="TextBox 16"/>
           <p:cNvSpPr txBox="1"/>
           <p:nvPr/>
         </p:nvSpPr>
@@ -9077,7 +9165,7 @@
         <p:spPr>
           <a:xfrm>
             <a:off x="3606393" y="2554833"/>
-            <a:ext cx="4945075" cy="1806854"/>
+            <a:ext cx="4945075" cy="1730776"/>
           </a:xfrm>
           <a:prstGeom prst="roundRect">
             <a:avLst/>
@@ -9252,8 +9340,8 @@
         </p:nvSpPr>
         <p:spPr>
           <a:xfrm>
-            <a:off x="3701491" y="4856195"/>
-            <a:ext cx="3899001" cy="323331"/>
+            <a:off x="3701491" y="4409236"/>
+            <a:ext cx="1426463" cy="228234"/>
           </a:xfrm>
           <a:prstGeom prst="roundRect">
             <a:avLst/>
@@ -9296,6 +9384,94 @@
         </p:nvSpPr>
         <p:spPr>
           <a:xfrm>
+            <a:off x="5223052" y="4409236"/>
+            <a:ext cx="1426463" cy="228234"/>
+          </a:xfrm>
+          <a:prstGeom prst="roundRect">
+            <a:avLst/>
+          </a:prstGeom>
+          <a:solidFill>
+            <a:srgbClr val="16303A"/>
+          </a:solidFill>
+          <a:ln>
+            <a:noFill/>
+          </a:ln>
+          <a:effectLst/>
+        </p:spPr>
+        <p:style>
+          <a:lnRef idx="1">
+            <a:schemeClr val="accent1"/>
+          </a:lnRef>
+          <a:fillRef idx="3">
+            <a:schemeClr val="accent1"/>
+          </a:fillRef>
+          <a:effectRef idx="2">
+            <a:schemeClr val="accent1"/>
+          </a:effectRef>
+          <a:fontRef idx="minor">
+            <a:schemeClr val="lt1"/>
+          </a:fontRef>
+        </p:style>
+        <p:txBody>
+          <a:bodyPr rtlCol="0" anchor="ctr"/>
+          <a:lstStyle/>
+          <a:p>
+            <a:pPr algn="ctr"/>
+          </a:p>
+        </p:txBody>
+      </p:sp>
+      <p:sp>
+        <p:nvSpPr>
+          <p:cNvPr id="13" name="Rounded Rectangle 12"/>
+          <p:cNvSpPr/>
+          <p:nvPr/>
+        </p:nvSpPr>
+        <p:spPr>
+          <a:xfrm>
+            <a:off x="3701491" y="4856195"/>
+            <a:ext cx="3899001" cy="323331"/>
+          </a:xfrm>
+          <a:prstGeom prst="roundRect">
+            <a:avLst/>
+          </a:prstGeom>
+          <a:solidFill>
+            <a:srgbClr val="16303A"/>
+          </a:solidFill>
+          <a:ln>
+            <a:noFill/>
+          </a:ln>
+          <a:effectLst/>
+        </p:spPr>
+        <p:style>
+          <a:lnRef idx="1">
+            <a:schemeClr val="accent1"/>
+          </a:lnRef>
+          <a:fillRef idx="3">
+            <a:schemeClr val="accent1"/>
+          </a:fillRef>
+          <a:effectRef idx="2">
+            <a:schemeClr val="accent1"/>
+          </a:effectRef>
+          <a:fontRef idx="minor">
+            <a:schemeClr val="lt1"/>
+          </a:fontRef>
+        </p:style>
+        <p:txBody>
+          <a:bodyPr rtlCol="0" anchor="ctr"/>
+          <a:lstStyle/>
+          <a:p>
+            <a:pPr algn="ctr"/>
+          </a:p>
+        </p:txBody>
+      </p:sp>
+      <p:sp>
+        <p:nvSpPr>
+          <p:cNvPr id="14" name="Rounded Rectangle 13"/>
+          <p:cNvSpPr/>
+          <p:nvPr/>
+        </p:nvSpPr>
+        <p:spPr>
+          <a:xfrm>
             <a:off x="7695590" y="4856195"/>
             <a:ext cx="779800" cy="323331"/>
           </a:xfrm>
@@ -9334,7 +9510,7 @@
       </p:sp>
       <p:sp>
         <p:nvSpPr>
-          <p:cNvPr id="13" name="Rounded Rectangle 12"/>
+          <p:cNvPr id="15" name="Rounded Rectangle 14"/>
           <p:cNvSpPr/>
           <p:nvPr/>
         </p:nvSpPr>
@@ -9378,7 +9554,7 @@
       </p:sp>
       <p:sp>
         <p:nvSpPr>
-          <p:cNvPr id="14" name="Rounded Rectangle 13"/>
+          <p:cNvPr id="16" name="Rounded Rectangle 15"/>
           <p:cNvSpPr/>
           <p:nvPr/>
         </p:nvSpPr>
@@ -9422,7 +9598,7 @@
       </p:sp>
       <p:sp>
         <p:nvSpPr>
-          <p:cNvPr id="15" name="TextBox 14"/>
+          <p:cNvPr id="17" name="TextBox 16"/>
           <p:cNvSpPr txBox="1"/>
           <p:nvPr/>
         </p:nvSpPr>
@@ -11281,7 +11457,7 @@
         <p:spPr>
           <a:xfrm>
             <a:off x="3606393" y="2554833"/>
-            <a:ext cx="4945075" cy="1806854"/>
+            <a:ext cx="4945075" cy="1730776"/>
           </a:xfrm>
           <a:prstGeom prst="roundRect">
             <a:avLst/>
@@ -11456,8 +11632,8 @@
         </p:nvSpPr>
         <p:spPr>
           <a:xfrm>
-            <a:off x="3701491" y="4856195"/>
-            <a:ext cx="3899001" cy="323331"/>
+            <a:off x="3701491" y="4409236"/>
+            <a:ext cx="1426463" cy="228234"/>
           </a:xfrm>
           <a:prstGeom prst="roundRect">
             <a:avLst/>
@@ -11500,6 +11676,94 @@
         </p:nvSpPr>
         <p:spPr>
           <a:xfrm>
+            <a:off x="5223052" y="4409236"/>
+            <a:ext cx="1426463" cy="228234"/>
+          </a:xfrm>
+          <a:prstGeom prst="roundRect">
+            <a:avLst/>
+          </a:prstGeom>
+          <a:solidFill>
+            <a:srgbClr val="16303A"/>
+          </a:solidFill>
+          <a:ln>
+            <a:noFill/>
+          </a:ln>
+          <a:effectLst/>
+        </p:spPr>
+        <p:style>
+          <a:lnRef idx="1">
+            <a:schemeClr val="accent1"/>
+          </a:lnRef>
+          <a:fillRef idx="3">
+            <a:schemeClr val="accent1"/>
+          </a:fillRef>
+          <a:effectRef idx="2">
+            <a:schemeClr val="accent1"/>
+          </a:effectRef>
+          <a:fontRef idx="minor">
+            <a:schemeClr val="lt1"/>
+          </a:fontRef>
+        </p:style>
+        <p:txBody>
+          <a:bodyPr rtlCol="0" anchor="ctr"/>
+          <a:lstStyle/>
+          <a:p>
+            <a:pPr algn="ctr"/>
+          </a:p>
+        </p:txBody>
+      </p:sp>
+      <p:sp>
+        <p:nvSpPr>
+          <p:cNvPr id="13" name="Rounded Rectangle 12"/>
+          <p:cNvSpPr/>
+          <p:nvPr/>
+        </p:nvSpPr>
+        <p:spPr>
+          <a:xfrm>
+            <a:off x="3701491" y="4856195"/>
+            <a:ext cx="3899001" cy="323331"/>
+          </a:xfrm>
+          <a:prstGeom prst="roundRect">
+            <a:avLst/>
+          </a:prstGeom>
+          <a:solidFill>
+            <a:srgbClr val="16303A"/>
+          </a:solidFill>
+          <a:ln>
+            <a:noFill/>
+          </a:ln>
+          <a:effectLst/>
+        </p:spPr>
+        <p:style>
+          <a:lnRef idx="1">
+            <a:schemeClr val="accent1"/>
+          </a:lnRef>
+          <a:fillRef idx="3">
+            <a:schemeClr val="accent1"/>
+          </a:fillRef>
+          <a:effectRef idx="2">
+            <a:schemeClr val="accent1"/>
+          </a:effectRef>
+          <a:fontRef idx="minor">
+            <a:schemeClr val="lt1"/>
+          </a:fontRef>
+        </p:style>
+        <p:txBody>
+          <a:bodyPr rtlCol="0" anchor="ctr"/>
+          <a:lstStyle/>
+          <a:p>
+            <a:pPr algn="ctr"/>
+          </a:p>
+        </p:txBody>
+      </p:sp>
+      <p:sp>
+        <p:nvSpPr>
+          <p:cNvPr id="14" name="Rounded Rectangle 13"/>
+          <p:cNvSpPr/>
+          <p:nvPr/>
+        </p:nvSpPr>
+        <p:spPr>
+          <a:xfrm>
             <a:off x="7695590" y="4856195"/>
             <a:ext cx="779800" cy="323331"/>
           </a:xfrm>
@@ -11538,7 +11802,7 @@
       </p:sp>
       <p:sp>
         <p:nvSpPr>
-          <p:cNvPr id="13" name="Rounded Rectangle 12"/>
+          <p:cNvPr id="15" name="Rounded Rectangle 14"/>
           <p:cNvSpPr/>
           <p:nvPr/>
         </p:nvSpPr>
@@ -11582,7 +11846,7 @@
       </p:sp>
       <p:sp>
         <p:nvSpPr>
-          <p:cNvPr id="14" name="Rounded Rectangle 13"/>
+          <p:cNvPr id="16" name="Rounded Rectangle 15"/>
           <p:cNvSpPr/>
           <p:nvPr/>
         </p:nvSpPr>
@@ -11626,7 +11890,7 @@
       </p:sp>
       <p:sp>
         <p:nvSpPr>
-          <p:cNvPr id="15" name="TextBox 14"/>
+          <p:cNvPr id="17" name="TextBox 16"/>
           <p:cNvSpPr txBox="1"/>
           <p:nvPr/>
         </p:nvSpPr>
@@ -16039,7 +16303,7 @@
         <p:spPr>
           <a:xfrm>
             <a:off x="3606393" y="2554833"/>
-            <a:ext cx="4945075" cy="1806854"/>
+            <a:ext cx="4945075" cy="1730776"/>
           </a:xfrm>
           <a:prstGeom prst="roundRect">
             <a:avLst/>
@@ -16214,8 +16478,8 @@
         </p:nvSpPr>
         <p:spPr>
           <a:xfrm>
-            <a:off x="3701491" y="4856195"/>
-            <a:ext cx="3899001" cy="323331"/>
+            <a:off x="3701491" y="4409236"/>
+            <a:ext cx="1426463" cy="228234"/>
           </a:xfrm>
           <a:prstGeom prst="roundRect">
             <a:avLst/>
@@ -16258,6 +16522,94 @@
         </p:nvSpPr>
         <p:spPr>
           <a:xfrm>
+            <a:off x="5223052" y="4409236"/>
+            <a:ext cx="1426463" cy="228234"/>
+          </a:xfrm>
+          <a:prstGeom prst="roundRect">
+            <a:avLst/>
+          </a:prstGeom>
+          <a:solidFill>
+            <a:srgbClr val="16303A"/>
+          </a:solidFill>
+          <a:ln>
+            <a:noFill/>
+          </a:ln>
+          <a:effectLst/>
+        </p:spPr>
+        <p:style>
+          <a:lnRef idx="1">
+            <a:schemeClr val="accent1"/>
+          </a:lnRef>
+          <a:fillRef idx="3">
+            <a:schemeClr val="accent1"/>
+          </a:fillRef>
+          <a:effectRef idx="2">
+            <a:schemeClr val="accent1"/>
+          </a:effectRef>
+          <a:fontRef idx="minor">
+            <a:schemeClr val="lt1"/>
+          </a:fontRef>
+        </p:style>
+        <p:txBody>
+          <a:bodyPr rtlCol="0" anchor="ctr"/>
+          <a:lstStyle/>
+          <a:p>
+            <a:pPr algn="ctr"/>
+          </a:p>
+        </p:txBody>
+      </p:sp>
+      <p:sp>
+        <p:nvSpPr>
+          <p:cNvPr id="13" name="Rounded Rectangle 12"/>
+          <p:cNvSpPr/>
+          <p:nvPr/>
+        </p:nvSpPr>
+        <p:spPr>
+          <a:xfrm>
+            <a:off x="3701491" y="4856195"/>
+            <a:ext cx="3899001" cy="323331"/>
+          </a:xfrm>
+          <a:prstGeom prst="roundRect">
+            <a:avLst/>
+          </a:prstGeom>
+          <a:solidFill>
+            <a:srgbClr val="16303A"/>
+          </a:solidFill>
+          <a:ln>
+            <a:noFill/>
+          </a:ln>
+          <a:effectLst/>
+        </p:spPr>
+        <p:style>
+          <a:lnRef idx="1">
+            <a:schemeClr val="accent1"/>
+          </a:lnRef>
+          <a:fillRef idx="3">
+            <a:schemeClr val="accent1"/>
+          </a:fillRef>
+          <a:effectRef idx="2">
+            <a:schemeClr val="accent1"/>
+          </a:effectRef>
+          <a:fontRef idx="minor">
+            <a:schemeClr val="lt1"/>
+          </a:fontRef>
+        </p:style>
+        <p:txBody>
+          <a:bodyPr rtlCol="0" anchor="ctr"/>
+          <a:lstStyle/>
+          <a:p>
+            <a:pPr algn="ctr"/>
+          </a:p>
+        </p:txBody>
+      </p:sp>
+      <p:sp>
+        <p:nvSpPr>
+          <p:cNvPr id="14" name="Rounded Rectangle 13"/>
+          <p:cNvSpPr/>
+          <p:nvPr/>
+        </p:nvSpPr>
+        <p:spPr>
+          <a:xfrm>
             <a:off x="7695590" y="4856195"/>
             <a:ext cx="779800" cy="323331"/>
           </a:xfrm>
@@ -16296,7 +16648,7 @@
       </p:sp>
       <p:sp>
         <p:nvSpPr>
-          <p:cNvPr id="13" name="Rounded Rectangle 12"/>
+          <p:cNvPr id="15" name="Rounded Rectangle 14"/>
           <p:cNvSpPr/>
           <p:nvPr/>
         </p:nvSpPr>
@@ -16340,7 +16692,7 @@
       </p:sp>
       <p:sp>
         <p:nvSpPr>
-          <p:cNvPr id="14" name="Rounded Rectangle 13"/>
+          <p:cNvPr id="16" name="Rounded Rectangle 15"/>
           <p:cNvSpPr/>
           <p:nvPr/>
         </p:nvSpPr>
@@ -16384,7 +16736,7 @@
       </p:sp>
       <p:sp>
         <p:nvSpPr>
-          <p:cNvPr id="15" name="TextBox 14"/>
+          <p:cNvPr id="17" name="TextBox 16"/>
           <p:cNvSpPr txBox="1"/>
           <p:nvPr/>
         </p:nvSpPr>
@@ -17612,7 +17964,7 @@
         <p:spPr>
           <a:xfrm>
             <a:off x="3606393" y="2554833"/>
-            <a:ext cx="4945075" cy="1806854"/>
+            <a:ext cx="4945075" cy="1730776"/>
           </a:xfrm>
           <a:prstGeom prst="roundRect">
             <a:avLst/>
@@ -17787,8 +18139,8 @@
         </p:nvSpPr>
         <p:spPr>
           <a:xfrm>
-            <a:off x="3701491" y="4856195"/>
-            <a:ext cx="3899001" cy="323331"/>
+            <a:off x="3701491" y="4409236"/>
+            <a:ext cx="1426463" cy="228234"/>
           </a:xfrm>
           <a:prstGeom prst="roundRect">
             <a:avLst/>
@@ -17831,6 +18183,94 @@
         </p:nvSpPr>
         <p:spPr>
           <a:xfrm>
+            <a:off x="5223052" y="4409236"/>
+            <a:ext cx="1426463" cy="228234"/>
+          </a:xfrm>
+          <a:prstGeom prst="roundRect">
+            <a:avLst/>
+          </a:prstGeom>
+          <a:solidFill>
+            <a:srgbClr val="16303A"/>
+          </a:solidFill>
+          <a:ln>
+            <a:noFill/>
+          </a:ln>
+          <a:effectLst/>
+        </p:spPr>
+        <p:style>
+          <a:lnRef idx="1">
+            <a:schemeClr val="accent1"/>
+          </a:lnRef>
+          <a:fillRef idx="3">
+            <a:schemeClr val="accent1"/>
+          </a:fillRef>
+          <a:effectRef idx="2">
+            <a:schemeClr val="accent1"/>
+          </a:effectRef>
+          <a:fontRef idx="minor">
+            <a:schemeClr val="lt1"/>
+          </a:fontRef>
+        </p:style>
+        <p:txBody>
+          <a:bodyPr rtlCol="0" anchor="ctr"/>
+          <a:lstStyle/>
+          <a:p>
+            <a:pPr algn="ctr"/>
+          </a:p>
+        </p:txBody>
+      </p:sp>
+      <p:sp>
+        <p:nvSpPr>
+          <p:cNvPr id="13" name="Rounded Rectangle 12"/>
+          <p:cNvSpPr/>
+          <p:nvPr/>
+        </p:nvSpPr>
+        <p:spPr>
+          <a:xfrm>
+            <a:off x="3701491" y="4856195"/>
+            <a:ext cx="3899001" cy="323331"/>
+          </a:xfrm>
+          <a:prstGeom prst="roundRect">
+            <a:avLst/>
+          </a:prstGeom>
+          <a:solidFill>
+            <a:srgbClr val="16303A"/>
+          </a:solidFill>
+          <a:ln>
+            <a:noFill/>
+          </a:ln>
+          <a:effectLst/>
+        </p:spPr>
+        <p:style>
+          <a:lnRef idx="1">
+            <a:schemeClr val="accent1"/>
+          </a:lnRef>
+          <a:fillRef idx="3">
+            <a:schemeClr val="accent1"/>
+          </a:fillRef>
+          <a:effectRef idx="2">
+            <a:schemeClr val="accent1"/>
+          </a:effectRef>
+          <a:fontRef idx="minor">
+            <a:schemeClr val="lt1"/>
+          </a:fontRef>
+        </p:style>
+        <p:txBody>
+          <a:bodyPr rtlCol="0" anchor="ctr"/>
+          <a:lstStyle/>
+          <a:p>
+            <a:pPr algn="ctr"/>
+          </a:p>
+        </p:txBody>
+      </p:sp>
+      <p:sp>
+        <p:nvSpPr>
+          <p:cNvPr id="14" name="Rounded Rectangle 13"/>
+          <p:cNvSpPr/>
+          <p:nvPr/>
+        </p:nvSpPr>
+        <p:spPr>
+          <a:xfrm>
             <a:off x="7695590" y="4856195"/>
             <a:ext cx="779800" cy="323331"/>
           </a:xfrm>
@@ -17869,7 +18309,7 @@
       </p:sp>
       <p:sp>
         <p:nvSpPr>
-          <p:cNvPr id="13" name="Rounded Rectangle 12"/>
+          <p:cNvPr id="15" name="Rounded Rectangle 14"/>
           <p:cNvSpPr/>
           <p:nvPr/>
         </p:nvSpPr>
@@ -17913,7 +18353,7 @@
       </p:sp>
       <p:sp>
         <p:nvSpPr>
-          <p:cNvPr id="14" name="Rounded Rectangle 13"/>
+          <p:cNvPr id="16" name="Rounded Rectangle 15"/>
           <p:cNvSpPr/>
           <p:nvPr/>
         </p:nvSpPr>
@@ -17957,7 +18397,7 @@
       </p:sp>
       <p:sp>
         <p:nvSpPr>
-          <p:cNvPr id="15" name="TextBox 14"/>
+          <p:cNvPr id="17" name="TextBox 16"/>
           <p:cNvSpPr txBox="1"/>
           <p:nvPr/>
         </p:nvSpPr>
@@ -18526,7 +18966,7 @@
         <p:spPr>
           <a:xfrm>
             <a:off x="3606393" y="2554833"/>
-            <a:ext cx="4945075" cy="1806854"/>
+            <a:ext cx="4945075" cy="1730776"/>
           </a:xfrm>
           <a:prstGeom prst="roundRect">
             <a:avLst/>
@@ -18701,8 +19141,8 @@
         </p:nvSpPr>
         <p:spPr>
           <a:xfrm>
-            <a:off x="3701491" y="4856195"/>
-            <a:ext cx="3899001" cy="323331"/>
+            <a:off x="3701491" y="4409236"/>
+            <a:ext cx="1426463" cy="228234"/>
           </a:xfrm>
           <a:prstGeom prst="roundRect">
             <a:avLst/>
@@ -18745,6 +19185,94 @@
         </p:nvSpPr>
         <p:spPr>
           <a:xfrm>
+            <a:off x="5223052" y="4409236"/>
+            <a:ext cx="1426463" cy="228234"/>
+          </a:xfrm>
+          <a:prstGeom prst="roundRect">
+            <a:avLst/>
+          </a:prstGeom>
+          <a:solidFill>
+            <a:srgbClr val="16303A"/>
+          </a:solidFill>
+          <a:ln>
+            <a:noFill/>
+          </a:ln>
+          <a:effectLst/>
+        </p:spPr>
+        <p:style>
+          <a:lnRef idx="1">
+            <a:schemeClr val="accent1"/>
+          </a:lnRef>
+          <a:fillRef idx="3">
+            <a:schemeClr val="accent1"/>
+          </a:fillRef>
+          <a:effectRef idx="2">
+            <a:schemeClr val="accent1"/>
+          </a:effectRef>
+          <a:fontRef idx="minor">
+            <a:schemeClr val="lt1"/>
+          </a:fontRef>
+        </p:style>
+        <p:txBody>
+          <a:bodyPr rtlCol="0" anchor="ctr"/>
+          <a:lstStyle/>
+          <a:p>
+            <a:pPr algn="ctr"/>
+          </a:p>
+        </p:txBody>
+      </p:sp>
+      <p:sp>
+        <p:nvSpPr>
+          <p:cNvPr id="13" name="Rounded Rectangle 12"/>
+          <p:cNvSpPr/>
+          <p:nvPr/>
+        </p:nvSpPr>
+        <p:spPr>
+          <a:xfrm>
+            <a:off x="3701491" y="4856195"/>
+            <a:ext cx="3899001" cy="323331"/>
+          </a:xfrm>
+          <a:prstGeom prst="roundRect">
+            <a:avLst/>
+          </a:prstGeom>
+          <a:solidFill>
+            <a:srgbClr val="16303A"/>
+          </a:solidFill>
+          <a:ln>
+            <a:noFill/>
+          </a:ln>
+          <a:effectLst/>
+        </p:spPr>
+        <p:style>
+          <a:lnRef idx="1">
+            <a:schemeClr val="accent1"/>
+          </a:lnRef>
+          <a:fillRef idx="3">
+            <a:schemeClr val="accent1"/>
+          </a:fillRef>
+          <a:effectRef idx="2">
+            <a:schemeClr val="accent1"/>
+          </a:effectRef>
+          <a:fontRef idx="minor">
+            <a:schemeClr val="lt1"/>
+          </a:fontRef>
+        </p:style>
+        <p:txBody>
+          <a:bodyPr rtlCol="0" anchor="ctr"/>
+          <a:lstStyle/>
+          <a:p>
+            <a:pPr algn="ctr"/>
+          </a:p>
+        </p:txBody>
+      </p:sp>
+      <p:sp>
+        <p:nvSpPr>
+          <p:cNvPr id="14" name="Rounded Rectangle 13"/>
+          <p:cNvSpPr/>
+          <p:nvPr/>
+        </p:nvSpPr>
+        <p:spPr>
+          <a:xfrm>
             <a:off x="7695590" y="4856195"/>
             <a:ext cx="779800" cy="323331"/>
           </a:xfrm>
@@ -18783,7 +19311,7 @@
       </p:sp>
       <p:sp>
         <p:nvSpPr>
-          <p:cNvPr id="13" name="Rounded Rectangle 12"/>
+          <p:cNvPr id="15" name="Rounded Rectangle 14"/>
           <p:cNvSpPr/>
           <p:nvPr/>
         </p:nvSpPr>
@@ -18827,7 +19355,7 @@
       </p:sp>
       <p:sp>
         <p:nvSpPr>
-          <p:cNvPr id="14" name="Rounded Rectangle 13"/>
+          <p:cNvPr id="16" name="Rounded Rectangle 15"/>
           <p:cNvSpPr/>
           <p:nvPr/>
         </p:nvSpPr>
@@ -18871,7 +19399,7 @@
       </p:sp>
       <p:sp>
         <p:nvSpPr>
-          <p:cNvPr id="15" name="TextBox 14"/>
+          <p:cNvPr id="17" name="TextBox 16"/>
           <p:cNvSpPr txBox="1"/>
           <p:nvPr/>
         </p:nvSpPr>
@@ -20102,7 +20630,7 @@
         <p:spPr>
           <a:xfrm>
             <a:off x="3606393" y="2554833"/>
-            <a:ext cx="4945075" cy="1806854"/>
+            <a:ext cx="4945075" cy="1730776"/>
           </a:xfrm>
           <a:prstGeom prst="roundRect">
             <a:avLst/>
@@ -20277,8 +20805,8 @@
         </p:nvSpPr>
         <p:spPr>
           <a:xfrm>
-            <a:off x="3701491" y="4856195"/>
-            <a:ext cx="3899001" cy="323331"/>
+            <a:off x="3701491" y="4409236"/>
+            <a:ext cx="1426463" cy="228234"/>
           </a:xfrm>
           <a:prstGeom prst="roundRect">
             <a:avLst/>
@@ -20321,6 +20849,94 @@
         </p:nvSpPr>
         <p:spPr>
           <a:xfrm>
+            <a:off x="5223052" y="4409236"/>
+            <a:ext cx="1426463" cy="228234"/>
+          </a:xfrm>
+          <a:prstGeom prst="roundRect">
+            <a:avLst/>
+          </a:prstGeom>
+          <a:solidFill>
+            <a:srgbClr val="16303A"/>
+          </a:solidFill>
+          <a:ln>
+            <a:noFill/>
+          </a:ln>
+          <a:effectLst/>
+        </p:spPr>
+        <p:style>
+          <a:lnRef idx="1">
+            <a:schemeClr val="accent1"/>
+          </a:lnRef>
+          <a:fillRef idx="3">
+            <a:schemeClr val="accent1"/>
+          </a:fillRef>
+          <a:effectRef idx="2">
+            <a:schemeClr val="accent1"/>
+          </a:effectRef>
+          <a:fontRef idx="minor">
+            <a:schemeClr val="lt1"/>
+          </a:fontRef>
+        </p:style>
+        <p:txBody>
+          <a:bodyPr rtlCol="0" anchor="ctr"/>
+          <a:lstStyle/>
+          <a:p>
+            <a:pPr algn="ctr"/>
+          </a:p>
+        </p:txBody>
+      </p:sp>
+      <p:sp>
+        <p:nvSpPr>
+          <p:cNvPr id="13" name="Rounded Rectangle 12"/>
+          <p:cNvSpPr/>
+          <p:nvPr/>
+        </p:nvSpPr>
+        <p:spPr>
+          <a:xfrm>
+            <a:off x="3701491" y="4856195"/>
+            <a:ext cx="3899001" cy="323331"/>
+          </a:xfrm>
+          <a:prstGeom prst="roundRect">
+            <a:avLst/>
+          </a:prstGeom>
+          <a:solidFill>
+            <a:srgbClr val="16303A"/>
+          </a:solidFill>
+          <a:ln>
+            <a:noFill/>
+          </a:ln>
+          <a:effectLst/>
+        </p:spPr>
+        <p:style>
+          <a:lnRef idx="1">
+            <a:schemeClr val="accent1"/>
+          </a:lnRef>
+          <a:fillRef idx="3">
+            <a:schemeClr val="accent1"/>
+          </a:fillRef>
+          <a:effectRef idx="2">
+            <a:schemeClr val="accent1"/>
+          </a:effectRef>
+          <a:fontRef idx="minor">
+            <a:schemeClr val="lt1"/>
+          </a:fontRef>
+        </p:style>
+        <p:txBody>
+          <a:bodyPr rtlCol="0" anchor="ctr"/>
+          <a:lstStyle/>
+          <a:p>
+            <a:pPr algn="ctr"/>
+          </a:p>
+        </p:txBody>
+      </p:sp>
+      <p:sp>
+        <p:nvSpPr>
+          <p:cNvPr id="14" name="Rounded Rectangle 13"/>
+          <p:cNvSpPr/>
+          <p:nvPr/>
+        </p:nvSpPr>
+        <p:spPr>
+          <a:xfrm>
             <a:off x="7695590" y="4856195"/>
             <a:ext cx="779800" cy="323331"/>
           </a:xfrm>
@@ -20359,7 +20975,7 @@
       </p:sp>
       <p:sp>
         <p:nvSpPr>
-          <p:cNvPr id="13" name="Rounded Rectangle 12"/>
+          <p:cNvPr id="15" name="Rounded Rectangle 14"/>
           <p:cNvSpPr/>
           <p:nvPr/>
         </p:nvSpPr>
@@ -20403,7 +21019,7 @@
       </p:sp>
       <p:sp>
         <p:nvSpPr>
-          <p:cNvPr id="14" name="Rounded Rectangle 13"/>
+          <p:cNvPr id="16" name="Rounded Rectangle 15"/>
           <p:cNvSpPr/>
           <p:nvPr/>
         </p:nvSpPr>
@@ -20447,7 +21063,7 @@
       </p:sp>
       <p:sp>
         <p:nvSpPr>
-          <p:cNvPr id="15" name="TextBox 14"/>
+          <p:cNvPr id="17" name="TextBox 16"/>
           <p:cNvSpPr txBox="1"/>
           <p:nvPr/>
         </p:nvSpPr>
@@ -20981,7 +21597,7 @@
         <p:spPr>
           <a:xfrm>
             <a:off x="3606393" y="2554833"/>
-            <a:ext cx="4945075" cy="1806854"/>
+            <a:ext cx="4945075" cy="1730776"/>
           </a:xfrm>
           <a:prstGeom prst="roundRect">
             <a:avLst/>
@@ -21156,8 +21772,8 @@
         </p:nvSpPr>
         <p:spPr>
           <a:xfrm>
-            <a:off x="3701491" y="4856195"/>
-            <a:ext cx="3899001" cy="323331"/>
+            <a:off x="3701491" y="4409236"/>
+            <a:ext cx="1426463" cy="228234"/>
           </a:xfrm>
           <a:prstGeom prst="roundRect">
             <a:avLst/>
@@ -21200,6 +21816,94 @@
         </p:nvSpPr>
         <p:spPr>
           <a:xfrm>
+            <a:off x="5223052" y="4409236"/>
+            <a:ext cx="1426463" cy="228234"/>
+          </a:xfrm>
+          <a:prstGeom prst="roundRect">
+            <a:avLst/>
+          </a:prstGeom>
+          <a:solidFill>
+            <a:srgbClr val="16303A"/>
+          </a:solidFill>
+          <a:ln>
+            <a:noFill/>
+          </a:ln>
+          <a:effectLst/>
+        </p:spPr>
+        <p:style>
+          <a:lnRef idx="1">
+            <a:schemeClr val="accent1"/>
+          </a:lnRef>
+          <a:fillRef idx="3">
+            <a:schemeClr val="accent1"/>
+          </a:fillRef>
+          <a:effectRef idx="2">
+            <a:schemeClr val="accent1"/>
+          </a:effectRef>
+          <a:fontRef idx="minor">
+            <a:schemeClr val="lt1"/>
+          </a:fontRef>
+        </p:style>
+        <p:txBody>
+          <a:bodyPr rtlCol="0" anchor="ctr"/>
+          <a:lstStyle/>
+          <a:p>
+            <a:pPr algn="ctr"/>
+          </a:p>
+        </p:txBody>
+      </p:sp>
+      <p:sp>
+        <p:nvSpPr>
+          <p:cNvPr id="13" name="Rounded Rectangle 12"/>
+          <p:cNvSpPr/>
+          <p:nvPr/>
+        </p:nvSpPr>
+        <p:spPr>
+          <a:xfrm>
+            <a:off x="3701491" y="4856195"/>
+            <a:ext cx="3899001" cy="323331"/>
+          </a:xfrm>
+          <a:prstGeom prst="roundRect">
+            <a:avLst/>
+          </a:prstGeom>
+          <a:solidFill>
+            <a:srgbClr val="16303A"/>
+          </a:solidFill>
+          <a:ln>
+            <a:noFill/>
+          </a:ln>
+          <a:effectLst/>
+        </p:spPr>
+        <p:style>
+          <a:lnRef idx="1">
+            <a:schemeClr val="accent1"/>
+          </a:lnRef>
+          <a:fillRef idx="3">
+            <a:schemeClr val="accent1"/>
+          </a:fillRef>
+          <a:effectRef idx="2">
+            <a:schemeClr val="accent1"/>
+          </a:effectRef>
+          <a:fontRef idx="minor">
+            <a:schemeClr val="lt1"/>
+          </a:fontRef>
+        </p:style>
+        <p:txBody>
+          <a:bodyPr rtlCol="0" anchor="ctr"/>
+          <a:lstStyle/>
+          <a:p>
+            <a:pPr algn="ctr"/>
+          </a:p>
+        </p:txBody>
+      </p:sp>
+      <p:sp>
+        <p:nvSpPr>
+          <p:cNvPr id="14" name="Rounded Rectangle 13"/>
+          <p:cNvSpPr/>
+          <p:nvPr/>
+        </p:nvSpPr>
+        <p:spPr>
+          <a:xfrm>
             <a:off x="7695590" y="4856195"/>
             <a:ext cx="779800" cy="323331"/>
           </a:xfrm>
@@ -21238,7 +21942,7 @@
       </p:sp>
       <p:sp>
         <p:nvSpPr>
-          <p:cNvPr id="13" name="Rounded Rectangle 12"/>
+          <p:cNvPr id="15" name="Rounded Rectangle 14"/>
           <p:cNvSpPr/>
           <p:nvPr/>
         </p:nvSpPr>
@@ -21282,7 +21986,7 @@
       </p:sp>
       <p:sp>
         <p:nvSpPr>
-          <p:cNvPr id="14" name="Rounded Rectangle 13"/>
+          <p:cNvPr id="16" name="Rounded Rectangle 15"/>
           <p:cNvSpPr/>
           <p:nvPr/>
         </p:nvSpPr>
@@ -21326,7 +22030,7 @@
       </p:sp>
       <p:sp>
         <p:nvSpPr>
-          <p:cNvPr id="15" name="TextBox 14"/>
+          <p:cNvPr id="17" name="TextBox 16"/>
           <p:cNvSpPr txBox="1"/>
           <p:nvPr/>
         </p:nvSpPr>
@@ -21860,7 +22564,7 @@
         <p:spPr>
           <a:xfrm>
             <a:off x="3606393" y="2554833"/>
-            <a:ext cx="4945075" cy="1806854"/>
+            <a:ext cx="4945075" cy="1730776"/>
           </a:xfrm>
           <a:prstGeom prst="roundRect">
             <a:avLst/>
@@ -22035,8 +22739,8 @@
         </p:nvSpPr>
         <p:spPr>
           <a:xfrm>
-            <a:off x="3701491" y="4856195"/>
-            <a:ext cx="3899001" cy="323331"/>
+            <a:off x="3701491" y="4409236"/>
+            <a:ext cx="1426463" cy="228234"/>
           </a:xfrm>
           <a:prstGeom prst="roundRect">
             <a:avLst/>
@@ -22079,6 +22783,94 @@
         </p:nvSpPr>
         <p:spPr>
           <a:xfrm>
+            <a:off x="5223052" y="4409236"/>
+            <a:ext cx="1426463" cy="228234"/>
+          </a:xfrm>
+          <a:prstGeom prst="roundRect">
+            <a:avLst/>
+          </a:prstGeom>
+          <a:solidFill>
+            <a:srgbClr val="16303A"/>
+          </a:solidFill>
+          <a:ln>
+            <a:noFill/>
+          </a:ln>
+          <a:effectLst/>
+        </p:spPr>
+        <p:style>
+          <a:lnRef idx="1">
+            <a:schemeClr val="accent1"/>
+          </a:lnRef>
+          <a:fillRef idx="3">
+            <a:schemeClr val="accent1"/>
+          </a:fillRef>
+          <a:effectRef idx="2">
+            <a:schemeClr val="accent1"/>
+          </a:effectRef>
+          <a:fontRef idx="minor">
+            <a:schemeClr val="lt1"/>
+          </a:fontRef>
+        </p:style>
+        <p:txBody>
+          <a:bodyPr rtlCol="0" anchor="ctr"/>
+          <a:lstStyle/>
+          <a:p>
+            <a:pPr algn="ctr"/>
+          </a:p>
+        </p:txBody>
+      </p:sp>
+      <p:sp>
+        <p:nvSpPr>
+          <p:cNvPr id="13" name="Rounded Rectangle 12"/>
+          <p:cNvSpPr/>
+          <p:nvPr/>
+        </p:nvSpPr>
+        <p:spPr>
+          <a:xfrm>
+            <a:off x="3701491" y="4856195"/>
+            <a:ext cx="3899001" cy="323331"/>
+          </a:xfrm>
+          <a:prstGeom prst="roundRect">
+            <a:avLst/>
+          </a:prstGeom>
+          <a:solidFill>
+            <a:srgbClr val="16303A"/>
+          </a:solidFill>
+          <a:ln>
+            <a:noFill/>
+          </a:ln>
+          <a:effectLst/>
+        </p:spPr>
+        <p:style>
+          <a:lnRef idx="1">
+            <a:schemeClr val="accent1"/>
+          </a:lnRef>
+          <a:fillRef idx="3">
+            <a:schemeClr val="accent1"/>
+          </a:fillRef>
+          <a:effectRef idx="2">
+            <a:schemeClr val="accent1"/>
+          </a:effectRef>
+          <a:fontRef idx="minor">
+            <a:schemeClr val="lt1"/>
+          </a:fontRef>
+        </p:style>
+        <p:txBody>
+          <a:bodyPr rtlCol="0" anchor="ctr"/>
+          <a:lstStyle/>
+          <a:p>
+            <a:pPr algn="ctr"/>
+          </a:p>
+        </p:txBody>
+      </p:sp>
+      <p:sp>
+        <p:nvSpPr>
+          <p:cNvPr id="14" name="Rounded Rectangle 13"/>
+          <p:cNvSpPr/>
+          <p:nvPr/>
+        </p:nvSpPr>
+        <p:spPr>
+          <a:xfrm>
             <a:off x="7695590" y="4856195"/>
             <a:ext cx="779800" cy="323331"/>
           </a:xfrm>
@@ -22117,7 +22909,7 @@
       </p:sp>
       <p:sp>
         <p:nvSpPr>
-          <p:cNvPr id="13" name="Rounded Rectangle 12"/>
+          <p:cNvPr id="15" name="Rounded Rectangle 14"/>
           <p:cNvSpPr/>
           <p:nvPr/>
         </p:nvSpPr>
@@ -22161,7 +22953,7 @@
       </p:sp>
       <p:sp>
         <p:nvSpPr>
-          <p:cNvPr id="14" name="Rounded Rectangle 13"/>
+          <p:cNvPr id="16" name="Rounded Rectangle 15"/>
           <p:cNvSpPr/>
           <p:nvPr/>
         </p:nvSpPr>
@@ -22205,7 +22997,7 @@
       </p:sp>
       <p:sp>
         <p:nvSpPr>
-          <p:cNvPr id="15" name="TextBox 14"/>
+          <p:cNvPr id="17" name="TextBox 16"/>
           <p:cNvSpPr txBox="1"/>
           <p:nvPr/>
         </p:nvSpPr>
@@ -22726,7 +23518,7 @@
         <p:spPr>
           <a:xfrm>
             <a:off x="3606393" y="2554833"/>
-            <a:ext cx="4945075" cy="1806854"/>
+            <a:ext cx="4945075" cy="1730776"/>
           </a:xfrm>
           <a:prstGeom prst="roundRect">
             <a:avLst/>
@@ -22901,8 +23693,8 @@
         </p:nvSpPr>
         <p:spPr>
           <a:xfrm>
-            <a:off x="3701491" y="4856195"/>
-            <a:ext cx="3899001" cy="323331"/>
+            <a:off x="3701491" y="4409236"/>
+            <a:ext cx="1426463" cy="228234"/>
           </a:xfrm>
           <a:prstGeom prst="roundRect">
             <a:avLst/>
@@ -22945,6 +23737,94 @@
         </p:nvSpPr>
         <p:spPr>
           <a:xfrm>
+            <a:off x="5223052" y="4409236"/>
+            <a:ext cx="1426463" cy="228234"/>
+          </a:xfrm>
+          <a:prstGeom prst="roundRect">
+            <a:avLst/>
+          </a:prstGeom>
+          <a:solidFill>
+            <a:srgbClr val="16303A"/>
+          </a:solidFill>
+          <a:ln>
+            <a:noFill/>
+          </a:ln>
+          <a:effectLst/>
+        </p:spPr>
+        <p:style>
+          <a:lnRef idx="1">
+            <a:schemeClr val="accent1"/>
+          </a:lnRef>
+          <a:fillRef idx="3">
+            <a:schemeClr val="accent1"/>
+          </a:fillRef>
+          <a:effectRef idx="2">
+            <a:schemeClr val="accent1"/>
+          </a:effectRef>
+          <a:fontRef idx="minor">
+            <a:schemeClr val="lt1"/>
+          </a:fontRef>
+        </p:style>
+        <p:txBody>
+          <a:bodyPr rtlCol="0" anchor="ctr"/>
+          <a:lstStyle/>
+          <a:p>
+            <a:pPr algn="ctr"/>
+          </a:p>
+        </p:txBody>
+      </p:sp>
+      <p:sp>
+        <p:nvSpPr>
+          <p:cNvPr id="13" name="Rounded Rectangle 12"/>
+          <p:cNvSpPr/>
+          <p:nvPr/>
+        </p:nvSpPr>
+        <p:spPr>
+          <a:xfrm>
+            <a:off x="3701491" y="4856195"/>
+            <a:ext cx="3899001" cy="323331"/>
+          </a:xfrm>
+          <a:prstGeom prst="roundRect">
+            <a:avLst/>
+          </a:prstGeom>
+          <a:solidFill>
+            <a:srgbClr val="16303A"/>
+          </a:solidFill>
+          <a:ln>
+            <a:noFill/>
+          </a:ln>
+          <a:effectLst/>
+        </p:spPr>
+        <p:style>
+          <a:lnRef idx="1">
+            <a:schemeClr val="accent1"/>
+          </a:lnRef>
+          <a:fillRef idx="3">
+            <a:schemeClr val="accent1"/>
+          </a:fillRef>
+          <a:effectRef idx="2">
+            <a:schemeClr val="accent1"/>
+          </a:effectRef>
+          <a:fontRef idx="minor">
+            <a:schemeClr val="lt1"/>
+          </a:fontRef>
+        </p:style>
+        <p:txBody>
+          <a:bodyPr rtlCol="0" anchor="ctr"/>
+          <a:lstStyle/>
+          <a:p>
+            <a:pPr algn="ctr"/>
+          </a:p>
+        </p:txBody>
+      </p:sp>
+      <p:sp>
+        <p:nvSpPr>
+          <p:cNvPr id="14" name="Rounded Rectangle 13"/>
+          <p:cNvSpPr/>
+          <p:nvPr/>
+        </p:nvSpPr>
+        <p:spPr>
+          <a:xfrm>
             <a:off x="7695590" y="4856195"/>
             <a:ext cx="779800" cy="323331"/>
           </a:xfrm>
@@ -22983,7 +23863,7 @@
       </p:sp>
       <p:sp>
         <p:nvSpPr>
-          <p:cNvPr id="13" name="Rounded Rectangle 12"/>
+          <p:cNvPr id="15" name="Rounded Rectangle 14"/>
           <p:cNvSpPr/>
           <p:nvPr/>
         </p:nvSpPr>
@@ -23027,7 +23907,7 @@
       </p:sp>
       <p:sp>
         <p:nvSpPr>
-          <p:cNvPr id="14" name="Rounded Rectangle 13"/>
+          <p:cNvPr id="16" name="Rounded Rectangle 15"/>
           <p:cNvSpPr/>
           <p:nvPr/>
         </p:nvSpPr>
@@ -23071,7 +23951,7 @@
       </p:sp>
       <p:sp>
         <p:nvSpPr>
-          <p:cNvPr id="15" name="TextBox 14"/>
+          <p:cNvPr id="17" name="TextBox 16"/>
           <p:cNvSpPr txBox="1"/>
           <p:nvPr/>
         </p:nvSpPr>
@@ -23630,7 +24510,7 @@
         <p:spPr>
           <a:xfrm>
             <a:off x="3606393" y="2554833"/>
-            <a:ext cx="4945075" cy="1806854"/>
+            <a:ext cx="4945075" cy="1730776"/>
           </a:xfrm>
           <a:prstGeom prst="roundRect">
             <a:avLst/>
@@ -23805,8 +24685,8 @@
         </p:nvSpPr>
         <p:spPr>
           <a:xfrm>
-            <a:off x="3701491" y="4856195"/>
-            <a:ext cx="3899001" cy="323331"/>
+            <a:off x="3701491" y="4409236"/>
+            <a:ext cx="1426463" cy="228234"/>
           </a:xfrm>
           <a:prstGeom prst="roundRect">
             <a:avLst/>
@@ -23849,6 +24729,94 @@
         </p:nvSpPr>
         <p:spPr>
           <a:xfrm>
+            <a:off x="5223052" y="4409236"/>
+            <a:ext cx="1426463" cy="228234"/>
+          </a:xfrm>
+          <a:prstGeom prst="roundRect">
+            <a:avLst/>
+          </a:prstGeom>
+          <a:solidFill>
+            <a:srgbClr val="16303A"/>
+          </a:solidFill>
+          <a:ln>
+            <a:noFill/>
+          </a:ln>
+          <a:effectLst/>
+        </p:spPr>
+        <p:style>
+          <a:lnRef idx="1">
+            <a:schemeClr val="accent1"/>
+          </a:lnRef>
+          <a:fillRef idx="3">
+            <a:schemeClr val="accent1"/>
+          </a:fillRef>
+          <a:effectRef idx="2">
+            <a:schemeClr val="accent1"/>
+          </a:effectRef>
+          <a:fontRef idx="minor">
+            <a:schemeClr val="lt1"/>
+          </a:fontRef>
+        </p:style>
+        <p:txBody>
+          <a:bodyPr rtlCol="0" anchor="ctr"/>
+          <a:lstStyle/>
+          <a:p>
+            <a:pPr algn="ctr"/>
+          </a:p>
+        </p:txBody>
+      </p:sp>
+      <p:sp>
+        <p:nvSpPr>
+          <p:cNvPr id="13" name="Rounded Rectangle 12"/>
+          <p:cNvSpPr/>
+          <p:nvPr/>
+        </p:nvSpPr>
+        <p:spPr>
+          <a:xfrm>
+            <a:off x="3701491" y="4856195"/>
+            <a:ext cx="3899001" cy="323331"/>
+          </a:xfrm>
+          <a:prstGeom prst="roundRect">
+            <a:avLst/>
+          </a:prstGeom>
+          <a:solidFill>
+            <a:srgbClr val="16303A"/>
+          </a:solidFill>
+          <a:ln>
+            <a:noFill/>
+          </a:ln>
+          <a:effectLst/>
+        </p:spPr>
+        <p:style>
+          <a:lnRef idx="1">
+            <a:schemeClr val="accent1"/>
+          </a:lnRef>
+          <a:fillRef idx="3">
+            <a:schemeClr val="accent1"/>
+          </a:fillRef>
+          <a:effectRef idx="2">
+            <a:schemeClr val="accent1"/>
+          </a:effectRef>
+          <a:fontRef idx="minor">
+            <a:schemeClr val="lt1"/>
+          </a:fontRef>
+        </p:style>
+        <p:txBody>
+          <a:bodyPr rtlCol="0" anchor="ctr"/>
+          <a:lstStyle/>
+          <a:p>
+            <a:pPr algn="ctr"/>
+          </a:p>
+        </p:txBody>
+      </p:sp>
+      <p:sp>
+        <p:nvSpPr>
+          <p:cNvPr id="14" name="Rounded Rectangle 13"/>
+          <p:cNvSpPr/>
+          <p:nvPr/>
+        </p:nvSpPr>
+        <p:spPr>
+          <a:xfrm>
             <a:off x="7695590" y="4856195"/>
             <a:ext cx="779800" cy="323331"/>
           </a:xfrm>
@@ -23887,7 +24855,7 @@
       </p:sp>
       <p:sp>
         <p:nvSpPr>
-          <p:cNvPr id="13" name="Rounded Rectangle 12"/>
+          <p:cNvPr id="15" name="Rounded Rectangle 14"/>
           <p:cNvSpPr/>
           <p:nvPr/>
         </p:nvSpPr>
@@ -23931,7 +24899,7 @@
       </p:sp>
       <p:sp>
         <p:nvSpPr>
-          <p:cNvPr id="14" name="Rounded Rectangle 13"/>
+          <p:cNvPr id="16" name="Rounded Rectangle 15"/>
           <p:cNvSpPr/>
           <p:nvPr/>
         </p:nvSpPr>
@@ -23975,7 +24943,7 @@
       </p:sp>
       <p:sp>
         <p:nvSpPr>
-          <p:cNvPr id="15" name="TextBox 14"/>
+          <p:cNvPr id="17" name="TextBox 16"/>
           <p:cNvSpPr txBox="1"/>
           <p:nvPr/>
         </p:nvSpPr>
@@ -26183,7 +27151,7 @@
         <p:spPr>
           <a:xfrm>
             <a:off x="3606393" y="2554833"/>
-            <a:ext cx="4945075" cy="1806854"/>
+            <a:ext cx="4945075" cy="1730776"/>
           </a:xfrm>
           <a:prstGeom prst="roundRect">
             <a:avLst/>
@@ -26358,8 +27326,8 @@
         </p:nvSpPr>
         <p:spPr>
           <a:xfrm>
-            <a:off x="3701491" y="4856195"/>
-            <a:ext cx="3899001" cy="323331"/>
+            <a:off x="3701491" y="4409236"/>
+            <a:ext cx="1426463" cy="228234"/>
           </a:xfrm>
           <a:prstGeom prst="roundRect">
             <a:avLst/>
@@ -26402,6 +27370,94 @@
         </p:nvSpPr>
         <p:spPr>
           <a:xfrm>
+            <a:off x="5223052" y="4409236"/>
+            <a:ext cx="1426463" cy="228234"/>
+          </a:xfrm>
+          <a:prstGeom prst="roundRect">
+            <a:avLst/>
+          </a:prstGeom>
+          <a:solidFill>
+            <a:srgbClr val="16303A"/>
+          </a:solidFill>
+          <a:ln>
+            <a:noFill/>
+          </a:ln>
+          <a:effectLst/>
+        </p:spPr>
+        <p:style>
+          <a:lnRef idx="1">
+            <a:schemeClr val="accent1"/>
+          </a:lnRef>
+          <a:fillRef idx="3">
+            <a:schemeClr val="accent1"/>
+          </a:fillRef>
+          <a:effectRef idx="2">
+            <a:schemeClr val="accent1"/>
+          </a:effectRef>
+          <a:fontRef idx="minor">
+            <a:schemeClr val="lt1"/>
+          </a:fontRef>
+        </p:style>
+        <p:txBody>
+          <a:bodyPr rtlCol="0" anchor="ctr"/>
+          <a:lstStyle/>
+          <a:p>
+            <a:pPr algn="ctr"/>
+          </a:p>
+        </p:txBody>
+      </p:sp>
+      <p:sp>
+        <p:nvSpPr>
+          <p:cNvPr id="13" name="Rounded Rectangle 12"/>
+          <p:cNvSpPr/>
+          <p:nvPr/>
+        </p:nvSpPr>
+        <p:spPr>
+          <a:xfrm>
+            <a:off x="3701491" y="4856195"/>
+            <a:ext cx="3899001" cy="323331"/>
+          </a:xfrm>
+          <a:prstGeom prst="roundRect">
+            <a:avLst/>
+          </a:prstGeom>
+          <a:solidFill>
+            <a:srgbClr val="16303A"/>
+          </a:solidFill>
+          <a:ln>
+            <a:noFill/>
+          </a:ln>
+          <a:effectLst/>
+        </p:spPr>
+        <p:style>
+          <a:lnRef idx="1">
+            <a:schemeClr val="accent1"/>
+          </a:lnRef>
+          <a:fillRef idx="3">
+            <a:schemeClr val="accent1"/>
+          </a:fillRef>
+          <a:effectRef idx="2">
+            <a:schemeClr val="accent1"/>
+          </a:effectRef>
+          <a:fontRef idx="minor">
+            <a:schemeClr val="lt1"/>
+          </a:fontRef>
+        </p:style>
+        <p:txBody>
+          <a:bodyPr rtlCol="0" anchor="ctr"/>
+          <a:lstStyle/>
+          <a:p>
+            <a:pPr algn="ctr"/>
+          </a:p>
+        </p:txBody>
+      </p:sp>
+      <p:sp>
+        <p:nvSpPr>
+          <p:cNvPr id="14" name="Rounded Rectangle 13"/>
+          <p:cNvSpPr/>
+          <p:nvPr/>
+        </p:nvSpPr>
+        <p:spPr>
+          <a:xfrm>
             <a:off x="7695590" y="4856195"/>
             <a:ext cx="779800" cy="323331"/>
           </a:xfrm>
@@ -26440,7 +27496,7 @@
       </p:sp>
       <p:sp>
         <p:nvSpPr>
-          <p:cNvPr id="13" name="Rounded Rectangle 12"/>
+          <p:cNvPr id="15" name="Rounded Rectangle 14"/>
           <p:cNvSpPr/>
           <p:nvPr/>
         </p:nvSpPr>
@@ -26484,7 +27540,7 @@
       </p:sp>
       <p:sp>
         <p:nvSpPr>
-          <p:cNvPr id="14" name="Rounded Rectangle 13"/>
+          <p:cNvPr id="16" name="Rounded Rectangle 15"/>
           <p:cNvSpPr/>
           <p:nvPr/>
         </p:nvSpPr>
@@ -26528,7 +27584,7 @@
       </p:sp>
       <p:sp>
         <p:nvSpPr>
-          <p:cNvPr id="15" name="TextBox 14"/>
+          <p:cNvPr id="17" name="TextBox 16"/>
           <p:cNvSpPr txBox="1"/>
           <p:nvPr/>
         </p:nvSpPr>
@@ -27087,7 +28143,7 @@
         <p:spPr>
           <a:xfrm>
             <a:off x="3606393" y="2554833"/>
-            <a:ext cx="4945075" cy="1806854"/>
+            <a:ext cx="4945075" cy="1730776"/>
           </a:xfrm>
           <a:prstGeom prst="roundRect">
             <a:avLst/>
@@ -27262,8 +28318,8 @@
         </p:nvSpPr>
         <p:spPr>
           <a:xfrm>
-            <a:off x="3701491" y="4856195"/>
-            <a:ext cx="3899001" cy="323331"/>
+            <a:off x="3701491" y="4409236"/>
+            <a:ext cx="1426463" cy="228234"/>
           </a:xfrm>
           <a:prstGeom prst="roundRect">
             <a:avLst/>
@@ -27306,6 +28362,94 @@
         </p:nvSpPr>
         <p:spPr>
           <a:xfrm>
+            <a:off x="5223052" y="4409236"/>
+            <a:ext cx="1426463" cy="228234"/>
+          </a:xfrm>
+          <a:prstGeom prst="roundRect">
+            <a:avLst/>
+          </a:prstGeom>
+          <a:solidFill>
+            <a:srgbClr val="16303A"/>
+          </a:solidFill>
+          <a:ln>
+            <a:noFill/>
+          </a:ln>
+          <a:effectLst/>
+        </p:spPr>
+        <p:style>
+          <a:lnRef idx="1">
+            <a:schemeClr val="accent1"/>
+          </a:lnRef>
+          <a:fillRef idx="3">
+            <a:schemeClr val="accent1"/>
+          </a:fillRef>
+          <a:effectRef idx="2">
+            <a:schemeClr val="accent1"/>
+          </a:effectRef>
+          <a:fontRef idx="minor">
+            <a:schemeClr val="lt1"/>
+          </a:fontRef>
+        </p:style>
+        <p:txBody>
+          <a:bodyPr rtlCol="0" anchor="ctr"/>
+          <a:lstStyle/>
+          <a:p>
+            <a:pPr algn="ctr"/>
+          </a:p>
+        </p:txBody>
+      </p:sp>
+      <p:sp>
+        <p:nvSpPr>
+          <p:cNvPr id="13" name="Rounded Rectangle 12"/>
+          <p:cNvSpPr/>
+          <p:nvPr/>
+        </p:nvSpPr>
+        <p:spPr>
+          <a:xfrm>
+            <a:off x="3701491" y="4856195"/>
+            <a:ext cx="3899001" cy="323331"/>
+          </a:xfrm>
+          <a:prstGeom prst="roundRect">
+            <a:avLst/>
+          </a:prstGeom>
+          <a:solidFill>
+            <a:srgbClr val="16303A"/>
+          </a:solidFill>
+          <a:ln>
+            <a:noFill/>
+          </a:ln>
+          <a:effectLst/>
+        </p:spPr>
+        <p:style>
+          <a:lnRef idx="1">
+            <a:schemeClr val="accent1"/>
+          </a:lnRef>
+          <a:fillRef idx="3">
+            <a:schemeClr val="accent1"/>
+          </a:fillRef>
+          <a:effectRef idx="2">
+            <a:schemeClr val="accent1"/>
+          </a:effectRef>
+          <a:fontRef idx="minor">
+            <a:schemeClr val="lt1"/>
+          </a:fontRef>
+        </p:style>
+        <p:txBody>
+          <a:bodyPr rtlCol="0" anchor="ctr"/>
+          <a:lstStyle/>
+          <a:p>
+            <a:pPr algn="ctr"/>
+          </a:p>
+        </p:txBody>
+      </p:sp>
+      <p:sp>
+        <p:nvSpPr>
+          <p:cNvPr id="14" name="Rounded Rectangle 13"/>
+          <p:cNvSpPr/>
+          <p:nvPr/>
+        </p:nvSpPr>
+        <p:spPr>
+          <a:xfrm>
             <a:off x="7695590" y="4856195"/>
             <a:ext cx="779800" cy="323331"/>
           </a:xfrm>
@@ -27344,7 +28488,7 @@
       </p:sp>
       <p:sp>
         <p:nvSpPr>
-          <p:cNvPr id="13" name="Rounded Rectangle 12"/>
+          <p:cNvPr id="15" name="Rounded Rectangle 14"/>
           <p:cNvSpPr/>
           <p:nvPr/>
         </p:nvSpPr>
@@ -27388,7 +28532,7 @@
       </p:sp>
       <p:sp>
         <p:nvSpPr>
-          <p:cNvPr id="14" name="Rounded Rectangle 13"/>
+          <p:cNvPr id="16" name="Rounded Rectangle 15"/>
           <p:cNvSpPr/>
           <p:nvPr/>
         </p:nvSpPr>
@@ -27432,7 +28576,7 @@
       </p:sp>
       <p:sp>
         <p:nvSpPr>
-          <p:cNvPr id="15" name="TextBox 14"/>
+          <p:cNvPr id="17" name="TextBox 16"/>
           <p:cNvSpPr txBox="1"/>
           <p:nvPr/>
         </p:nvSpPr>
@@ -27696,7 +28840,7 @@
         <p:spPr>
           <a:xfrm>
             <a:off x="3606393" y="2554833"/>
-            <a:ext cx="4945075" cy="1806854"/>
+            <a:ext cx="4945075" cy="1730776"/>
           </a:xfrm>
           <a:prstGeom prst="roundRect">
             <a:avLst/>
@@ -27871,8 +29015,8 @@
         </p:nvSpPr>
         <p:spPr>
           <a:xfrm>
-            <a:off x="3701491" y="4856195"/>
-            <a:ext cx="3899001" cy="323331"/>
+            <a:off x="3701491" y="4409236"/>
+            <a:ext cx="1426463" cy="228234"/>
           </a:xfrm>
           <a:prstGeom prst="roundRect">
             <a:avLst/>
@@ -27915,6 +29059,94 @@
         </p:nvSpPr>
         <p:spPr>
           <a:xfrm>
+            <a:off x="5223052" y="4409236"/>
+            <a:ext cx="1426463" cy="228234"/>
+          </a:xfrm>
+          <a:prstGeom prst="roundRect">
+            <a:avLst/>
+          </a:prstGeom>
+          <a:solidFill>
+            <a:srgbClr val="16303A"/>
+          </a:solidFill>
+          <a:ln>
+            <a:noFill/>
+          </a:ln>
+          <a:effectLst/>
+        </p:spPr>
+        <p:style>
+          <a:lnRef idx="1">
+            <a:schemeClr val="accent1"/>
+          </a:lnRef>
+          <a:fillRef idx="3">
+            <a:schemeClr val="accent1"/>
+          </a:fillRef>
+          <a:effectRef idx="2">
+            <a:schemeClr val="accent1"/>
+          </a:effectRef>
+          <a:fontRef idx="minor">
+            <a:schemeClr val="lt1"/>
+          </a:fontRef>
+        </p:style>
+        <p:txBody>
+          <a:bodyPr rtlCol="0" anchor="ctr"/>
+          <a:lstStyle/>
+          <a:p>
+            <a:pPr algn="ctr"/>
+          </a:p>
+        </p:txBody>
+      </p:sp>
+      <p:sp>
+        <p:nvSpPr>
+          <p:cNvPr id="13" name="Rounded Rectangle 12"/>
+          <p:cNvSpPr/>
+          <p:nvPr/>
+        </p:nvSpPr>
+        <p:spPr>
+          <a:xfrm>
+            <a:off x="3701491" y="4856195"/>
+            <a:ext cx="3899001" cy="323331"/>
+          </a:xfrm>
+          <a:prstGeom prst="roundRect">
+            <a:avLst/>
+          </a:prstGeom>
+          <a:solidFill>
+            <a:srgbClr val="16303A"/>
+          </a:solidFill>
+          <a:ln>
+            <a:noFill/>
+          </a:ln>
+          <a:effectLst/>
+        </p:spPr>
+        <p:style>
+          <a:lnRef idx="1">
+            <a:schemeClr val="accent1"/>
+          </a:lnRef>
+          <a:fillRef idx="3">
+            <a:schemeClr val="accent1"/>
+          </a:fillRef>
+          <a:effectRef idx="2">
+            <a:schemeClr val="accent1"/>
+          </a:effectRef>
+          <a:fontRef idx="minor">
+            <a:schemeClr val="lt1"/>
+          </a:fontRef>
+        </p:style>
+        <p:txBody>
+          <a:bodyPr rtlCol="0" anchor="ctr"/>
+          <a:lstStyle/>
+          <a:p>
+            <a:pPr algn="ctr"/>
+          </a:p>
+        </p:txBody>
+      </p:sp>
+      <p:sp>
+        <p:nvSpPr>
+          <p:cNvPr id="14" name="Rounded Rectangle 13"/>
+          <p:cNvSpPr/>
+          <p:nvPr/>
+        </p:nvSpPr>
+        <p:spPr>
+          <a:xfrm>
             <a:off x="7695590" y="4856195"/>
             <a:ext cx="779800" cy="323331"/>
           </a:xfrm>
@@ -27953,7 +29185,7 @@
       </p:sp>
       <p:sp>
         <p:nvSpPr>
-          <p:cNvPr id="13" name="Rounded Rectangle 12"/>
+          <p:cNvPr id="15" name="Rounded Rectangle 14"/>
           <p:cNvSpPr/>
           <p:nvPr/>
         </p:nvSpPr>
@@ -27997,7 +29229,7 @@
       </p:sp>
       <p:sp>
         <p:nvSpPr>
-          <p:cNvPr id="14" name="Rounded Rectangle 13"/>
+          <p:cNvPr id="16" name="Rounded Rectangle 15"/>
           <p:cNvSpPr/>
           <p:nvPr/>
         </p:nvSpPr>
@@ -28041,7 +29273,7 @@
       </p:sp>
       <p:sp>
         <p:nvSpPr>
-          <p:cNvPr id="15" name="TextBox 14"/>
+          <p:cNvPr id="17" name="TextBox 16"/>
           <p:cNvSpPr txBox="1"/>
           <p:nvPr/>
         </p:nvSpPr>
@@ -28610,7 +29842,7 @@
         <p:spPr>
           <a:xfrm>
             <a:off x="3606393" y="2554833"/>
-            <a:ext cx="4945075" cy="1806854"/>
+            <a:ext cx="4945075" cy="1730776"/>
           </a:xfrm>
           <a:prstGeom prst="roundRect">
             <a:avLst/>
@@ -28785,8 +30017,8 @@
         </p:nvSpPr>
         <p:spPr>
           <a:xfrm>
-            <a:off x="3701491" y="4856195"/>
-            <a:ext cx="3899001" cy="323331"/>
+            <a:off x="3701491" y="4409236"/>
+            <a:ext cx="1426463" cy="228234"/>
           </a:xfrm>
           <a:prstGeom prst="roundRect">
             <a:avLst/>
@@ -28829,6 +30061,94 @@
         </p:nvSpPr>
         <p:spPr>
           <a:xfrm>
+            <a:off x="5223052" y="4409236"/>
+            <a:ext cx="1426463" cy="228234"/>
+          </a:xfrm>
+          <a:prstGeom prst="roundRect">
+            <a:avLst/>
+          </a:prstGeom>
+          <a:solidFill>
+            <a:srgbClr val="16303A"/>
+          </a:solidFill>
+          <a:ln>
+            <a:noFill/>
+          </a:ln>
+          <a:effectLst/>
+        </p:spPr>
+        <p:style>
+          <a:lnRef idx="1">
+            <a:schemeClr val="accent1"/>
+          </a:lnRef>
+          <a:fillRef idx="3">
+            <a:schemeClr val="accent1"/>
+          </a:fillRef>
+          <a:effectRef idx="2">
+            <a:schemeClr val="accent1"/>
+          </a:effectRef>
+          <a:fontRef idx="minor">
+            <a:schemeClr val="lt1"/>
+          </a:fontRef>
+        </p:style>
+        <p:txBody>
+          <a:bodyPr rtlCol="0" anchor="ctr"/>
+          <a:lstStyle/>
+          <a:p>
+            <a:pPr algn="ctr"/>
+          </a:p>
+        </p:txBody>
+      </p:sp>
+      <p:sp>
+        <p:nvSpPr>
+          <p:cNvPr id="13" name="Rounded Rectangle 12"/>
+          <p:cNvSpPr/>
+          <p:nvPr/>
+        </p:nvSpPr>
+        <p:spPr>
+          <a:xfrm>
+            <a:off x="3701491" y="4856195"/>
+            <a:ext cx="3899001" cy="323331"/>
+          </a:xfrm>
+          <a:prstGeom prst="roundRect">
+            <a:avLst/>
+          </a:prstGeom>
+          <a:solidFill>
+            <a:srgbClr val="16303A"/>
+          </a:solidFill>
+          <a:ln>
+            <a:noFill/>
+          </a:ln>
+          <a:effectLst/>
+        </p:spPr>
+        <p:style>
+          <a:lnRef idx="1">
+            <a:schemeClr val="accent1"/>
+          </a:lnRef>
+          <a:fillRef idx="3">
+            <a:schemeClr val="accent1"/>
+          </a:fillRef>
+          <a:effectRef idx="2">
+            <a:schemeClr val="accent1"/>
+          </a:effectRef>
+          <a:fontRef idx="minor">
+            <a:schemeClr val="lt1"/>
+          </a:fontRef>
+        </p:style>
+        <p:txBody>
+          <a:bodyPr rtlCol="0" anchor="ctr"/>
+          <a:lstStyle/>
+          <a:p>
+            <a:pPr algn="ctr"/>
+          </a:p>
+        </p:txBody>
+      </p:sp>
+      <p:sp>
+        <p:nvSpPr>
+          <p:cNvPr id="14" name="Rounded Rectangle 13"/>
+          <p:cNvSpPr/>
+          <p:nvPr/>
+        </p:nvSpPr>
+        <p:spPr>
+          <a:xfrm>
             <a:off x="7695590" y="4856195"/>
             <a:ext cx="779800" cy="323331"/>
           </a:xfrm>
@@ -28867,7 +30187,7 @@
       </p:sp>
       <p:sp>
         <p:nvSpPr>
-          <p:cNvPr id="13" name="Rounded Rectangle 12"/>
+          <p:cNvPr id="15" name="Rounded Rectangle 14"/>
           <p:cNvSpPr/>
           <p:nvPr/>
         </p:nvSpPr>
@@ -28911,7 +30231,7 @@
       </p:sp>
       <p:sp>
         <p:nvSpPr>
-          <p:cNvPr id="14" name="Rounded Rectangle 13"/>
+          <p:cNvPr id="16" name="Rounded Rectangle 15"/>
           <p:cNvSpPr/>
           <p:nvPr/>
         </p:nvSpPr>
@@ -28955,7 +30275,7 @@
       </p:sp>
       <p:sp>
         <p:nvSpPr>
-          <p:cNvPr id="15" name="TextBox 14"/>
+          <p:cNvPr id="17" name="TextBox 16"/>
           <p:cNvSpPr txBox="1"/>
           <p:nvPr/>
         </p:nvSpPr>
@@ -29349,7 +30669,7 @@
         <p:spPr>
           <a:xfrm>
             <a:off x="3606393" y="2554833"/>
-            <a:ext cx="4945075" cy="1806854"/>
+            <a:ext cx="4945075" cy="1730776"/>
           </a:xfrm>
           <a:prstGeom prst="roundRect">
             <a:avLst/>
@@ -29524,8 +30844,8 @@
         </p:nvSpPr>
         <p:spPr>
           <a:xfrm>
-            <a:off x="3701491" y="4856195"/>
-            <a:ext cx="3899001" cy="323331"/>
+            <a:off x="3701491" y="4409236"/>
+            <a:ext cx="1426463" cy="228234"/>
           </a:xfrm>
           <a:prstGeom prst="roundRect">
             <a:avLst/>
@@ -29568,6 +30888,94 @@
         </p:nvSpPr>
         <p:spPr>
           <a:xfrm>
+            <a:off x="5223052" y="4409236"/>
+            <a:ext cx="1426463" cy="228234"/>
+          </a:xfrm>
+          <a:prstGeom prst="roundRect">
+            <a:avLst/>
+          </a:prstGeom>
+          <a:solidFill>
+            <a:srgbClr val="16303A"/>
+          </a:solidFill>
+          <a:ln>
+            <a:noFill/>
+          </a:ln>
+          <a:effectLst/>
+        </p:spPr>
+        <p:style>
+          <a:lnRef idx="1">
+            <a:schemeClr val="accent1"/>
+          </a:lnRef>
+          <a:fillRef idx="3">
+            <a:schemeClr val="accent1"/>
+          </a:fillRef>
+          <a:effectRef idx="2">
+            <a:schemeClr val="accent1"/>
+          </a:effectRef>
+          <a:fontRef idx="minor">
+            <a:schemeClr val="lt1"/>
+          </a:fontRef>
+        </p:style>
+        <p:txBody>
+          <a:bodyPr rtlCol="0" anchor="ctr"/>
+          <a:lstStyle/>
+          <a:p>
+            <a:pPr algn="ctr"/>
+          </a:p>
+        </p:txBody>
+      </p:sp>
+      <p:sp>
+        <p:nvSpPr>
+          <p:cNvPr id="13" name="Rounded Rectangle 12"/>
+          <p:cNvSpPr/>
+          <p:nvPr/>
+        </p:nvSpPr>
+        <p:spPr>
+          <a:xfrm>
+            <a:off x="3701491" y="4856195"/>
+            <a:ext cx="3899001" cy="323331"/>
+          </a:xfrm>
+          <a:prstGeom prst="roundRect">
+            <a:avLst/>
+          </a:prstGeom>
+          <a:solidFill>
+            <a:srgbClr val="16303A"/>
+          </a:solidFill>
+          <a:ln>
+            <a:noFill/>
+          </a:ln>
+          <a:effectLst/>
+        </p:spPr>
+        <p:style>
+          <a:lnRef idx="1">
+            <a:schemeClr val="accent1"/>
+          </a:lnRef>
+          <a:fillRef idx="3">
+            <a:schemeClr val="accent1"/>
+          </a:fillRef>
+          <a:effectRef idx="2">
+            <a:schemeClr val="accent1"/>
+          </a:effectRef>
+          <a:fontRef idx="minor">
+            <a:schemeClr val="lt1"/>
+          </a:fontRef>
+        </p:style>
+        <p:txBody>
+          <a:bodyPr rtlCol="0" anchor="ctr"/>
+          <a:lstStyle/>
+          <a:p>
+            <a:pPr algn="ctr"/>
+          </a:p>
+        </p:txBody>
+      </p:sp>
+      <p:sp>
+        <p:nvSpPr>
+          <p:cNvPr id="14" name="Rounded Rectangle 13"/>
+          <p:cNvSpPr/>
+          <p:nvPr/>
+        </p:nvSpPr>
+        <p:spPr>
+          <a:xfrm>
             <a:off x="7695590" y="4856195"/>
             <a:ext cx="779800" cy="323331"/>
           </a:xfrm>
@@ -29606,7 +31014,7 @@
       </p:sp>
       <p:sp>
         <p:nvSpPr>
-          <p:cNvPr id="13" name="Rounded Rectangle 12"/>
+          <p:cNvPr id="15" name="Rounded Rectangle 14"/>
           <p:cNvSpPr/>
           <p:nvPr/>
         </p:nvSpPr>
@@ -29650,7 +31058,7 @@
       </p:sp>
       <p:sp>
         <p:nvSpPr>
-          <p:cNvPr id="14" name="Rounded Rectangle 13"/>
+          <p:cNvPr id="16" name="Rounded Rectangle 15"/>
           <p:cNvSpPr/>
           <p:nvPr/>
         </p:nvSpPr>
@@ -29694,7 +31102,7 @@
       </p:sp>
       <p:sp>
         <p:nvSpPr>
-          <p:cNvPr id="15" name="TextBox 14"/>
+          <p:cNvPr id="17" name="TextBox 16"/>
           <p:cNvSpPr txBox="1"/>
           <p:nvPr/>
         </p:nvSpPr>
@@ -30288,7 +31696,7 @@
         <p:spPr>
           <a:xfrm>
             <a:off x="3606393" y="2554833"/>
-            <a:ext cx="4945075" cy="1806854"/>
+            <a:ext cx="4945075" cy="1730776"/>
           </a:xfrm>
           <a:prstGeom prst="roundRect">
             <a:avLst/>
@@ -30463,8 +31871,8 @@
         </p:nvSpPr>
         <p:spPr>
           <a:xfrm>
-            <a:off x="3701491" y="4856195"/>
-            <a:ext cx="3899001" cy="323331"/>
+            <a:off x="3701491" y="4409236"/>
+            <a:ext cx="1426463" cy="228234"/>
           </a:xfrm>
           <a:prstGeom prst="roundRect">
             <a:avLst/>
@@ -30507,6 +31915,94 @@
         </p:nvSpPr>
         <p:spPr>
           <a:xfrm>
+            <a:off x="5223052" y="4409236"/>
+            <a:ext cx="1426463" cy="228234"/>
+          </a:xfrm>
+          <a:prstGeom prst="roundRect">
+            <a:avLst/>
+          </a:prstGeom>
+          <a:solidFill>
+            <a:srgbClr val="16303A"/>
+          </a:solidFill>
+          <a:ln>
+            <a:noFill/>
+          </a:ln>
+          <a:effectLst/>
+        </p:spPr>
+        <p:style>
+          <a:lnRef idx="1">
+            <a:schemeClr val="accent1"/>
+          </a:lnRef>
+          <a:fillRef idx="3">
+            <a:schemeClr val="accent1"/>
+          </a:fillRef>
+          <a:effectRef idx="2">
+            <a:schemeClr val="accent1"/>
+          </a:effectRef>
+          <a:fontRef idx="minor">
+            <a:schemeClr val="lt1"/>
+          </a:fontRef>
+        </p:style>
+        <p:txBody>
+          <a:bodyPr rtlCol="0" anchor="ctr"/>
+          <a:lstStyle/>
+          <a:p>
+            <a:pPr algn="ctr"/>
+          </a:p>
+        </p:txBody>
+      </p:sp>
+      <p:sp>
+        <p:nvSpPr>
+          <p:cNvPr id="13" name="Rounded Rectangle 12"/>
+          <p:cNvSpPr/>
+          <p:nvPr/>
+        </p:nvSpPr>
+        <p:spPr>
+          <a:xfrm>
+            <a:off x="3701491" y="4856195"/>
+            <a:ext cx="3899001" cy="323331"/>
+          </a:xfrm>
+          <a:prstGeom prst="roundRect">
+            <a:avLst/>
+          </a:prstGeom>
+          <a:solidFill>
+            <a:srgbClr val="16303A"/>
+          </a:solidFill>
+          <a:ln>
+            <a:noFill/>
+          </a:ln>
+          <a:effectLst/>
+        </p:spPr>
+        <p:style>
+          <a:lnRef idx="1">
+            <a:schemeClr val="accent1"/>
+          </a:lnRef>
+          <a:fillRef idx="3">
+            <a:schemeClr val="accent1"/>
+          </a:fillRef>
+          <a:effectRef idx="2">
+            <a:schemeClr val="accent1"/>
+          </a:effectRef>
+          <a:fontRef idx="minor">
+            <a:schemeClr val="lt1"/>
+          </a:fontRef>
+        </p:style>
+        <p:txBody>
+          <a:bodyPr rtlCol="0" anchor="ctr"/>
+          <a:lstStyle/>
+          <a:p>
+            <a:pPr algn="ctr"/>
+          </a:p>
+        </p:txBody>
+      </p:sp>
+      <p:sp>
+        <p:nvSpPr>
+          <p:cNvPr id="14" name="Rounded Rectangle 13"/>
+          <p:cNvSpPr/>
+          <p:nvPr/>
+        </p:nvSpPr>
+        <p:spPr>
+          <a:xfrm>
             <a:off x="7695590" y="4856195"/>
             <a:ext cx="779800" cy="323331"/>
           </a:xfrm>
@@ -30545,7 +32041,7 @@
       </p:sp>
       <p:sp>
         <p:nvSpPr>
-          <p:cNvPr id="13" name="Rounded Rectangle 12"/>
+          <p:cNvPr id="15" name="Rounded Rectangle 14"/>
           <p:cNvSpPr/>
           <p:nvPr/>
         </p:nvSpPr>
@@ -30589,7 +32085,7 @@
       </p:sp>
       <p:sp>
         <p:nvSpPr>
-          <p:cNvPr id="14" name="Rounded Rectangle 13"/>
+          <p:cNvPr id="16" name="Rounded Rectangle 15"/>
           <p:cNvSpPr/>
           <p:nvPr/>
         </p:nvSpPr>
@@ -30633,7 +32129,7 @@
       </p:sp>
       <p:sp>
         <p:nvSpPr>
-          <p:cNvPr id="15" name="TextBox 14"/>
+          <p:cNvPr id="17" name="TextBox 16"/>
           <p:cNvSpPr txBox="1"/>
           <p:nvPr/>
         </p:nvSpPr>
@@ -32197,7 +33693,7 @@
         <p:spPr>
           <a:xfrm>
             <a:off x="3606393" y="2554833"/>
-            <a:ext cx="4945075" cy="1806854"/>
+            <a:ext cx="4945075" cy="1730776"/>
           </a:xfrm>
           <a:prstGeom prst="roundRect">
             <a:avLst/>
@@ -32372,8 +33868,8 @@
         </p:nvSpPr>
         <p:spPr>
           <a:xfrm>
-            <a:off x="3701491" y="4856195"/>
-            <a:ext cx="3899001" cy="323331"/>
+            <a:off x="3701491" y="4409236"/>
+            <a:ext cx="1426463" cy="228234"/>
           </a:xfrm>
           <a:prstGeom prst="roundRect">
             <a:avLst/>
@@ -32416,6 +33912,94 @@
         </p:nvSpPr>
         <p:spPr>
           <a:xfrm>
+            <a:off x="5223052" y="4409236"/>
+            <a:ext cx="1426463" cy="228234"/>
+          </a:xfrm>
+          <a:prstGeom prst="roundRect">
+            <a:avLst/>
+          </a:prstGeom>
+          <a:solidFill>
+            <a:srgbClr val="16303A"/>
+          </a:solidFill>
+          <a:ln>
+            <a:noFill/>
+          </a:ln>
+          <a:effectLst/>
+        </p:spPr>
+        <p:style>
+          <a:lnRef idx="1">
+            <a:schemeClr val="accent1"/>
+          </a:lnRef>
+          <a:fillRef idx="3">
+            <a:schemeClr val="accent1"/>
+          </a:fillRef>
+          <a:effectRef idx="2">
+            <a:schemeClr val="accent1"/>
+          </a:effectRef>
+          <a:fontRef idx="minor">
+            <a:schemeClr val="lt1"/>
+          </a:fontRef>
+        </p:style>
+        <p:txBody>
+          <a:bodyPr rtlCol="0" anchor="ctr"/>
+          <a:lstStyle/>
+          <a:p>
+            <a:pPr algn="ctr"/>
+          </a:p>
+        </p:txBody>
+      </p:sp>
+      <p:sp>
+        <p:nvSpPr>
+          <p:cNvPr id="13" name="Rounded Rectangle 12"/>
+          <p:cNvSpPr/>
+          <p:nvPr/>
+        </p:nvSpPr>
+        <p:spPr>
+          <a:xfrm>
+            <a:off x="3701491" y="4856195"/>
+            <a:ext cx="3899001" cy="323331"/>
+          </a:xfrm>
+          <a:prstGeom prst="roundRect">
+            <a:avLst/>
+          </a:prstGeom>
+          <a:solidFill>
+            <a:srgbClr val="16303A"/>
+          </a:solidFill>
+          <a:ln>
+            <a:noFill/>
+          </a:ln>
+          <a:effectLst/>
+        </p:spPr>
+        <p:style>
+          <a:lnRef idx="1">
+            <a:schemeClr val="accent1"/>
+          </a:lnRef>
+          <a:fillRef idx="3">
+            <a:schemeClr val="accent1"/>
+          </a:fillRef>
+          <a:effectRef idx="2">
+            <a:schemeClr val="accent1"/>
+          </a:effectRef>
+          <a:fontRef idx="minor">
+            <a:schemeClr val="lt1"/>
+          </a:fontRef>
+        </p:style>
+        <p:txBody>
+          <a:bodyPr rtlCol="0" anchor="ctr"/>
+          <a:lstStyle/>
+          <a:p>
+            <a:pPr algn="ctr"/>
+          </a:p>
+        </p:txBody>
+      </p:sp>
+      <p:sp>
+        <p:nvSpPr>
+          <p:cNvPr id="14" name="Rounded Rectangle 13"/>
+          <p:cNvSpPr/>
+          <p:nvPr/>
+        </p:nvSpPr>
+        <p:spPr>
+          <a:xfrm>
             <a:off x="7695590" y="4856195"/>
             <a:ext cx="779800" cy="323331"/>
           </a:xfrm>
@@ -32454,7 +34038,7 @@
       </p:sp>
       <p:sp>
         <p:nvSpPr>
-          <p:cNvPr id="13" name="Rounded Rectangle 12"/>
+          <p:cNvPr id="15" name="Rounded Rectangle 14"/>
           <p:cNvSpPr/>
           <p:nvPr/>
         </p:nvSpPr>
@@ -32498,7 +34082,7 @@
       </p:sp>
       <p:sp>
         <p:nvSpPr>
-          <p:cNvPr id="14" name="Rounded Rectangle 13"/>
+          <p:cNvPr id="16" name="Rounded Rectangle 15"/>
           <p:cNvSpPr/>
           <p:nvPr/>
         </p:nvSpPr>
@@ -32542,7 +34126,7 @@
       </p:sp>
       <p:sp>
         <p:nvSpPr>
-          <p:cNvPr id="15" name="TextBox 14"/>
+          <p:cNvPr id="17" name="TextBox 16"/>
           <p:cNvSpPr txBox="1"/>
           <p:nvPr/>
         </p:nvSpPr>
@@ -33391,7 +34975,7 @@
         <p:spPr>
           <a:xfrm>
             <a:off x="3606393" y="2554833"/>
-            <a:ext cx="4945075" cy="1806854"/>
+            <a:ext cx="4945075" cy="1730776"/>
           </a:xfrm>
           <a:prstGeom prst="roundRect">
             <a:avLst/>
@@ -33566,8 +35150,8 @@
         </p:nvSpPr>
         <p:spPr>
           <a:xfrm>
-            <a:off x="3701491" y="4856195"/>
-            <a:ext cx="3899001" cy="323331"/>
+            <a:off x="3701491" y="4409236"/>
+            <a:ext cx="1426463" cy="228234"/>
           </a:xfrm>
           <a:prstGeom prst="roundRect">
             <a:avLst/>
@@ -33610,6 +35194,94 @@
         </p:nvSpPr>
         <p:spPr>
           <a:xfrm>
+            <a:off x="5223052" y="4409236"/>
+            <a:ext cx="1426463" cy="228234"/>
+          </a:xfrm>
+          <a:prstGeom prst="roundRect">
+            <a:avLst/>
+          </a:prstGeom>
+          <a:solidFill>
+            <a:srgbClr val="16303A"/>
+          </a:solidFill>
+          <a:ln>
+            <a:noFill/>
+          </a:ln>
+          <a:effectLst/>
+        </p:spPr>
+        <p:style>
+          <a:lnRef idx="1">
+            <a:schemeClr val="accent1"/>
+          </a:lnRef>
+          <a:fillRef idx="3">
+            <a:schemeClr val="accent1"/>
+          </a:fillRef>
+          <a:effectRef idx="2">
+            <a:schemeClr val="accent1"/>
+          </a:effectRef>
+          <a:fontRef idx="minor">
+            <a:schemeClr val="lt1"/>
+          </a:fontRef>
+        </p:style>
+        <p:txBody>
+          <a:bodyPr rtlCol="0" anchor="ctr"/>
+          <a:lstStyle/>
+          <a:p>
+            <a:pPr algn="ctr"/>
+          </a:p>
+        </p:txBody>
+      </p:sp>
+      <p:sp>
+        <p:nvSpPr>
+          <p:cNvPr id="13" name="Rounded Rectangle 12"/>
+          <p:cNvSpPr/>
+          <p:nvPr/>
+        </p:nvSpPr>
+        <p:spPr>
+          <a:xfrm>
+            <a:off x="3701491" y="4856195"/>
+            <a:ext cx="3899001" cy="323331"/>
+          </a:xfrm>
+          <a:prstGeom prst="roundRect">
+            <a:avLst/>
+          </a:prstGeom>
+          <a:solidFill>
+            <a:srgbClr val="16303A"/>
+          </a:solidFill>
+          <a:ln>
+            <a:noFill/>
+          </a:ln>
+          <a:effectLst/>
+        </p:spPr>
+        <p:style>
+          <a:lnRef idx="1">
+            <a:schemeClr val="accent1"/>
+          </a:lnRef>
+          <a:fillRef idx="3">
+            <a:schemeClr val="accent1"/>
+          </a:fillRef>
+          <a:effectRef idx="2">
+            <a:schemeClr val="accent1"/>
+          </a:effectRef>
+          <a:fontRef idx="minor">
+            <a:schemeClr val="lt1"/>
+          </a:fontRef>
+        </p:style>
+        <p:txBody>
+          <a:bodyPr rtlCol="0" anchor="ctr"/>
+          <a:lstStyle/>
+          <a:p>
+            <a:pPr algn="ctr"/>
+          </a:p>
+        </p:txBody>
+      </p:sp>
+      <p:sp>
+        <p:nvSpPr>
+          <p:cNvPr id="14" name="Rounded Rectangle 13"/>
+          <p:cNvSpPr/>
+          <p:nvPr/>
+        </p:nvSpPr>
+        <p:spPr>
+          <a:xfrm>
             <a:off x="7695590" y="4856195"/>
             <a:ext cx="779800" cy="323331"/>
           </a:xfrm>
@@ -33648,7 +35320,7 @@
       </p:sp>
       <p:sp>
         <p:nvSpPr>
-          <p:cNvPr id="13" name="Rounded Rectangle 12"/>
+          <p:cNvPr id="15" name="Rounded Rectangle 14"/>
           <p:cNvSpPr/>
           <p:nvPr/>
         </p:nvSpPr>
@@ -33692,7 +35364,7 @@
       </p:sp>
       <p:sp>
         <p:nvSpPr>
-          <p:cNvPr id="14" name="Rounded Rectangle 13"/>
+          <p:cNvPr id="16" name="Rounded Rectangle 15"/>
           <p:cNvSpPr/>
           <p:nvPr/>
         </p:nvSpPr>
@@ -33736,7 +35408,7 @@
       </p:sp>
       <p:sp>
         <p:nvSpPr>
-          <p:cNvPr id="15" name="TextBox 14"/>
+          <p:cNvPr id="17" name="TextBox 16"/>
           <p:cNvSpPr txBox="1"/>
           <p:nvPr/>
         </p:nvSpPr>
@@ -34000,7 +35672,7 @@
         <p:spPr>
           <a:xfrm>
             <a:off x="3606393" y="2554833"/>
-            <a:ext cx="4945075" cy="1806854"/>
+            <a:ext cx="4945075" cy="1730776"/>
           </a:xfrm>
           <a:prstGeom prst="roundRect">
             <a:avLst/>
@@ -34175,8 +35847,8 @@
         </p:nvSpPr>
         <p:spPr>
           <a:xfrm>
-            <a:off x="3701491" y="4856195"/>
-            <a:ext cx="3899001" cy="323331"/>
+            <a:off x="3701491" y="4409236"/>
+            <a:ext cx="1426463" cy="228234"/>
           </a:xfrm>
           <a:prstGeom prst="roundRect">
             <a:avLst/>
@@ -34219,6 +35891,94 @@
         </p:nvSpPr>
         <p:spPr>
           <a:xfrm>
+            <a:off x="5223052" y="4409236"/>
+            <a:ext cx="1426463" cy="228234"/>
+          </a:xfrm>
+          <a:prstGeom prst="roundRect">
+            <a:avLst/>
+          </a:prstGeom>
+          <a:solidFill>
+            <a:srgbClr val="16303A"/>
+          </a:solidFill>
+          <a:ln>
+            <a:noFill/>
+          </a:ln>
+          <a:effectLst/>
+        </p:spPr>
+        <p:style>
+          <a:lnRef idx="1">
+            <a:schemeClr val="accent1"/>
+          </a:lnRef>
+          <a:fillRef idx="3">
+            <a:schemeClr val="accent1"/>
+          </a:fillRef>
+          <a:effectRef idx="2">
+            <a:schemeClr val="accent1"/>
+          </a:effectRef>
+          <a:fontRef idx="minor">
+            <a:schemeClr val="lt1"/>
+          </a:fontRef>
+        </p:style>
+        <p:txBody>
+          <a:bodyPr rtlCol="0" anchor="ctr"/>
+          <a:lstStyle/>
+          <a:p>
+            <a:pPr algn="ctr"/>
+          </a:p>
+        </p:txBody>
+      </p:sp>
+      <p:sp>
+        <p:nvSpPr>
+          <p:cNvPr id="13" name="Rounded Rectangle 12"/>
+          <p:cNvSpPr/>
+          <p:nvPr/>
+        </p:nvSpPr>
+        <p:spPr>
+          <a:xfrm>
+            <a:off x="3701491" y="4856195"/>
+            <a:ext cx="3899001" cy="323331"/>
+          </a:xfrm>
+          <a:prstGeom prst="roundRect">
+            <a:avLst/>
+          </a:prstGeom>
+          <a:solidFill>
+            <a:srgbClr val="16303A"/>
+          </a:solidFill>
+          <a:ln>
+            <a:noFill/>
+          </a:ln>
+          <a:effectLst/>
+        </p:spPr>
+        <p:style>
+          <a:lnRef idx="1">
+            <a:schemeClr val="accent1"/>
+          </a:lnRef>
+          <a:fillRef idx="3">
+            <a:schemeClr val="accent1"/>
+          </a:fillRef>
+          <a:effectRef idx="2">
+            <a:schemeClr val="accent1"/>
+          </a:effectRef>
+          <a:fontRef idx="minor">
+            <a:schemeClr val="lt1"/>
+          </a:fontRef>
+        </p:style>
+        <p:txBody>
+          <a:bodyPr rtlCol="0" anchor="ctr"/>
+          <a:lstStyle/>
+          <a:p>
+            <a:pPr algn="ctr"/>
+          </a:p>
+        </p:txBody>
+      </p:sp>
+      <p:sp>
+        <p:nvSpPr>
+          <p:cNvPr id="14" name="Rounded Rectangle 13"/>
+          <p:cNvSpPr/>
+          <p:nvPr/>
+        </p:nvSpPr>
+        <p:spPr>
+          <a:xfrm>
             <a:off x="7695590" y="4856195"/>
             <a:ext cx="779800" cy="323331"/>
           </a:xfrm>
@@ -34257,7 +36017,7 @@
       </p:sp>
       <p:sp>
         <p:nvSpPr>
-          <p:cNvPr id="13" name="Rounded Rectangle 12"/>
+          <p:cNvPr id="15" name="Rounded Rectangle 14"/>
           <p:cNvSpPr/>
           <p:nvPr/>
         </p:nvSpPr>
@@ -34301,7 +36061,7 @@
       </p:sp>
       <p:sp>
         <p:nvSpPr>
-          <p:cNvPr id="14" name="Rounded Rectangle 13"/>
+          <p:cNvPr id="16" name="Rounded Rectangle 15"/>
           <p:cNvSpPr/>
           <p:nvPr/>
         </p:nvSpPr>
@@ -34345,7 +36105,7 @@
       </p:sp>
       <p:sp>
         <p:nvSpPr>
-          <p:cNvPr id="15" name="TextBox 14"/>
+          <p:cNvPr id="17" name="TextBox 16"/>
           <p:cNvSpPr txBox="1"/>
           <p:nvPr/>
         </p:nvSpPr>
@@ -35309,7 +37069,7 @@
         <p:spPr>
           <a:xfrm>
             <a:off x="3606393" y="2554833"/>
-            <a:ext cx="4945075" cy="1806854"/>
+            <a:ext cx="4945075" cy="1730776"/>
           </a:xfrm>
           <a:prstGeom prst="roundRect">
             <a:avLst/>
@@ -35484,8 +37244,8 @@
         </p:nvSpPr>
         <p:spPr>
           <a:xfrm>
-            <a:off x="3701491" y="4856195"/>
-            <a:ext cx="3899001" cy="323331"/>
+            <a:off x="3701491" y="4409236"/>
+            <a:ext cx="1426463" cy="228234"/>
           </a:xfrm>
           <a:prstGeom prst="roundRect">
             <a:avLst/>
@@ -35528,6 +37288,94 @@
         </p:nvSpPr>
         <p:spPr>
           <a:xfrm>
+            <a:off x="5223052" y="4409236"/>
+            <a:ext cx="1426463" cy="228234"/>
+          </a:xfrm>
+          <a:prstGeom prst="roundRect">
+            <a:avLst/>
+          </a:prstGeom>
+          <a:solidFill>
+            <a:srgbClr val="16303A"/>
+          </a:solidFill>
+          <a:ln>
+            <a:noFill/>
+          </a:ln>
+          <a:effectLst/>
+        </p:spPr>
+        <p:style>
+          <a:lnRef idx="1">
+            <a:schemeClr val="accent1"/>
+          </a:lnRef>
+          <a:fillRef idx="3">
+            <a:schemeClr val="accent1"/>
+          </a:fillRef>
+          <a:effectRef idx="2">
+            <a:schemeClr val="accent1"/>
+          </a:effectRef>
+          <a:fontRef idx="minor">
+            <a:schemeClr val="lt1"/>
+          </a:fontRef>
+        </p:style>
+        <p:txBody>
+          <a:bodyPr rtlCol="0" anchor="ctr"/>
+          <a:lstStyle/>
+          <a:p>
+            <a:pPr algn="ctr"/>
+          </a:p>
+        </p:txBody>
+      </p:sp>
+      <p:sp>
+        <p:nvSpPr>
+          <p:cNvPr id="13" name="Rounded Rectangle 12"/>
+          <p:cNvSpPr/>
+          <p:nvPr/>
+        </p:nvSpPr>
+        <p:spPr>
+          <a:xfrm>
+            <a:off x="3701491" y="4856195"/>
+            <a:ext cx="3899001" cy="323331"/>
+          </a:xfrm>
+          <a:prstGeom prst="roundRect">
+            <a:avLst/>
+          </a:prstGeom>
+          <a:solidFill>
+            <a:srgbClr val="16303A"/>
+          </a:solidFill>
+          <a:ln>
+            <a:noFill/>
+          </a:ln>
+          <a:effectLst/>
+        </p:spPr>
+        <p:style>
+          <a:lnRef idx="1">
+            <a:schemeClr val="accent1"/>
+          </a:lnRef>
+          <a:fillRef idx="3">
+            <a:schemeClr val="accent1"/>
+          </a:fillRef>
+          <a:effectRef idx="2">
+            <a:schemeClr val="accent1"/>
+          </a:effectRef>
+          <a:fontRef idx="minor">
+            <a:schemeClr val="lt1"/>
+          </a:fontRef>
+        </p:style>
+        <p:txBody>
+          <a:bodyPr rtlCol="0" anchor="ctr"/>
+          <a:lstStyle/>
+          <a:p>
+            <a:pPr algn="ctr"/>
+          </a:p>
+        </p:txBody>
+      </p:sp>
+      <p:sp>
+        <p:nvSpPr>
+          <p:cNvPr id="14" name="Rounded Rectangle 13"/>
+          <p:cNvSpPr/>
+          <p:nvPr/>
+        </p:nvSpPr>
+        <p:spPr>
+          <a:xfrm>
             <a:off x="7695590" y="4856195"/>
             <a:ext cx="779800" cy="323331"/>
           </a:xfrm>
@@ -35566,7 +37414,7 @@
       </p:sp>
       <p:sp>
         <p:nvSpPr>
-          <p:cNvPr id="13" name="Rounded Rectangle 12"/>
+          <p:cNvPr id="15" name="Rounded Rectangle 14"/>
           <p:cNvSpPr/>
           <p:nvPr/>
         </p:nvSpPr>
@@ -35610,7 +37458,7 @@
       </p:sp>
       <p:sp>
         <p:nvSpPr>
-          <p:cNvPr id="14" name="Rounded Rectangle 13"/>
+          <p:cNvPr id="16" name="Rounded Rectangle 15"/>
           <p:cNvSpPr/>
           <p:nvPr/>
         </p:nvSpPr>
@@ -35654,7 +37502,7 @@
       </p:sp>
       <p:sp>
         <p:nvSpPr>
-          <p:cNvPr id="15" name="TextBox 14"/>
+          <p:cNvPr id="17" name="TextBox 16"/>
           <p:cNvSpPr txBox="1"/>
           <p:nvPr/>
         </p:nvSpPr>
@@ -37033,7 +38881,7 @@
         <p:spPr>
           <a:xfrm>
             <a:off x="3606393" y="2554833"/>
-            <a:ext cx="4945075" cy="1806854"/>
+            <a:ext cx="4945075" cy="1730776"/>
           </a:xfrm>
           <a:prstGeom prst="roundRect">
             <a:avLst/>
@@ -37208,8 +39056,8 @@
         </p:nvSpPr>
         <p:spPr>
           <a:xfrm>
-            <a:off x="3701491" y="4856195"/>
-            <a:ext cx="3899001" cy="323331"/>
+            <a:off x="3701491" y="4409236"/>
+            <a:ext cx="1426463" cy="228234"/>
           </a:xfrm>
           <a:prstGeom prst="roundRect">
             <a:avLst/>
@@ -37252,6 +39100,94 @@
         </p:nvSpPr>
         <p:spPr>
           <a:xfrm>
+            <a:off x="5223052" y="4409236"/>
+            <a:ext cx="1426463" cy="228234"/>
+          </a:xfrm>
+          <a:prstGeom prst="roundRect">
+            <a:avLst/>
+          </a:prstGeom>
+          <a:solidFill>
+            <a:srgbClr val="16303A"/>
+          </a:solidFill>
+          <a:ln>
+            <a:noFill/>
+          </a:ln>
+          <a:effectLst/>
+        </p:spPr>
+        <p:style>
+          <a:lnRef idx="1">
+            <a:schemeClr val="accent1"/>
+          </a:lnRef>
+          <a:fillRef idx="3">
+            <a:schemeClr val="accent1"/>
+          </a:fillRef>
+          <a:effectRef idx="2">
+            <a:schemeClr val="accent1"/>
+          </a:effectRef>
+          <a:fontRef idx="minor">
+            <a:schemeClr val="lt1"/>
+          </a:fontRef>
+        </p:style>
+        <p:txBody>
+          <a:bodyPr rtlCol="0" anchor="ctr"/>
+          <a:lstStyle/>
+          <a:p>
+            <a:pPr algn="ctr"/>
+          </a:p>
+        </p:txBody>
+      </p:sp>
+      <p:sp>
+        <p:nvSpPr>
+          <p:cNvPr id="13" name="Rounded Rectangle 12"/>
+          <p:cNvSpPr/>
+          <p:nvPr/>
+        </p:nvSpPr>
+        <p:spPr>
+          <a:xfrm>
+            <a:off x="3701491" y="4856195"/>
+            <a:ext cx="3899001" cy="323331"/>
+          </a:xfrm>
+          <a:prstGeom prst="roundRect">
+            <a:avLst/>
+          </a:prstGeom>
+          <a:solidFill>
+            <a:srgbClr val="16303A"/>
+          </a:solidFill>
+          <a:ln>
+            <a:noFill/>
+          </a:ln>
+          <a:effectLst/>
+        </p:spPr>
+        <p:style>
+          <a:lnRef idx="1">
+            <a:schemeClr val="accent1"/>
+          </a:lnRef>
+          <a:fillRef idx="3">
+            <a:schemeClr val="accent1"/>
+          </a:fillRef>
+          <a:effectRef idx="2">
+            <a:schemeClr val="accent1"/>
+          </a:effectRef>
+          <a:fontRef idx="minor">
+            <a:schemeClr val="lt1"/>
+          </a:fontRef>
+        </p:style>
+        <p:txBody>
+          <a:bodyPr rtlCol="0" anchor="ctr"/>
+          <a:lstStyle/>
+          <a:p>
+            <a:pPr algn="ctr"/>
+          </a:p>
+        </p:txBody>
+      </p:sp>
+      <p:sp>
+        <p:nvSpPr>
+          <p:cNvPr id="14" name="Rounded Rectangle 13"/>
+          <p:cNvSpPr/>
+          <p:nvPr/>
+        </p:nvSpPr>
+        <p:spPr>
+          <a:xfrm>
             <a:off x="7695590" y="4856195"/>
             <a:ext cx="779800" cy="323331"/>
           </a:xfrm>
@@ -37290,7 +39226,7 @@
       </p:sp>
       <p:sp>
         <p:nvSpPr>
-          <p:cNvPr id="13" name="Rounded Rectangle 12"/>
+          <p:cNvPr id="15" name="Rounded Rectangle 14"/>
           <p:cNvSpPr/>
           <p:nvPr/>
         </p:nvSpPr>
@@ -37334,14 +39270,14 @@
       </p:sp>
       <p:sp>
         <p:nvSpPr>
-          <p:cNvPr id="14" name="Rounded Rectangle 13"/>
+          <p:cNvPr id="16" name="Rounded Rectangle 15"/>
           <p:cNvSpPr/>
           <p:nvPr/>
         </p:nvSpPr>
         <p:spPr>
           <a:xfrm>
             <a:off x="3568354" y="2516794"/>
-            <a:ext cx="5021153" cy="1882932"/>
+            <a:ext cx="5021153" cy="1806854"/>
           </a:xfrm>
           <a:prstGeom prst="roundRect">
             <a:avLst/>
@@ -37378,7 +39314,7 @@
       </p:sp>
       <p:sp>
         <p:nvSpPr>
-          <p:cNvPr id="15" name="TextBox 14"/>
+          <p:cNvPr id="17" name="TextBox 16"/>
           <p:cNvSpPr txBox="1"/>
           <p:nvPr/>
         </p:nvSpPr>
@@ -38852,7 +40788,7 @@
         <p:spPr>
           <a:xfrm>
             <a:off x="3606393" y="2554833"/>
-            <a:ext cx="4945075" cy="1806854"/>
+            <a:ext cx="4945075" cy="1730776"/>
           </a:xfrm>
           <a:prstGeom prst="roundRect">
             <a:avLst/>
@@ -39027,8 +40963,8 @@
         </p:nvSpPr>
         <p:spPr>
           <a:xfrm>
-            <a:off x="3701491" y="4856195"/>
-            <a:ext cx="3899001" cy="323331"/>
+            <a:off x="3701491" y="4409236"/>
+            <a:ext cx="1426463" cy="228234"/>
           </a:xfrm>
           <a:prstGeom prst="roundRect">
             <a:avLst/>
@@ -39071,6 +41007,94 @@
         </p:nvSpPr>
         <p:spPr>
           <a:xfrm>
+            <a:off x="5223052" y="4409236"/>
+            <a:ext cx="1426463" cy="228234"/>
+          </a:xfrm>
+          <a:prstGeom prst="roundRect">
+            <a:avLst/>
+          </a:prstGeom>
+          <a:solidFill>
+            <a:srgbClr val="16303A"/>
+          </a:solidFill>
+          <a:ln>
+            <a:noFill/>
+          </a:ln>
+          <a:effectLst/>
+        </p:spPr>
+        <p:style>
+          <a:lnRef idx="1">
+            <a:schemeClr val="accent1"/>
+          </a:lnRef>
+          <a:fillRef idx="3">
+            <a:schemeClr val="accent1"/>
+          </a:fillRef>
+          <a:effectRef idx="2">
+            <a:schemeClr val="accent1"/>
+          </a:effectRef>
+          <a:fontRef idx="minor">
+            <a:schemeClr val="lt1"/>
+          </a:fontRef>
+        </p:style>
+        <p:txBody>
+          <a:bodyPr rtlCol="0" anchor="ctr"/>
+          <a:lstStyle/>
+          <a:p>
+            <a:pPr algn="ctr"/>
+          </a:p>
+        </p:txBody>
+      </p:sp>
+      <p:sp>
+        <p:nvSpPr>
+          <p:cNvPr id="13" name="Rounded Rectangle 12"/>
+          <p:cNvSpPr/>
+          <p:nvPr/>
+        </p:nvSpPr>
+        <p:spPr>
+          <a:xfrm>
+            <a:off x="3701491" y="4856195"/>
+            <a:ext cx="3899001" cy="323331"/>
+          </a:xfrm>
+          <a:prstGeom prst="roundRect">
+            <a:avLst/>
+          </a:prstGeom>
+          <a:solidFill>
+            <a:srgbClr val="16303A"/>
+          </a:solidFill>
+          <a:ln>
+            <a:noFill/>
+          </a:ln>
+          <a:effectLst/>
+        </p:spPr>
+        <p:style>
+          <a:lnRef idx="1">
+            <a:schemeClr val="accent1"/>
+          </a:lnRef>
+          <a:fillRef idx="3">
+            <a:schemeClr val="accent1"/>
+          </a:fillRef>
+          <a:effectRef idx="2">
+            <a:schemeClr val="accent1"/>
+          </a:effectRef>
+          <a:fontRef idx="minor">
+            <a:schemeClr val="lt1"/>
+          </a:fontRef>
+        </p:style>
+        <p:txBody>
+          <a:bodyPr rtlCol="0" anchor="ctr"/>
+          <a:lstStyle/>
+          <a:p>
+            <a:pPr algn="ctr"/>
+          </a:p>
+        </p:txBody>
+      </p:sp>
+      <p:sp>
+        <p:nvSpPr>
+          <p:cNvPr id="14" name="Rounded Rectangle 13"/>
+          <p:cNvSpPr/>
+          <p:nvPr/>
+        </p:nvSpPr>
+        <p:spPr>
+          <a:xfrm>
             <a:off x="7695590" y="4856195"/>
             <a:ext cx="779800" cy="323331"/>
           </a:xfrm>
@@ -39109,7 +41133,7 @@
       </p:sp>
       <p:sp>
         <p:nvSpPr>
-          <p:cNvPr id="13" name="Rounded Rectangle 12"/>
+          <p:cNvPr id="15" name="Rounded Rectangle 14"/>
           <p:cNvSpPr/>
           <p:nvPr/>
         </p:nvSpPr>
@@ -39153,7 +41177,7 @@
       </p:sp>
       <p:sp>
         <p:nvSpPr>
-          <p:cNvPr id="14" name="Rounded Rectangle 13"/>
+          <p:cNvPr id="16" name="Rounded Rectangle 15"/>
           <p:cNvSpPr/>
           <p:nvPr/>
         </p:nvSpPr>
@@ -39197,7 +41221,7 @@
       </p:sp>
       <p:sp>
         <p:nvSpPr>
-          <p:cNvPr id="15" name="TextBox 14"/>
+          <p:cNvPr id="17" name="TextBox 16"/>
           <p:cNvSpPr txBox="1"/>
           <p:nvPr/>
         </p:nvSpPr>
@@ -39991,7 +42015,7 @@
         <p:spPr>
           <a:xfrm>
             <a:off x="3606393" y="2554833"/>
-            <a:ext cx="4945075" cy="1806854"/>
+            <a:ext cx="4945075" cy="1730776"/>
           </a:xfrm>
           <a:prstGeom prst="roundRect">
             <a:avLst/>
@@ -40166,8 +42190,8 @@
         </p:nvSpPr>
         <p:spPr>
           <a:xfrm>
-            <a:off x="3701491" y="4856195"/>
-            <a:ext cx="3899001" cy="323331"/>
+            <a:off x="3701491" y="4409236"/>
+            <a:ext cx="1426463" cy="228234"/>
           </a:xfrm>
           <a:prstGeom prst="roundRect">
             <a:avLst/>
@@ -40210,6 +42234,94 @@
         </p:nvSpPr>
         <p:spPr>
           <a:xfrm>
+            <a:off x="5223052" y="4409236"/>
+            <a:ext cx="1426463" cy="228234"/>
+          </a:xfrm>
+          <a:prstGeom prst="roundRect">
+            <a:avLst/>
+          </a:prstGeom>
+          <a:solidFill>
+            <a:srgbClr val="16303A"/>
+          </a:solidFill>
+          <a:ln>
+            <a:noFill/>
+          </a:ln>
+          <a:effectLst/>
+        </p:spPr>
+        <p:style>
+          <a:lnRef idx="1">
+            <a:schemeClr val="accent1"/>
+          </a:lnRef>
+          <a:fillRef idx="3">
+            <a:schemeClr val="accent1"/>
+          </a:fillRef>
+          <a:effectRef idx="2">
+            <a:schemeClr val="accent1"/>
+          </a:effectRef>
+          <a:fontRef idx="minor">
+            <a:schemeClr val="lt1"/>
+          </a:fontRef>
+        </p:style>
+        <p:txBody>
+          <a:bodyPr rtlCol="0" anchor="ctr"/>
+          <a:lstStyle/>
+          <a:p>
+            <a:pPr algn="ctr"/>
+          </a:p>
+        </p:txBody>
+      </p:sp>
+      <p:sp>
+        <p:nvSpPr>
+          <p:cNvPr id="13" name="Rounded Rectangle 12"/>
+          <p:cNvSpPr/>
+          <p:nvPr/>
+        </p:nvSpPr>
+        <p:spPr>
+          <a:xfrm>
+            <a:off x="3701491" y="4856195"/>
+            <a:ext cx="3899001" cy="323331"/>
+          </a:xfrm>
+          <a:prstGeom prst="roundRect">
+            <a:avLst/>
+          </a:prstGeom>
+          <a:solidFill>
+            <a:srgbClr val="16303A"/>
+          </a:solidFill>
+          <a:ln>
+            <a:noFill/>
+          </a:ln>
+          <a:effectLst/>
+        </p:spPr>
+        <p:style>
+          <a:lnRef idx="1">
+            <a:schemeClr val="accent1"/>
+          </a:lnRef>
+          <a:fillRef idx="3">
+            <a:schemeClr val="accent1"/>
+          </a:fillRef>
+          <a:effectRef idx="2">
+            <a:schemeClr val="accent1"/>
+          </a:effectRef>
+          <a:fontRef idx="minor">
+            <a:schemeClr val="lt1"/>
+          </a:fontRef>
+        </p:style>
+        <p:txBody>
+          <a:bodyPr rtlCol="0" anchor="ctr"/>
+          <a:lstStyle/>
+          <a:p>
+            <a:pPr algn="ctr"/>
+          </a:p>
+        </p:txBody>
+      </p:sp>
+      <p:sp>
+        <p:nvSpPr>
+          <p:cNvPr id="14" name="Rounded Rectangle 13"/>
+          <p:cNvSpPr/>
+          <p:nvPr/>
+        </p:nvSpPr>
+        <p:spPr>
+          <a:xfrm>
             <a:off x="7695590" y="4856195"/>
             <a:ext cx="779800" cy="323331"/>
           </a:xfrm>
@@ -40248,7 +42360,7 @@
       </p:sp>
       <p:sp>
         <p:nvSpPr>
-          <p:cNvPr id="13" name="Rounded Rectangle 12"/>
+          <p:cNvPr id="15" name="Rounded Rectangle 14"/>
           <p:cNvSpPr/>
           <p:nvPr/>
         </p:nvSpPr>
@@ -40292,7 +42404,7 @@
       </p:sp>
       <p:sp>
         <p:nvSpPr>
-          <p:cNvPr id="14" name="Rounded Rectangle 13"/>
+          <p:cNvPr id="16" name="Rounded Rectangle 15"/>
           <p:cNvSpPr/>
           <p:nvPr/>
         </p:nvSpPr>
@@ -40336,7 +42448,7 @@
       </p:sp>
       <p:sp>
         <p:nvSpPr>
-          <p:cNvPr id="15" name="TextBox 14"/>
+          <p:cNvPr id="17" name="TextBox 16"/>
           <p:cNvSpPr txBox="1"/>
           <p:nvPr/>
         </p:nvSpPr>
@@ -41040,7 +43152,7 @@
         <p:spPr>
           <a:xfrm>
             <a:off x="3606393" y="2554833"/>
-            <a:ext cx="4945075" cy="1806854"/>
+            <a:ext cx="4945075" cy="1730776"/>
           </a:xfrm>
           <a:prstGeom prst="roundRect">
             <a:avLst/>
@@ -41215,8 +43327,8 @@
         </p:nvSpPr>
         <p:spPr>
           <a:xfrm>
-            <a:off x="3701491" y="4856195"/>
-            <a:ext cx="3899001" cy="323331"/>
+            <a:off x="3701491" y="4409236"/>
+            <a:ext cx="1426463" cy="228234"/>
           </a:xfrm>
           <a:prstGeom prst="roundRect">
             <a:avLst/>
@@ -41259,6 +43371,94 @@
         </p:nvSpPr>
         <p:spPr>
           <a:xfrm>
+            <a:off x="5223052" y="4409236"/>
+            <a:ext cx="1426463" cy="228234"/>
+          </a:xfrm>
+          <a:prstGeom prst="roundRect">
+            <a:avLst/>
+          </a:prstGeom>
+          <a:solidFill>
+            <a:srgbClr val="16303A"/>
+          </a:solidFill>
+          <a:ln>
+            <a:noFill/>
+          </a:ln>
+          <a:effectLst/>
+        </p:spPr>
+        <p:style>
+          <a:lnRef idx="1">
+            <a:schemeClr val="accent1"/>
+          </a:lnRef>
+          <a:fillRef idx="3">
+            <a:schemeClr val="accent1"/>
+          </a:fillRef>
+          <a:effectRef idx="2">
+            <a:schemeClr val="accent1"/>
+          </a:effectRef>
+          <a:fontRef idx="minor">
+            <a:schemeClr val="lt1"/>
+          </a:fontRef>
+        </p:style>
+        <p:txBody>
+          <a:bodyPr rtlCol="0" anchor="ctr"/>
+          <a:lstStyle/>
+          <a:p>
+            <a:pPr algn="ctr"/>
+          </a:p>
+        </p:txBody>
+      </p:sp>
+      <p:sp>
+        <p:nvSpPr>
+          <p:cNvPr id="13" name="Rounded Rectangle 12"/>
+          <p:cNvSpPr/>
+          <p:nvPr/>
+        </p:nvSpPr>
+        <p:spPr>
+          <a:xfrm>
+            <a:off x="3701491" y="4856195"/>
+            <a:ext cx="3899001" cy="323331"/>
+          </a:xfrm>
+          <a:prstGeom prst="roundRect">
+            <a:avLst/>
+          </a:prstGeom>
+          <a:solidFill>
+            <a:srgbClr val="16303A"/>
+          </a:solidFill>
+          <a:ln>
+            <a:noFill/>
+          </a:ln>
+          <a:effectLst/>
+        </p:spPr>
+        <p:style>
+          <a:lnRef idx="1">
+            <a:schemeClr val="accent1"/>
+          </a:lnRef>
+          <a:fillRef idx="3">
+            <a:schemeClr val="accent1"/>
+          </a:fillRef>
+          <a:effectRef idx="2">
+            <a:schemeClr val="accent1"/>
+          </a:effectRef>
+          <a:fontRef idx="minor">
+            <a:schemeClr val="lt1"/>
+          </a:fontRef>
+        </p:style>
+        <p:txBody>
+          <a:bodyPr rtlCol="0" anchor="ctr"/>
+          <a:lstStyle/>
+          <a:p>
+            <a:pPr algn="ctr"/>
+          </a:p>
+        </p:txBody>
+      </p:sp>
+      <p:sp>
+        <p:nvSpPr>
+          <p:cNvPr id="14" name="Rounded Rectangle 13"/>
+          <p:cNvSpPr/>
+          <p:nvPr/>
+        </p:nvSpPr>
+        <p:spPr>
+          <a:xfrm>
             <a:off x="7695590" y="4856195"/>
             <a:ext cx="779800" cy="323331"/>
           </a:xfrm>
@@ -41297,7 +43497,7 @@
       </p:sp>
       <p:sp>
         <p:nvSpPr>
-          <p:cNvPr id="13" name="Rounded Rectangle 12"/>
+          <p:cNvPr id="15" name="Rounded Rectangle 14"/>
           <p:cNvSpPr/>
           <p:nvPr/>
         </p:nvSpPr>
@@ -41341,14 +43541,14 @@
       </p:sp>
       <p:sp>
         <p:nvSpPr>
-          <p:cNvPr id="14" name="Rounded Rectangle 13"/>
+          <p:cNvPr id="16" name="Rounded Rectangle 15"/>
           <p:cNvSpPr/>
           <p:nvPr/>
         </p:nvSpPr>
         <p:spPr>
           <a:xfrm>
             <a:off x="3568354" y="2516794"/>
-            <a:ext cx="5021153" cy="1882932"/>
+            <a:ext cx="5021153" cy="1806854"/>
           </a:xfrm>
           <a:prstGeom prst="roundRect">
             <a:avLst/>
@@ -41385,7 +43585,7 @@
       </p:sp>
       <p:sp>
         <p:nvSpPr>
-          <p:cNvPr id="15" name="TextBox 14"/>
+          <p:cNvPr id="17" name="TextBox 16"/>
           <p:cNvSpPr txBox="1"/>
           <p:nvPr/>
         </p:nvSpPr>
@@ -42709,7 +44909,7 @@
         <p:spPr>
           <a:xfrm>
             <a:off x="3606393" y="2554833"/>
-            <a:ext cx="4945075" cy="1806854"/>
+            <a:ext cx="4945075" cy="1730776"/>
           </a:xfrm>
           <a:prstGeom prst="roundRect">
             <a:avLst/>
@@ -42884,8 +45084,8 @@
         </p:nvSpPr>
         <p:spPr>
           <a:xfrm>
-            <a:off x="3701491" y="4856195"/>
-            <a:ext cx="3899001" cy="323331"/>
+            <a:off x="3701491" y="4409236"/>
+            <a:ext cx="1426463" cy="228234"/>
           </a:xfrm>
           <a:prstGeom prst="roundRect">
             <a:avLst/>
@@ -42928,6 +45128,94 @@
         </p:nvSpPr>
         <p:spPr>
           <a:xfrm>
+            <a:off x="5223052" y="4409236"/>
+            <a:ext cx="1426463" cy="228234"/>
+          </a:xfrm>
+          <a:prstGeom prst="roundRect">
+            <a:avLst/>
+          </a:prstGeom>
+          <a:solidFill>
+            <a:srgbClr val="16303A"/>
+          </a:solidFill>
+          <a:ln>
+            <a:noFill/>
+          </a:ln>
+          <a:effectLst/>
+        </p:spPr>
+        <p:style>
+          <a:lnRef idx="1">
+            <a:schemeClr val="accent1"/>
+          </a:lnRef>
+          <a:fillRef idx="3">
+            <a:schemeClr val="accent1"/>
+          </a:fillRef>
+          <a:effectRef idx="2">
+            <a:schemeClr val="accent1"/>
+          </a:effectRef>
+          <a:fontRef idx="minor">
+            <a:schemeClr val="lt1"/>
+          </a:fontRef>
+        </p:style>
+        <p:txBody>
+          <a:bodyPr rtlCol="0" anchor="ctr"/>
+          <a:lstStyle/>
+          <a:p>
+            <a:pPr algn="ctr"/>
+          </a:p>
+        </p:txBody>
+      </p:sp>
+      <p:sp>
+        <p:nvSpPr>
+          <p:cNvPr id="13" name="Rounded Rectangle 12"/>
+          <p:cNvSpPr/>
+          <p:nvPr/>
+        </p:nvSpPr>
+        <p:spPr>
+          <a:xfrm>
+            <a:off x="3701491" y="4856195"/>
+            <a:ext cx="3899001" cy="323331"/>
+          </a:xfrm>
+          <a:prstGeom prst="roundRect">
+            <a:avLst/>
+          </a:prstGeom>
+          <a:solidFill>
+            <a:srgbClr val="16303A"/>
+          </a:solidFill>
+          <a:ln>
+            <a:noFill/>
+          </a:ln>
+          <a:effectLst/>
+        </p:spPr>
+        <p:style>
+          <a:lnRef idx="1">
+            <a:schemeClr val="accent1"/>
+          </a:lnRef>
+          <a:fillRef idx="3">
+            <a:schemeClr val="accent1"/>
+          </a:fillRef>
+          <a:effectRef idx="2">
+            <a:schemeClr val="accent1"/>
+          </a:effectRef>
+          <a:fontRef idx="minor">
+            <a:schemeClr val="lt1"/>
+          </a:fontRef>
+        </p:style>
+        <p:txBody>
+          <a:bodyPr rtlCol="0" anchor="ctr"/>
+          <a:lstStyle/>
+          <a:p>
+            <a:pPr algn="ctr"/>
+          </a:p>
+        </p:txBody>
+      </p:sp>
+      <p:sp>
+        <p:nvSpPr>
+          <p:cNvPr id="14" name="Rounded Rectangle 13"/>
+          <p:cNvSpPr/>
+          <p:nvPr/>
+        </p:nvSpPr>
+        <p:spPr>
+          <a:xfrm>
             <a:off x="7695590" y="4856195"/>
             <a:ext cx="779800" cy="323331"/>
           </a:xfrm>
@@ -42966,7 +45254,7 @@
       </p:sp>
       <p:sp>
         <p:nvSpPr>
-          <p:cNvPr id="13" name="Rounded Rectangle 12"/>
+          <p:cNvPr id="15" name="Rounded Rectangle 14"/>
           <p:cNvSpPr/>
           <p:nvPr/>
         </p:nvSpPr>
@@ -43010,7 +45298,7 @@
       </p:sp>
       <p:sp>
         <p:nvSpPr>
-          <p:cNvPr id="14" name="Rounded Rectangle 13"/>
+          <p:cNvPr id="16" name="Rounded Rectangle 15"/>
           <p:cNvSpPr/>
           <p:nvPr/>
         </p:nvSpPr>
@@ -43054,7 +45342,7 @@
       </p:sp>
       <p:sp>
         <p:nvSpPr>
-          <p:cNvPr id="15" name="TextBox 14"/>
+          <p:cNvPr id="17" name="TextBox 16"/>
           <p:cNvSpPr txBox="1"/>
           <p:nvPr/>
         </p:nvSpPr>
@@ -43433,7 +45721,7 @@
         <p:spPr>
           <a:xfrm>
             <a:off x="3606393" y="2554833"/>
-            <a:ext cx="4945075" cy="1806854"/>
+            <a:ext cx="4945075" cy="1730776"/>
           </a:xfrm>
           <a:prstGeom prst="roundRect">
             <a:avLst/>
@@ -43608,8 +45896,8 @@
         </p:nvSpPr>
         <p:spPr>
           <a:xfrm>
-            <a:off x="3701491" y="4856195"/>
-            <a:ext cx="3899001" cy="323331"/>
+            <a:off x="3701491" y="4409236"/>
+            <a:ext cx="1426463" cy="228234"/>
           </a:xfrm>
           <a:prstGeom prst="roundRect">
             <a:avLst/>
@@ -43652,6 +45940,94 @@
         </p:nvSpPr>
         <p:spPr>
           <a:xfrm>
+            <a:off x="5223052" y="4409236"/>
+            <a:ext cx="1426463" cy="228234"/>
+          </a:xfrm>
+          <a:prstGeom prst="roundRect">
+            <a:avLst/>
+          </a:prstGeom>
+          <a:solidFill>
+            <a:srgbClr val="16303A"/>
+          </a:solidFill>
+          <a:ln>
+            <a:noFill/>
+          </a:ln>
+          <a:effectLst/>
+        </p:spPr>
+        <p:style>
+          <a:lnRef idx="1">
+            <a:schemeClr val="accent1"/>
+          </a:lnRef>
+          <a:fillRef idx="3">
+            <a:schemeClr val="accent1"/>
+          </a:fillRef>
+          <a:effectRef idx="2">
+            <a:schemeClr val="accent1"/>
+          </a:effectRef>
+          <a:fontRef idx="minor">
+            <a:schemeClr val="lt1"/>
+          </a:fontRef>
+        </p:style>
+        <p:txBody>
+          <a:bodyPr rtlCol="0" anchor="ctr"/>
+          <a:lstStyle/>
+          <a:p>
+            <a:pPr algn="ctr"/>
+          </a:p>
+        </p:txBody>
+      </p:sp>
+      <p:sp>
+        <p:nvSpPr>
+          <p:cNvPr id="13" name="Rounded Rectangle 12"/>
+          <p:cNvSpPr/>
+          <p:nvPr/>
+        </p:nvSpPr>
+        <p:spPr>
+          <a:xfrm>
+            <a:off x="3701491" y="4856195"/>
+            <a:ext cx="3899001" cy="323331"/>
+          </a:xfrm>
+          <a:prstGeom prst="roundRect">
+            <a:avLst/>
+          </a:prstGeom>
+          <a:solidFill>
+            <a:srgbClr val="16303A"/>
+          </a:solidFill>
+          <a:ln>
+            <a:noFill/>
+          </a:ln>
+          <a:effectLst/>
+        </p:spPr>
+        <p:style>
+          <a:lnRef idx="1">
+            <a:schemeClr val="accent1"/>
+          </a:lnRef>
+          <a:fillRef idx="3">
+            <a:schemeClr val="accent1"/>
+          </a:fillRef>
+          <a:effectRef idx="2">
+            <a:schemeClr val="accent1"/>
+          </a:effectRef>
+          <a:fontRef idx="minor">
+            <a:schemeClr val="lt1"/>
+          </a:fontRef>
+        </p:style>
+        <p:txBody>
+          <a:bodyPr rtlCol="0" anchor="ctr"/>
+          <a:lstStyle/>
+          <a:p>
+            <a:pPr algn="ctr"/>
+          </a:p>
+        </p:txBody>
+      </p:sp>
+      <p:sp>
+        <p:nvSpPr>
+          <p:cNvPr id="14" name="Rounded Rectangle 13"/>
+          <p:cNvSpPr/>
+          <p:nvPr/>
+        </p:nvSpPr>
+        <p:spPr>
+          <a:xfrm>
             <a:off x="7695590" y="4856195"/>
             <a:ext cx="779800" cy="323331"/>
           </a:xfrm>
@@ -43690,7 +46066,7 @@
       </p:sp>
       <p:sp>
         <p:nvSpPr>
-          <p:cNvPr id="13" name="Rounded Rectangle 12"/>
+          <p:cNvPr id="15" name="Rounded Rectangle 14"/>
           <p:cNvSpPr/>
           <p:nvPr/>
         </p:nvSpPr>
@@ -43734,7 +46110,7 @@
       </p:sp>
       <p:sp>
         <p:nvSpPr>
-          <p:cNvPr id="14" name="Rounded Rectangle 13"/>
+          <p:cNvPr id="16" name="Rounded Rectangle 15"/>
           <p:cNvSpPr/>
           <p:nvPr/>
         </p:nvSpPr>
@@ -43778,7 +46154,7 @@
       </p:sp>
       <p:sp>
         <p:nvSpPr>
-          <p:cNvPr id="15" name="TextBox 14"/>
+          <p:cNvPr id="17" name="TextBox 16"/>
           <p:cNvSpPr txBox="1"/>
           <p:nvPr/>
         </p:nvSpPr>
@@ -44157,7 +46533,7 @@
         <p:spPr>
           <a:xfrm>
             <a:off x="3606393" y="2554833"/>
-            <a:ext cx="4945075" cy="1806854"/>
+            <a:ext cx="4945075" cy="1730776"/>
           </a:xfrm>
           <a:prstGeom prst="roundRect">
             <a:avLst/>
@@ -44332,8 +46708,8 @@
         </p:nvSpPr>
         <p:spPr>
           <a:xfrm>
-            <a:off x="3701491" y="4856195"/>
-            <a:ext cx="3899001" cy="323331"/>
+            <a:off x="3701491" y="4409236"/>
+            <a:ext cx="1426463" cy="228234"/>
           </a:xfrm>
           <a:prstGeom prst="roundRect">
             <a:avLst/>
@@ -44376,6 +46752,94 @@
         </p:nvSpPr>
         <p:spPr>
           <a:xfrm>
+            <a:off x="5223052" y="4409236"/>
+            <a:ext cx="1426463" cy="228234"/>
+          </a:xfrm>
+          <a:prstGeom prst="roundRect">
+            <a:avLst/>
+          </a:prstGeom>
+          <a:solidFill>
+            <a:srgbClr val="16303A"/>
+          </a:solidFill>
+          <a:ln>
+            <a:noFill/>
+          </a:ln>
+          <a:effectLst/>
+        </p:spPr>
+        <p:style>
+          <a:lnRef idx="1">
+            <a:schemeClr val="accent1"/>
+          </a:lnRef>
+          <a:fillRef idx="3">
+            <a:schemeClr val="accent1"/>
+          </a:fillRef>
+          <a:effectRef idx="2">
+            <a:schemeClr val="accent1"/>
+          </a:effectRef>
+          <a:fontRef idx="minor">
+            <a:schemeClr val="lt1"/>
+          </a:fontRef>
+        </p:style>
+        <p:txBody>
+          <a:bodyPr rtlCol="0" anchor="ctr"/>
+          <a:lstStyle/>
+          <a:p>
+            <a:pPr algn="ctr"/>
+          </a:p>
+        </p:txBody>
+      </p:sp>
+      <p:sp>
+        <p:nvSpPr>
+          <p:cNvPr id="13" name="Rounded Rectangle 12"/>
+          <p:cNvSpPr/>
+          <p:nvPr/>
+        </p:nvSpPr>
+        <p:spPr>
+          <a:xfrm>
+            <a:off x="3701491" y="4856195"/>
+            <a:ext cx="3899001" cy="323331"/>
+          </a:xfrm>
+          <a:prstGeom prst="roundRect">
+            <a:avLst/>
+          </a:prstGeom>
+          <a:solidFill>
+            <a:srgbClr val="16303A"/>
+          </a:solidFill>
+          <a:ln>
+            <a:noFill/>
+          </a:ln>
+          <a:effectLst/>
+        </p:spPr>
+        <p:style>
+          <a:lnRef idx="1">
+            <a:schemeClr val="accent1"/>
+          </a:lnRef>
+          <a:fillRef idx="3">
+            <a:schemeClr val="accent1"/>
+          </a:fillRef>
+          <a:effectRef idx="2">
+            <a:schemeClr val="accent1"/>
+          </a:effectRef>
+          <a:fontRef idx="minor">
+            <a:schemeClr val="lt1"/>
+          </a:fontRef>
+        </p:style>
+        <p:txBody>
+          <a:bodyPr rtlCol="0" anchor="ctr"/>
+          <a:lstStyle/>
+          <a:p>
+            <a:pPr algn="ctr"/>
+          </a:p>
+        </p:txBody>
+      </p:sp>
+      <p:sp>
+        <p:nvSpPr>
+          <p:cNvPr id="14" name="Rounded Rectangle 13"/>
+          <p:cNvSpPr/>
+          <p:nvPr/>
+        </p:nvSpPr>
+        <p:spPr>
+          <a:xfrm>
             <a:off x="7695590" y="4856195"/>
             <a:ext cx="779800" cy="323331"/>
           </a:xfrm>
@@ -44414,7 +46878,7 @@
       </p:sp>
       <p:sp>
         <p:nvSpPr>
-          <p:cNvPr id="13" name="Rounded Rectangle 12"/>
+          <p:cNvPr id="15" name="Rounded Rectangle 14"/>
           <p:cNvSpPr/>
           <p:nvPr/>
         </p:nvSpPr>
@@ -44458,7 +46922,7 @@
       </p:sp>
       <p:sp>
         <p:nvSpPr>
-          <p:cNvPr id="14" name="Rounded Rectangle 13"/>
+          <p:cNvPr id="16" name="Rounded Rectangle 15"/>
           <p:cNvSpPr/>
           <p:nvPr/>
         </p:nvSpPr>
@@ -44502,7 +46966,7 @@
       </p:sp>
       <p:sp>
         <p:nvSpPr>
-          <p:cNvPr id="15" name="TextBox 14"/>
+          <p:cNvPr id="17" name="TextBox 16"/>
           <p:cNvSpPr txBox="1"/>
           <p:nvPr/>
         </p:nvSpPr>

</xml_diff>